<commit_message>
Give Cypress one shared X server per CI job
Concurrent atomized targets each spawned their own Xvfb on :99, so the second
one died with "Server is already active for display 99" after its tests had
already passed — a green test report on a failed task. Start one Xvfb for the
job and export DISPLAY instead.

Also tightens two slide layouts found in a render pass.
</commit_message>
<xml_diff>
--- a/talk/Scaling-E2E-Tests-with-Nx.pptx
+++ b/talk/Scaling-E2E-Tests-with-Nx.pptx
@@ -5193,7 +5193,7 @@
         <p:spPr>
           <a:xfrm>
             <a:off x="640080" y="1783080"/>
-            <a:ext cx="6766560" cy="2011680"/>
+            <a:ext cx="7223760" cy="2011680"/>
           </a:xfrm>
           <a:prstGeom prst="roundRect">
             <a:avLst>
@@ -5220,7 +5220,7 @@
         <p:spPr>
           <a:xfrm>
             <a:off x="868680" y="1984248"/>
-            <a:ext cx="6309360" cy="1609344"/>
+            <a:ext cx="6766560" cy="1609344"/>
           </a:xfrm>
           <a:prstGeom prst="rect">
             <a:avLst/>
@@ -5239,7 +5239,7 @@
               <a:buNone/>
             </a:pPr>
             <a:r>
-              <a:rPr lang="en-US" sz="1300" dirty="0">
+              <a:rPr lang="en-US" sz="1200" dirty="0">
                 <a:solidFill>
                   <a:srgbClr val="7DD3FC"/>
                 </a:solidFill>
@@ -5249,7 +5249,7 @@
               </a:rPr>
               <a:t>strategy:</a:t>
             </a:r>
-            <a:endParaRPr lang="en-US" sz="1300" dirty="0"/>
+            <a:endParaRPr lang="en-US" sz="1200" dirty="0"/>
           </a:p>
           <a:p>
             <a:pPr indent="0" marL="0">
@@ -5259,7 +5259,7 @@
               <a:buNone/>
             </a:pPr>
             <a:r>
-              <a:rPr lang="en-US" sz="1300" dirty="0">
+              <a:rPr lang="en-US" sz="1200" dirty="0">
                 <a:solidFill>
                   <a:srgbClr val="FFFFFF"/>
                 </a:solidFill>
@@ -5269,7 +5269,7 @@
               </a:rPr>
               <a:t>  matrix: { shard: [1, 2, 3] }</a:t>
             </a:r>
-            <a:endParaRPr lang="en-US" sz="1300" dirty="0"/>
+            <a:endParaRPr lang="en-US" sz="1200" dirty="0"/>
           </a:p>
           <a:p>
             <a:pPr indent="0" marL="0">
@@ -5279,7 +5279,7 @@
               <a:buNone/>
             </a:pPr>
             <a:r>
-              <a:rPr lang="en-US" sz="1300" dirty="0">
+              <a:rPr lang="en-US" sz="1200" dirty="0">
                 <a:solidFill>
                   <a:srgbClr val="7DD3FC"/>
                 </a:solidFill>
@@ -5289,7 +5289,7 @@
               </a:rPr>
               <a:t>steps:</a:t>
             </a:r>
-            <a:endParaRPr lang="en-US" sz="1300" dirty="0"/>
+            <a:endParaRPr lang="en-US" sz="1200" dirty="0"/>
           </a:p>
           <a:p>
             <a:pPr indent="0" marL="0">
@@ -5299,7 +5299,7 @@
               <a:buNone/>
             </a:pPr>
             <a:r>
-              <a:rPr lang="en-US" sz="1300" dirty="0">
+              <a:rPr lang="en-US" sz="1200" dirty="0">
                 <a:solidFill>
                   <a:srgbClr val="8A94A6"/>
                 </a:solidFill>
@@ -5309,7 +5309,7 @@
               </a:rPr>
               <a:t>  - uses: actions/cache@v4          # .nx/cache, per shard</a:t>
             </a:r>
-            <a:endParaRPr lang="en-US" sz="1300" dirty="0"/>
+            <a:endParaRPr lang="en-US" sz="1200" dirty="0"/>
           </a:p>
           <a:p>
             <a:pPr indent="0" marL="0">
@@ -5319,7 +5319,7 @@
               <a:buNone/>
             </a:pPr>
             <a:r>
-              <a:rPr lang="en-US" sz="1300" dirty="0">
+              <a:rPr lang="en-US" sz="1200" dirty="0">
                 <a:solidFill>
                   <a:srgbClr val="4ADE80"/>
                 </a:solidFill>
@@ -5329,7 +5329,7 @@
               </a:rPr>
               <a:t>  - run: node tools/shard-e2e.mjs --shard=${{ matrix.shard }}/3</a:t>
             </a:r>
-            <a:endParaRPr lang="en-US" sz="1300" dirty="0"/>
+            <a:endParaRPr lang="en-US" sz="1200" dirty="0"/>
           </a:p>
         </p:txBody>
       </p:sp>
@@ -5341,8 +5341,8 @@
         </p:nvSpPr>
         <p:spPr>
           <a:xfrm>
-            <a:off x="7589520" y="1828800"/>
-            <a:ext cx="3931920" cy="2194560"/>
+            <a:off x="8046720" y="1783080"/>
+            <a:ext cx="3474720" cy="2194560"/>
           </a:xfrm>
           <a:prstGeom prst="rect">
             <a:avLst/>
@@ -5362,7 +5362,7 @@
               <a:buChar char="•"/>
             </a:pPr>
             <a:r>
-              <a:rPr lang="en-US" sz="1400" dirty="0">
+              <a:rPr lang="en-US" sz="1300" dirty="0">
                 <a:solidFill>
                   <a:srgbClr val="C3CAD6"/>
                 </a:solidFill>
@@ -5372,7 +5372,7 @@
               </a:rPr>
               <a:t>Discovery is the same; only the slice differs</a:t>
             </a:r>
-            <a:endParaRPr lang="en-US" sz="1400" dirty="0"/>
+            <a:endParaRPr lang="en-US" sz="1300" dirty="0"/>
           </a:p>
           <a:p>
             <a:pPr marL="342900" indent="-342900">
@@ -5383,7 +5383,7 @@
               <a:buChar char="•"/>
             </a:pPr>
             <a:r>
-              <a:rPr lang="en-US" sz="1400" dirty="0">
+              <a:rPr lang="en-US" sz="1300" dirty="0">
                 <a:solidFill>
                   <a:srgbClr val="C3CAD6"/>
                 </a:solidFill>
@@ -5393,7 +5393,7 @@
               </a:rPr>
               <a:t>Round-robin, not contiguous blocks — adjacent specs cost alike</a:t>
             </a:r>
-            <a:endParaRPr lang="en-US" sz="1400" dirty="0"/>
+            <a:endParaRPr lang="en-US" sz="1300" dirty="0"/>
           </a:p>
           <a:p>
             <a:pPr marL="342900" indent="-342900">
@@ -5404,7 +5404,7 @@
               <a:buChar char="•"/>
             </a:pPr>
             <a:r>
-              <a:rPr lang="en-US" sz="1400" dirty="0">
+              <a:rPr lang="en-US" sz="1300" dirty="0">
                 <a:solidFill>
                   <a:srgbClr val="C3CAD6"/>
                 </a:solidFill>
@@ -5414,7 +5414,7 @@
               </a:rPr>
               <a:t>Restore .nx/cache per shard so a re-run of a red job is cheap</a:t>
             </a:r>
-            <a:endParaRPr lang="en-US" sz="1400" dirty="0"/>
+            <a:endParaRPr lang="en-US" sz="1300" dirty="0"/>
           </a:p>
         </p:txBody>
       </p:sp>
@@ -5541,7 +5541,7 @@
           <a:ln/>
         </p:spPr>
         <p:txBody>
-          <a:bodyPr wrap="square" lIns="0" tIns="0" rIns="0" bIns="0" rtlCol="0" anchor="ctr"/>
+          <a:bodyPr wrap="square" lIns="0" tIns="0" rIns="0" bIns="0" rtlCol="0" anchor="t"/>
           <a:lstStyle/>
           <a:p>
             <a:pPr indent="0" marL="0">
@@ -5646,7 +5646,7 @@
           <a:ln/>
         </p:spPr>
         <p:txBody>
-          <a:bodyPr wrap="square" lIns="0" tIns="0" rIns="0" bIns="0" rtlCol="0" anchor="ctr"/>
+          <a:bodyPr wrap="square" lIns="0" tIns="0" rIns="0" bIns="0" rtlCol="0" anchor="t"/>
           <a:lstStyle/>
           <a:p>
             <a:pPr indent="0" marL="0">
@@ -5751,7 +5751,7 @@
           <a:ln/>
         </p:spPr>
         <p:txBody>
-          <a:bodyPr wrap="square" lIns="0" tIns="0" rIns="0" bIns="0" rtlCol="0" anchor="ctr"/>
+          <a:bodyPr wrap="square" lIns="0" tIns="0" rIns="0" bIns="0" rtlCol="0" anchor="t"/>
           <a:lstStyle/>
           <a:p>
             <a:pPr indent="0" marL="0">
@@ -10383,11 +10383,11 @@
         <p:spPr>
           <a:xfrm>
             <a:off x="640080" y="2194560"/>
-            <a:ext cx="5120640" cy="685800"/>
+            <a:ext cx="5120640" cy="768096"/>
           </a:xfrm>
           <a:prstGeom prst="roundRect">
             <a:avLst>
-              <a:gd name="adj" fmla="val 8000"/>
+              <a:gd name="adj" fmla="val 7143"/>
             </a:avLst>
           </a:prstGeom>
           <a:solidFill>
@@ -10410,7 +10410,7 @@
         <p:spPr>
           <a:xfrm>
             <a:off x="868680" y="2395728"/>
-            <a:ext cx="4663440" cy="283464"/>
+            <a:ext cx="4663440" cy="365760"/>
           </a:xfrm>
           <a:prstGeom prst="rect">
             <a:avLst/>

</xml_diff>

<commit_message>
Add the two CI traps to the gotchas slide
Both the Nx 23 cache location and the Xvfb display collision were hit for real
while getting this repo's CI green, so they earn a place over the e2e vs
e2e-ci distinction, which the README covers well enough.
</commit_message>
<xml_diff>
--- a/talk/Scaling-E2E-Tests-with-Nx.pptx
+++ b/talk/Scaling-E2E-Tests-with-Nx.pptx
@@ -957,7 +957,7 @@
           <a:p>
             <a:r>
               <a:rPr lang="en-US" dirty="0"/>
-              <a:t>Good slide to leave up during questions.</a:t>
+              <a:t>Good slide to leave up during questions. Items 3 and 4 both bit this repo on its first CI run — worth telling as war stories rather than reading out.</a:t>
             </a:r>
             <a:endParaRPr lang="en-US" dirty="0"/>
           </a:p>
@@ -5876,7 +5876,7 @@
                 <a:ea typeface="Cambria" pitchFamily="34" charset="-122"/>
                 <a:cs typeface="Cambria" pitchFamily="34" charset="-120"/>
               </a:rPr>
-              <a:t>Five things that will bite you</a:t>
+              <a:t>Six things that will bite you</a:t>
             </a:r>
             <a:endParaRPr lang="en-US" sz="3800" dirty="0"/>
           </a:p>
@@ -5890,7 +5890,7 @@
         </p:nvSpPr>
         <p:spPr>
           <a:xfrm>
-            <a:off x="640080" y="1975104"/>
+            <a:off x="640080" y="1929384"/>
             <a:ext cx="365760" cy="365760"/>
           </a:xfrm>
           <a:prstGeom prst="ellipse">
@@ -5910,7 +5910,7 @@
         </p:nvSpPr>
         <p:spPr>
           <a:xfrm>
-            <a:off x="640080" y="1975104"/>
+            <a:off x="640080" y="1929384"/>
             <a:ext cx="365760" cy="365760"/>
           </a:xfrm>
           <a:prstGeom prst="rect">
@@ -5949,7 +5949,7 @@
         </p:nvSpPr>
         <p:spPr>
           <a:xfrm>
-            <a:off x="1188720" y="1920240"/>
+            <a:off x="1188720" y="1874520"/>
             <a:ext cx="4023360" cy="365760"/>
           </a:xfrm>
           <a:prstGeom prst="rect">
@@ -5988,7 +5988,7 @@
         </p:nvSpPr>
         <p:spPr>
           <a:xfrm>
-            <a:off x="5303520" y="1920240"/>
+            <a:off x="5303520" y="1874520"/>
             <a:ext cx="6217920" cy="457200"/>
           </a:xfrm>
           <a:prstGeom prst="rect">
@@ -6027,7 +6027,7 @@
         </p:nvSpPr>
         <p:spPr>
           <a:xfrm>
-            <a:off x="640080" y="2816352"/>
+            <a:off x="640080" y="2706624"/>
             <a:ext cx="365760" cy="365760"/>
           </a:xfrm>
           <a:prstGeom prst="ellipse">
@@ -6047,7 +6047,7 @@
         </p:nvSpPr>
         <p:spPr>
           <a:xfrm>
-            <a:off x="640080" y="2816352"/>
+            <a:off x="640080" y="2706624"/>
             <a:ext cx="365760" cy="365760"/>
           </a:xfrm>
           <a:prstGeom prst="rect">
@@ -6086,7 +6086,7 @@
         </p:nvSpPr>
         <p:spPr>
           <a:xfrm>
-            <a:off x="1188720" y="2761488"/>
+            <a:off x="1188720" y="2651760"/>
             <a:ext cx="4023360" cy="365760"/>
           </a:xfrm>
           <a:prstGeom prst="rect">
@@ -6125,7 +6125,7 @@
         </p:nvSpPr>
         <p:spPr>
           <a:xfrm>
-            <a:off x="5303520" y="2761488"/>
+            <a:off x="5303520" y="2651760"/>
             <a:ext cx="6217920" cy="457200"/>
           </a:xfrm>
           <a:prstGeom prst="rect">
@@ -6164,7 +6164,7 @@
         </p:nvSpPr>
         <p:spPr>
           <a:xfrm>
-            <a:off x="640080" y="3657600"/>
+            <a:off x="640080" y="3483864"/>
             <a:ext cx="365760" cy="365760"/>
           </a:xfrm>
           <a:prstGeom prst="ellipse">
@@ -6184,7 +6184,7 @@
         </p:nvSpPr>
         <p:spPr>
           <a:xfrm>
-            <a:off x="640080" y="3657600"/>
+            <a:off x="640080" y="3483864"/>
             <a:ext cx="365760" cy="365760"/>
           </a:xfrm>
           <a:prstGeom prst="rect">
@@ -6223,7 +6223,7 @@
         </p:nvSpPr>
         <p:spPr>
           <a:xfrm>
-            <a:off x="1188720" y="3602736"/>
+            <a:off x="1188720" y="3429000"/>
             <a:ext cx="4023360" cy="365760"/>
           </a:xfrm>
           <a:prstGeom prst="rect">
@@ -6248,7 +6248,7 @@
                 <a:ea typeface="Calibri" pitchFamily="34" charset="-122"/>
                 <a:cs typeface="Calibri" pitchFamily="34" charset="-120"/>
               </a:rPr>
-              <a:t>e2e ≠ e2e-ci</a:t>
+              <a:t>The cache is not in .nx/cache</a:t>
             </a:r>
             <a:endParaRPr lang="en-US" sz="1600" dirty="0"/>
           </a:p>
@@ -6262,7 +6262,7 @@
         </p:nvSpPr>
         <p:spPr>
           <a:xfrm>
-            <a:off x="5303520" y="3602736"/>
+            <a:off x="5303520" y="3429000"/>
             <a:ext cx="6217920" cy="457200"/>
           </a:xfrm>
           <a:prstGeom prst="rect">
@@ -6287,7 +6287,7 @@
                 <a:ea typeface="Calibri" pitchFamily="34" charset="-122"/>
                 <a:cs typeface="Calibri" pitchFamily="34" charset="-120"/>
               </a:rPr>
-              <a:t>e2e uses the dev server on :4200, e2e-ci builds and previews on :4300.</a:t>
+              <a:t>Nx 23 puts it in ~/.nx/&lt;hash&gt;/cache. Every CI recipe online caches the wrong path.</a:t>
             </a:r>
             <a:endParaRPr lang="en-US" sz="1400" dirty="0"/>
           </a:p>
@@ -6301,7 +6301,7 @@
         </p:nvSpPr>
         <p:spPr>
           <a:xfrm>
-            <a:off x="640080" y="4498848"/>
+            <a:off x="640080" y="4261104"/>
             <a:ext cx="365760" cy="365760"/>
           </a:xfrm>
           <a:prstGeom prst="ellipse">
@@ -6321,7 +6321,7 @@
         </p:nvSpPr>
         <p:spPr>
           <a:xfrm>
-            <a:off x="640080" y="4498848"/>
+            <a:off x="640080" y="4261104"/>
             <a:ext cx="365760" cy="365760"/>
           </a:xfrm>
           <a:prstGeom prst="rect">
@@ -6360,7 +6360,7 @@
         </p:nvSpPr>
         <p:spPr>
           <a:xfrm>
-            <a:off x="1188720" y="4443984"/>
+            <a:off x="1188720" y="4206240"/>
             <a:ext cx="4023360" cy="365760"/>
           </a:xfrm>
           <a:prstGeom prst="rect">
@@ -6385,7 +6385,7 @@
                 <a:ea typeface="Calibri" pitchFamily="34" charset="-122"/>
                 <a:cs typeface="Calibri" pitchFamily="34" charset="-120"/>
               </a:rPr>
-              <a:t>Cache the Cypress binary</a:t>
+              <a:t>Parallel Cypress fights over :99</a:t>
             </a:r>
             <a:endParaRPr lang="en-US" sz="1600" dirty="0"/>
           </a:p>
@@ -6399,7 +6399,7 @@
         </p:nvSpPr>
         <p:spPr>
           <a:xfrm>
-            <a:off x="5303520" y="4443984"/>
+            <a:off x="5303520" y="4206240"/>
             <a:ext cx="6217920" cy="457200"/>
           </a:xfrm>
           <a:prstGeom prst="rect">
@@ -6424,7 +6424,7 @@
                 <a:ea typeface="Calibri" pitchFamily="34" charset="-122"/>
                 <a:cs typeface="Calibri" pitchFamily="34" charset="-120"/>
               </a:rPr>
-              <a:t>Otherwise every CI shard re-downloads ~200 MB.</a:t>
+              <a:t>Each process spawns its own Xvfb. Start one and export DISPLAY.</a:t>
             </a:r>
             <a:endParaRPr lang="en-US" sz="1400" dirty="0"/>
           </a:p>
@@ -6438,7 +6438,7 @@
         </p:nvSpPr>
         <p:spPr>
           <a:xfrm>
-            <a:off x="640080" y="5340096"/>
+            <a:off x="640080" y="5038344"/>
             <a:ext cx="365760" cy="365760"/>
           </a:xfrm>
           <a:prstGeom prst="ellipse">
@@ -6458,7 +6458,7 @@
         </p:nvSpPr>
         <p:spPr>
           <a:xfrm>
-            <a:off x="640080" y="5340096"/>
+            <a:off x="640080" y="5038344"/>
             <a:ext cx="365760" cy="365760"/>
           </a:xfrm>
           <a:prstGeom prst="rect">
@@ -6497,7 +6497,7 @@
         </p:nvSpPr>
         <p:spPr>
           <a:xfrm>
-            <a:off x="1188720" y="5285232"/>
+            <a:off x="1188720" y="4983480"/>
             <a:ext cx="4023360" cy="365760"/>
           </a:xfrm>
           <a:prstGeom prst="rect">
@@ -6522,6 +6522,143 @@
                 <a:ea typeface="Calibri" pitchFamily="34" charset="-122"/>
                 <a:cs typeface="Calibri" pitchFamily="34" charset="-120"/>
               </a:rPr>
+              <a:t>Cache the Cypress binary</a:t>
+            </a:r>
+            <a:endParaRPr lang="en-US" sz="1600" dirty="0"/>
+          </a:p>
+        </p:txBody>
+      </p:sp>
+      <p:sp>
+        <p:nvSpPr>
+          <p:cNvPr id="23" name="Text 21"/>
+          <p:cNvSpPr txBox="1"/>
+          <p:nvPr/>
+        </p:nvSpPr>
+        <p:spPr>
+          <a:xfrm>
+            <a:off x="5303520" y="4983480"/>
+            <a:ext cx="6217920" cy="457200"/>
+          </a:xfrm>
+          <a:prstGeom prst="rect">
+            <a:avLst/>
+          </a:prstGeom>
+          <a:noFill/>
+          <a:ln/>
+        </p:spPr>
+        <p:txBody>
+          <a:bodyPr wrap="square" lIns="0" tIns="0" rIns="0" bIns="0" rtlCol="0" anchor="ctr"/>
+          <a:lstStyle/>
+          <a:p>
+            <a:pPr indent="0" marL="0">
+              <a:buNone/>
+            </a:pPr>
+            <a:r>
+              <a:rPr lang="en-US" sz="1400" dirty="0">
+                <a:solidFill>
+                  <a:srgbClr val="55607A"/>
+                </a:solidFill>
+                <a:latin typeface="Calibri" pitchFamily="34" charset="0"/>
+                <a:ea typeface="Calibri" pitchFamily="34" charset="-122"/>
+                <a:cs typeface="Calibri" pitchFamily="34" charset="-120"/>
+              </a:rPr>
+              <a:t>Otherwise every CI shard re-downloads ~200 MB.</a:t>
+            </a:r>
+            <a:endParaRPr lang="en-US" sz="1400" dirty="0"/>
+          </a:p>
+        </p:txBody>
+      </p:sp>
+      <p:sp>
+        <p:nvSpPr>
+          <p:cNvPr id="24" name="Shape 22"/>
+          <p:cNvSpPr/>
+          <p:nvPr/>
+        </p:nvSpPr>
+        <p:spPr>
+          <a:xfrm>
+            <a:off x="640080" y="5815584"/>
+            <a:ext cx="365760" cy="365760"/>
+          </a:xfrm>
+          <a:prstGeom prst="ellipse">
+            <a:avLst/>
+          </a:prstGeom>
+          <a:solidFill>
+            <a:srgbClr val="B45309"/>
+          </a:solidFill>
+          <a:ln/>
+        </p:spPr>
+      </p:sp>
+      <p:sp>
+        <p:nvSpPr>
+          <p:cNvPr id="25" name="Text 23"/>
+          <p:cNvSpPr txBox="1"/>
+          <p:nvPr/>
+        </p:nvSpPr>
+        <p:spPr>
+          <a:xfrm>
+            <a:off x="640080" y="5815584"/>
+            <a:ext cx="365760" cy="365760"/>
+          </a:xfrm>
+          <a:prstGeom prst="rect">
+            <a:avLst/>
+          </a:prstGeom>
+          <a:noFill/>
+          <a:ln/>
+        </p:spPr>
+        <p:txBody>
+          <a:bodyPr wrap="square" lIns="0" tIns="0" rIns="0" bIns="0" rtlCol="0" anchor="ctr"/>
+          <a:lstStyle/>
+          <a:p>
+            <a:pPr algn="ctr" indent="0" marL="0">
+              <a:buNone/>
+            </a:pPr>
+            <a:r>
+              <a:rPr lang="en-US" sz="1400" b="1" dirty="0">
+                <a:solidFill>
+                  <a:srgbClr val="FFFFFF"/>
+                </a:solidFill>
+                <a:latin typeface="Calibri" pitchFamily="34" charset="0"/>
+                <a:ea typeface="Calibri" pitchFamily="34" charset="-122"/>
+                <a:cs typeface="Calibri" pitchFamily="34" charset="-120"/>
+              </a:rPr>
+              <a:t>6</a:t>
+            </a:r>
+            <a:endParaRPr lang="en-US" sz="1400" dirty="0"/>
+          </a:p>
+        </p:txBody>
+      </p:sp>
+      <p:sp>
+        <p:nvSpPr>
+          <p:cNvPr id="26" name="Text 24"/>
+          <p:cNvSpPr txBox="1"/>
+          <p:nvPr/>
+        </p:nvSpPr>
+        <p:spPr>
+          <a:xfrm>
+            <a:off x="1188720" y="5760720"/>
+            <a:ext cx="4023360" cy="365760"/>
+          </a:xfrm>
+          <a:prstGeom prst="rect">
+            <a:avLst/>
+          </a:prstGeom>
+          <a:noFill/>
+          <a:ln/>
+        </p:spPr>
+        <p:txBody>
+          <a:bodyPr wrap="square" lIns="0" tIns="0" rIns="0" bIns="0" rtlCol="0" anchor="ctr"/>
+          <a:lstStyle/>
+          <a:p>
+            <a:pPr indent="0" marL="0">
+              <a:buNone/>
+            </a:pPr>
+            <a:r>
+              <a:rPr lang="en-US" sz="1600" b="1" dirty="0">
+                <a:solidFill>
+                  <a:srgbClr val="10131A"/>
+                </a:solidFill>
+                <a:latin typeface="Calibri" pitchFamily="34" charset="0"/>
+                <a:ea typeface="Calibri" pitchFamily="34" charset="-122"/>
+                <a:cs typeface="Calibri" pitchFamily="34" charset="-120"/>
+              </a:rPr>
               <a:t>App changes invalidate everything</a:t>
             </a:r>
             <a:endParaRPr lang="en-US" sz="1600" dirty="0"/>
@@ -6530,13 +6667,13 @@
       </p:sp>
       <p:sp>
         <p:nvSpPr>
-          <p:cNvPr id="23" name="Text 21"/>
-          <p:cNvSpPr txBox="1"/>
-          <p:nvPr/>
-        </p:nvSpPr>
-        <p:spPr>
-          <a:xfrm>
-            <a:off x="5303520" y="5285232"/>
+          <p:cNvPr id="27" name="Text 25"/>
+          <p:cNvSpPr txBox="1"/>
+          <p:nvPr/>
+        </p:nvSpPr>
+        <p:spPr>
+          <a:xfrm>
+            <a:off x="5303520" y="5760720"/>
             <a:ext cx="6217920" cy="457200"/>
           </a:xfrm>
           <a:prstGeom prst="rect">

</xml_diff>

<commit_message>
Record the measured CI cache numbers
Same commit run twice on Actions: jobs go 1m32s-2m7s cold to 37-47s with the
cache restored, and the e2e step itself to 31ms at 83% hits. Which means once
the tests are cached, CI time is setup time.
</commit_message>
<xml_diff>
--- a/talk/Scaling-E2E-Tests-with-Nx.pptx
+++ b/talk/Scaling-E2E-Tests-with-Nx.pptx
@@ -869,7 +869,7 @@
           <a:p>
             <a:r>
               <a:rPr lang="en-US" dirty="0"/>
-              <a:t>Do not oversell. The argument is that the free tier of this idea is unclaimed, not that the paid product is pointless.</a:t>
+              <a:t>Do not oversell. The argument is that the free tier of this idea is unclaimed, not that the paid product is pointless. The 1m32s to 38s figure is from this repo's own Actions runs, same commit run twice; the e2e step itself drops to 31ms and what remains is checkout plus npm ci.</a:t>
             </a:r>
             <a:endParaRPr lang="en-US" dirty="0"/>
           </a:p>
@@ -5307,7 +5307,7 @@
                 <a:ea typeface="Courier New" pitchFamily="34" charset="-122"/>
                 <a:cs typeface="Courier New" pitchFamily="34" charset="-120"/>
               </a:rPr>
-              <a:t>  - uses: actions/cache@v4          # .nx/cache, per shard</a:t>
+              <a:t>  - uses: actions/cache@v4          # path: .nx  (all of it)</a:t>
             </a:r>
             <a:endParaRPr lang="en-US" sz="1200" dirty="0"/>
           </a:p>
@@ -5412,7 +5412,28 @@
                 <a:ea typeface="Calibri" pitchFamily="34" charset="-122"/>
                 <a:cs typeface="Calibri" pitchFamily="34" charset="-120"/>
               </a:rPr>
-              <a:t>Restore .nx/cache per shard so a re-run of a red job is cheap</a:t>
+              <a:t>Cache all of .nx per shard, so a re-run of a red job is cheap</a:t>
+            </a:r>
+            <a:endParaRPr lang="en-US" sz="1300" dirty="0"/>
+          </a:p>
+          <a:p>
+            <a:pPr marL="342900" indent="-342900">
+              <a:spcAft>
+                <a:spcPts val="1000"/>
+              </a:spcAft>
+              <a:buSzPct val="100000"/>
+              <a:buChar char="•"/>
+            </a:pPr>
+            <a:r>
+              <a:rPr lang="en-US" sz="1300" b="1" dirty="0">
+                <a:solidFill>
+                  <a:srgbClr val="4ADE80"/>
+                </a:solidFill>
+                <a:latin typeface="Calibri" pitchFamily="34" charset="0"/>
+                <a:ea typeface="Calibri" pitchFamily="34" charset="-122"/>
+                <a:cs typeface="Calibri" pitchFamily="34" charset="-120"/>
+              </a:rPr>
+              <a:t>Measured here: 1m 32s cold → 38s with the cache restored</a:t>
             </a:r>
             <a:endParaRPr lang="en-US" sz="1300" dirty="0"/>
           </a:p>

</xml_diff>

<commit_message>
Record that the cache is keyed on inputs, not commits
The previous commit touched only the deck, so CI restored the commit before it
and reported 33/36 hits at 119ms — single-machine went 3m44s to 35s unplanned.
That is a better demonstration than the staged one, and it corrects a gotcha
here that claimed failure-only replay works within a commit but not across one.
</commit_message>
<xml_diff>
--- a/talk/Scaling-E2E-Tests-with-Nx.pptx
+++ b/talk/Scaling-E2E-Tests-with-Nx.pptx
@@ -784,7 +784,7 @@
           <a:p>
             <a:r>
               <a:rPr lang="en-US" dirty="0"/>
-              <a:t>If you want the "everything re-runs" version instead, run nx reset before this step.</a:t>
+              <a:t>If you want the "everything re-runs" version instead, run nx reset before this step. Best real example from this repo: a commit that touched only the slide deck restored the previous commit's cache and reported 33/36 hits and a 119ms run — the single-machine CI job went from 3m44s to 35s without anyone planning it. Inputs, not commits.</a:t>
             </a:r>
             <a:endParaRPr lang="en-US" dirty="0"/>
           </a:p>
@@ -5335,7 +5335,7 @@
                 <a:ea typeface="Calibri" pitchFamily="34" charset="-122"/>
                 <a:cs typeface="Calibri" pitchFamily="34" charset="-120"/>
               </a:rPr>
-              <a:t>The flip side: touch a shared component and all ten specs invalidate — correctly. Failure-only retries work between retries of the same commit, not across a code change.</a:t>
+              <a:t>The flip side: touch libs/ui and both admin and docs invalidate — correctly. But the key is built from inputs, not from the commit, so a change outside the graph costs nothing.</a:t>
             </a:r>
             <a:endParaRPr lang="en-US" sz="1400" dirty="0"/>
           </a:p>

</xml_diff>

<commit_message>
Fill in the speaker details and LinkedIn QR
Also anchors the audience-question titles to the top of their cards — the
middle one wraps to two lines and pptxgenjs was centring it, so that card sat
lower than its neighbours.

All three QR codes verified by decoding the generated PNGs, not by trusting
the generator.
</commit_message>
<xml_diff>
--- a/talk/Scaling-E2E-Tests-with-Nx.pptx
+++ b/talk/Scaling-E2E-Tests-with-Nx.pptx
@@ -3136,7 +3136,7 @@
                 <a:ea typeface="Calibri" pitchFamily="34" charset="-122"/>
                 <a:cs typeface="Calibri" pitchFamily="34" charset="-120"/>
               </a:rPr>
-              <a:t>SET YOUR ZUHLKE TITLE IN deck.js</a:t>
+              <a:t>Principal Consultant &amp; Partner, Zühlke</a:t>
             </a:r>
             <a:endParaRPr lang="en-US" sz="1500" dirty="0"/>
           </a:p>
@@ -3159,75 +3159,43 @@
             </a:avLst>
           </a:prstGeom>
           <a:solidFill>
-            <a:srgbClr val="1B2029"/>
+            <a:srgbClr val="FFFFFF"/>
           </a:solidFill>
-          <a:ln w="19050">
+          <a:ln w="12700">
             <a:solidFill>
-              <a:srgbClr val="FB7185"/>
+              <a:srgbClr val="333333"/>
             </a:solidFill>
-            <a:prstDash val="dash"/>
+            <a:prstDash val="solid"/>
           </a:ln>
         </p:spPr>
       </p:sp>
-      <p:sp>
-        <p:nvSpPr>
-          <p:cNvPr id="9" name="Text 7"/>
-          <p:cNvSpPr txBox="1"/>
-          <p:nvPr/>
-        </p:nvSpPr>
-        <p:spPr>
-          <a:xfrm>
-            <a:off x="8869680" y="2011680"/>
-            <a:ext cx="2286000" cy="2286000"/>
-          </a:xfrm>
-          <a:prstGeom prst="rect">
-            <a:avLst/>
-          </a:prstGeom>
-          <a:noFill/>
-          <a:ln/>
-        </p:spPr>
-        <p:txBody>
-          <a:bodyPr wrap="square" lIns="0" tIns="0" rIns="0" bIns="0" rtlCol="0" anchor="ctr"/>
-          <a:lstStyle/>
-          <a:p>
-            <a:pPr algn="ctr" indent="0" marL="0">
-              <a:buNone/>
-            </a:pPr>
-            <a:r>
-              <a:rPr lang="en-US" sz="1300" dirty="0">
-                <a:solidFill>
-                  <a:srgbClr val="FB7185"/>
-                </a:solidFill>
-                <a:latin typeface="Calibri" pitchFamily="34" charset="0"/>
-                <a:ea typeface="Calibri" pitchFamily="34" charset="-122"/>
-                <a:cs typeface="Calibri" pitchFamily="34" charset="-120"/>
-              </a:rPr>
-              <a:t>LinkedIn QR</a:t>
-            </a:r>
-            <a:endParaRPr lang="en-US" sz="1300" dirty="0"/>
-          </a:p>
-          <a:p>
-            <a:pPr algn="ctr" indent="0" marL="0">
-              <a:buNone/>
-            </a:pPr>
-            <a:r>
-              <a:rPr lang="en-US" sz="1300" dirty="0">
-                <a:solidFill>
-                  <a:srgbClr val="FB7185"/>
-                </a:solidFill>
-                <a:latin typeface="Calibri" pitchFamily="34" charset="0"/>
-                <a:ea typeface="Calibri" pitchFamily="34" charset="-122"/>
-                <a:cs typeface="Calibri" pitchFamily="34" charset="-120"/>
-              </a:rPr>
-              <a:t>not generated</a:t>
-            </a:r>
-            <a:endParaRPr lang="en-US" sz="1300" dirty="0"/>
-          </a:p>
-        </p:txBody>
-      </p:sp>
-      <p:sp>
-        <p:nvSpPr>
-          <p:cNvPr id="10" name="Text 8"/>
+      <p:pic>
+        <p:nvPicPr>
+          <p:cNvPr id="9" name="Image 0" descr="/Users/vra/IdeaProjects/nx-scaling-e2e-tests-with-atomizer/talk/assets/qr-linkedin.png">    </p:cNvPr>
+          <p:cNvPicPr>
+            <a:picLocks noChangeAspect="1"/>
+          </p:cNvPicPr>
+          <p:nvPr/>
+        </p:nvPicPr>
+        <p:blipFill>
+          <a:blip r:embed="rId1"/>
+          <a:stretch>
+            <a:fillRect/>
+          </a:stretch>
+        </p:blipFill>
+        <p:spPr>
+          <a:xfrm>
+            <a:off x="8988552" y="2130552"/>
+            <a:ext cx="2048256" cy="2048256"/>
+          </a:xfrm>
+          <a:prstGeom prst="rect">
+            <a:avLst/>
+          </a:prstGeom>
+        </p:spPr>
+      </p:pic>
+      <p:sp>
+        <p:nvSpPr>
+          <p:cNvPr id="10" name="Text 7"/>
           <p:cNvSpPr txBox="1"/>
           <p:nvPr/>
         </p:nvSpPr>
@@ -5191,7 +5159,7 @@
         <p:spPr>
           <a:xfrm>
             <a:off x="8046720" y="1783080"/>
-            <a:ext cx="3474720" cy="2377440"/>
+            <a:ext cx="3291840" cy="2377440"/>
           </a:xfrm>
           <a:prstGeom prst="rect">
             <a:avLst/>
@@ -13032,7 +13000,7 @@
                 <a:ea typeface="Calibri" pitchFamily="34" charset="-122"/>
                 <a:cs typeface="Calibri" pitchFamily="34" charset="-120"/>
               </a:rPr>
-              <a:t>Vladimir Radzivil · SET YOUR LINKEDIN HANDLE IN deck.js</a:t>
+              <a:t>Vladimir Radzivil · linkedin.com/in/vladimirradzivil</a:t>
             </a:r>
             <a:endParaRPr lang="en-US" sz="1400" dirty="0"/>
           </a:p>
@@ -15111,7 +15079,7 @@
           <a:ln/>
         </p:spPr>
         <p:txBody>
-          <a:bodyPr wrap="square" lIns="0" tIns="0" rIns="0" bIns="0" rtlCol="0" anchor="ctr"/>
+          <a:bodyPr wrap="square" lIns="0" tIns="0" rIns="0" bIns="0" rtlCol="0" anchor="t"/>
           <a:lstStyle/>
           <a:p>
             <a:pPr indent="0" marL="0">
@@ -15280,7 +15248,7 @@
           <a:ln/>
         </p:spPr>
         <p:txBody>
-          <a:bodyPr wrap="square" lIns="0" tIns="0" rIns="0" bIns="0" rtlCol="0" anchor="ctr"/>
+          <a:bodyPr wrap="square" lIns="0" tIns="0" rIns="0" bIns="0" rtlCol="0" anchor="t"/>
           <a:lstStyle/>
           <a:p>
             <a:pPr indent="0" marL="0">
@@ -15449,7 +15417,7 @@
           <a:ln/>
         </p:spPr>
         <p:txBody>
-          <a:bodyPr wrap="square" lIns="0" tIns="0" rIns="0" bIns="0" rtlCol="0" anchor="ctr"/>
+          <a:bodyPr wrap="square" lIns="0" tIns="0" rIns="0" bIns="0" rtlCol="0" anchor="t"/>
           <a:lstStyle/>
           <a:p>
             <a:pPr indent="0" marL="0">

</xml_diff>

<commit_message>
Make room for a speaker photo on the title slide
Circular portrait beside the name, reading assets/avatar.{png,jpg,jpeg}. The
file is not in the repo yet, so the slide currently draws a dashed placeholder
rather than leaving a silent gap.
</commit_message>
<xml_diff>
--- a/talk/Scaling-E2E-Tests-with-Nx.pptx
+++ b/talk/Scaling-E2E-Tests-with-Nx.pptx
@@ -3066,14 +3066,78 @@
       </p:sp>
       <p:sp>
         <p:nvSpPr>
-          <p:cNvPr id="6" name="Text 4"/>
-          <p:cNvSpPr txBox="1"/>
-          <p:nvPr/>
-        </p:nvSpPr>
-        <p:spPr>
-          <a:xfrm>
-            <a:off x="640080" y="4297680"/>
-            <a:ext cx="7863840" cy="411480"/>
+          <p:cNvPr id="6" name="Shape 4"/>
+          <p:cNvSpPr/>
+          <p:nvPr/>
+        </p:nvSpPr>
+        <p:spPr>
+          <a:xfrm>
+            <a:off x="640080" y="4224528"/>
+            <a:ext cx="1234440" cy="1234440"/>
+          </a:xfrm>
+          <a:prstGeom prst="ellipse">
+            <a:avLst/>
+          </a:prstGeom>
+          <a:solidFill>
+            <a:srgbClr val="1B2029"/>
+          </a:solidFill>
+          <a:ln w="19050">
+            <a:solidFill>
+              <a:srgbClr val="FB7185"/>
+            </a:solidFill>
+            <a:prstDash val="dash"/>
+          </a:ln>
+        </p:spPr>
+      </p:sp>
+      <p:sp>
+        <p:nvSpPr>
+          <p:cNvPr id="7" name="Text 5"/>
+          <p:cNvSpPr txBox="1"/>
+          <p:nvPr/>
+        </p:nvSpPr>
+        <p:spPr>
+          <a:xfrm>
+            <a:off x="640080" y="4224528"/>
+            <a:ext cx="1234440" cy="1234440"/>
+          </a:xfrm>
+          <a:prstGeom prst="rect">
+            <a:avLst/>
+          </a:prstGeom>
+          <a:noFill/>
+          <a:ln/>
+        </p:spPr>
+        <p:txBody>
+          <a:bodyPr wrap="square" lIns="0" tIns="0" rIns="0" bIns="0" rtlCol="0" anchor="ctr"/>
+          <a:lstStyle/>
+          <a:p>
+            <a:pPr algn="ctr" indent="0" marL="0">
+              <a:buNone/>
+            </a:pPr>
+            <a:r>
+              <a:rPr lang="en-US" sz="1100" dirty="0">
+                <a:solidFill>
+                  <a:srgbClr val="FB7185"/>
+                </a:solidFill>
+                <a:latin typeface="Calibri" pitchFamily="34" charset="0"/>
+                <a:ea typeface="Calibri" pitchFamily="34" charset="-122"/>
+                <a:cs typeface="Calibri" pitchFamily="34" charset="-120"/>
+              </a:rPr>
+              <a:t>PHOTO</a:t>
+            </a:r>
+            <a:endParaRPr lang="en-US" sz="1100" dirty="0"/>
+          </a:p>
+        </p:txBody>
+      </p:sp>
+      <p:sp>
+        <p:nvSpPr>
+          <p:cNvPr id="8" name="Text 6"/>
+          <p:cNvSpPr txBox="1"/>
+          <p:nvPr/>
+        </p:nvSpPr>
+        <p:spPr>
+          <a:xfrm>
+            <a:off x="2148840" y="4416552"/>
+            <a:ext cx="6309360" cy="411480"/>
           </a:xfrm>
           <a:prstGeom prst="rect">
             <a:avLst/>
@@ -3105,14 +3169,14 @@
       </p:sp>
       <p:sp>
         <p:nvSpPr>
-          <p:cNvPr id="7" name="Text 5"/>
-          <p:cNvSpPr txBox="1"/>
-          <p:nvPr/>
-        </p:nvSpPr>
-        <p:spPr>
-          <a:xfrm>
-            <a:off x="640080" y="4709160"/>
-            <a:ext cx="7863840" cy="365760"/>
+          <p:cNvPr id="9" name="Text 7"/>
+          <p:cNvSpPr txBox="1"/>
+          <p:nvPr/>
+        </p:nvSpPr>
+        <p:spPr>
+          <a:xfrm>
+            <a:off x="2148840" y="4828032"/>
+            <a:ext cx="6309360" cy="365760"/>
           </a:xfrm>
           <a:prstGeom prst="rect">
             <a:avLst/>
@@ -3144,7 +3208,7 @@
       </p:sp>
       <p:sp>
         <p:nvSpPr>
-          <p:cNvPr id="8" name="Shape 6"/>
+          <p:cNvPr id="10" name="Shape 8"/>
           <p:cNvSpPr/>
           <p:nvPr/>
         </p:nvSpPr>
@@ -3171,7 +3235,7 @@
       </p:sp>
       <p:pic>
         <p:nvPicPr>
-          <p:cNvPr id="9" name="Image 0" descr="/Users/vra/IdeaProjects/nx-scaling-e2e-tests-with-atomizer/talk/assets/qr-linkedin.png">    </p:cNvPr>
+          <p:cNvPr id="11" name="Image 0" descr="/Users/vra/IdeaProjects/nx-scaling-e2e-tests-with-atomizer/talk/assets/qr-linkedin.png">    </p:cNvPr>
           <p:cNvPicPr>
             <a:picLocks noChangeAspect="1"/>
           </p:cNvPicPr>
@@ -3195,7 +3259,7 @@
       </p:pic>
       <p:sp>
         <p:nvSpPr>
-          <p:cNvPr id="10" name="Text 7"/>
+          <p:cNvPr id="12" name="Text 9"/>
           <p:cNvSpPr txBox="1"/>
           <p:nvPr/>
         </p:nvSpPr>

</xml_diff>

<commit_message>
Add the speaker photo to the title slide
</commit_message>
<xml_diff>
--- a/talk/Scaling-E2E-Tests-with-Nx.pptx
+++ b/talk/Scaling-E2E-Tests-with-Nx.pptx
@@ -3064,12 +3064,20 @@
           </a:ln>
         </p:spPr>
       </p:sp>
-      <p:sp>
-        <p:nvSpPr>
-          <p:cNvPr id="6" name="Shape 4"/>
-          <p:cNvSpPr/>
-          <p:nvPr/>
-        </p:nvSpPr>
+      <p:pic>
+        <p:nvPicPr>
+          <p:cNvPr id="6" name="Image 0" descr="/Users/vra/IdeaProjects/nx-scaling-e2e-tests-with-atomizer/talk/assets/avatar.jpg">    </p:cNvPr>
+          <p:cNvPicPr>
+            <a:picLocks noChangeAspect="1"/>
+          </p:cNvPicPr>
+          <p:nvPr/>
+        </p:nvPicPr>
+        <p:blipFill>
+          <a:blip r:embed="rId1"/>
+          <a:stretch>
+            <a:fillRect/>
+          </a:stretch>
+        </p:blipFill>
         <p:spPr>
           <a:xfrm>
             <a:off x="640080" y="4224528"/>
@@ -3078,59 +3086,11 @@
           <a:prstGeom prst="ellipse">
             <a:avLst/>
           </a:prstGeom>
-          <a:solidFill>
-            <a:srgbClr val="1B2029"/>
-          </a:solidFill>
-          <a:ln w="19050">
-            <a:solidFill>
-              <a:srgbClr val="FB7185"/>
-            </a:solidFill>
-            <a:prstDash val="dash"/>
-          </a:ln>
-        </p:spPr>
-      </p:sp>
-      <p:sp>
-        <p:nvSpPr>
-          <p:cNvPr id="7" name="Text 5"/>
-          <p:cNvSpPr txBox="1"/>
-          <p:nvPr/>
-        </p:nvSpPr>
-        <p:spPr>
-          <a:xfrm>
-            <a:off x="640080" y="4224528"/>
-            <a:ext cx="1234440" cy="1234440"/>
-          </a:xfrm>
-          <a:prstGeom prst="rect">
-            <a:avLst/>
-          </a:prstGeom>
-          <a:noFill/>
-          <a:ln/>
-        </p:spPr>
-        <p:txBody>
-          <a:bodyPr wrap="square" lIns="0" tIns="0" rIns="0" bIns="0" rtlCol="0" anchor="ctr"/>
-          <a:lstStyle/>
-          <a:p>
-            <a:pPr algn="ctr" indent="0" marL="0">
-              <a:buNone/>
-            </a:pPr>
-            <a:r>
-              <a:rPr lang="en-US" sz="1100" dirty="0">
-                <a:solidFill>
-                  <a:srgbClr val="FB7185"/>
-                </a:solidFill>
-                <a:latin typeface="Calibri" pitchFamily="34" charset="0"/>
-                <a:ea typeface="Calibri" pitchFamily="34" charset="-122"/>
-                <a:cs typeface="Calibri" pitchFamily="34" charset="-120"/>
-              </a:rPr>
-              <a:t>PHOTO</a:t>
-            </a:r>
-            <a:endParaRPr lang="en-US" sz="1100" dirty="0"/>
-          </a:p>
-        </p:txBody>
-      </p:sp>
-      <p:sp>
-        <p:nvSpPr>
-          <p:cNvPr id="8" name="Text 6"/>
+        </p:spPr>
+      </p:pic>
+      <p:sp>
+        <p:nvSpPr>
+          <p:cNvPr id="7" name="Text 4"/>
           <p:cNvSpPr txBox="1"/>
           <p:nvPr/>
         </p:nvSpPr>
@@ -3169,7 +3129,7 @@
       </p:sp>
       <p:sp>
         <p:nvSpPr>
-          <p:cNvPr id="9" name="Text 7"/>
+          <p:cNvPr id="8" name="Text 5"/>
           <p:cNvSpPr txBox="1"/>
           <p:nvPr/>
         </p:nvSpPr>
@@ -3208,7 +3168,7 @@
       </p:sp>
       <p:sp>
         <p:nvSpPr>
-          <p:cNvPr id="10" name="Shape 8"/>
+          <p:cNvPr id="9" name="Shape 6"/>
           <p:cNvSpPr/>
           <p:nvPr/>
         </p:nvSpPr>
@@ -3235,14 +3195,14 @@
       </p:sp>
       <p:pic>
         <p:nvPicPr>
-          <p:cNvPr id="11" name="Image 0" descr="/Users/vra/IdeaProjects/nx-scaling-e2e-tests-with-atomizer/talk/assets/qr-linkedin.png">    </p:cNvPr>
+          <p:cNvPr id="10" name="Image 1" descr="/Users/vra/IdeaProjects/nx-scaling-e2e-tests-with-atomizer/talk/assets/qr-linkedin.png">    </p:cNvPr>
           <p:cNvPicPr>
             <a:picLocks noChangeAspect="1"/>
           </p:cNvPicPr>
           <p:nvPr/>
         </p:nvPicPr>
         <p:blipFill>
-          <a:blip r:embed="rId1"/>
+          <a:blip r:embed="rId2"/>
           <a:stretch>
             <a:fillRect/>
           </a:stretch>
@@ -3259,7 +3219,7 @@
       </p:pic>
       <p:sp>
         <p:nvSpPr>
-          <p:cNvPr id="12" name="Text 9"/>
+          <p:cNvPr id="11" name="Text 7"/>
           <p:cNvSpPr txBox="1"/>
           <p:nvPr/>
         </p:nvSpPr>

</xml_diff>

<commit_message>
Make the why-now slide argue in minutes
Replaces the abstract "unchanged" framing with the number the rest of the talk
is aimed at: an hour to run everything today, ten minutes for an isolated
change. The 6:1 bar comparison does the arguing, and it matches where the real
project actually landed.
</commit_message>
<xml_diff>
--- a/talk/Scaling-E2E-Tests-with-Nx.pptx
+++ b/talk/Scaling-E2E-Tests-with-Nx.pptx
@@ -2551,7 +2551,7 @@
           <a:p>
             <a:r>
               <a:rPr lang="en-US" dirty="0"/>
-              <a:t>This is the argument for caring. Do not oversell AI — the point is only that the ratio moved. Generation is cheap, verification is not, so verification is where the leverage went.</a:t>
+              <a:t>The argument for caring, in one comparison. Do not oversell AI — the only claim is that the ratio moved: generation got cheap, verification did not, so verification is where the leverage is now. Ten minutes is not arbitrary; it is roughly what an isolated change costs once affected plus caching plus per-app runners are all doing their job, and it is what the real project landed on.</a:t>
             </a:r>
             <a:endParaRPr lang="en-US" dirty="0"/>
           </a:p>
@@ -18298,12 +18298,12 @@
         </p:nvSpPr>
         <p:spPr>
           <a:xfrm>
-            <a:off x="640080" y="1920240"/>
-            <a:ext cx="5257800" cy="2103120"/>
+            <a:off x="640080" y="1783080"/>
+            <a:ext cx="5257800" cy="1874520"/>
           </a:xfrm>
           <a:prstGeom prst="roundRect">
             <a:avLst>
-              <a:gd name="adj" fmla="val 3913"/>
+              <a:gd name="adj" fmla="val 4390"/>
             </a:avLst>
           </a:prstGeom>
           <a:solidFill>
@@ -18325,7 +18325,46 @@
         </p:nvSpPr>
         <p:spPr>
           <a:xfrm>
-            <a:off x="914400" y="2148840"/>
+            <a:off x="914400" y="1965960"/>
+            <a:ext cx="4709160" cy="365760"/>
+          </a:xfrm>
+          <a:prstGeom prst="rect">
+            <a:avLst/>
+          </a:prstGeom>
+          <a:noFill/>
+          <a:ln/>
+        </p:spPr>
+        <p:txBody>
+          <a:bodyPr wrap="square" lIns="0" tIns="0" rIns="0" bIns="0" rtlCol="0" anchor="ctr"/>
+          <a:lstStyle/>
+          <a:p>
+            <a:pPr indent="0" marL="0">
+              <a:buNone/>
+            </a:pPr>
+            <a:r>
+              <a:rPr lang="en-US" sz="1800" b="1" dirty="0">
+                <a:solidFill>
+                  <a:srgbClr val="FFFFFF"/>
+                </a:solidFill>
+                <a:latin typeface="Calibri" pitchFamily="34" charset="0"/>
+                <a:ea typeface="Calibri" pitchFamily="34" charset="-122"/>
+                <a:cs typeface="Calibri" pitchFamily="34" charset="-120"/>
+              </a:rPr>
+              <a:t>Writing the change</a:t>
+            </a:r>
+            <a:endParaRPr lang="en-US" sz="1800" dirty="0"/>
+          </a:p>
+        </p:txBody>
+      </p:sp>
+      <p:sp>
+        <p:nvSpPr>
+          <p:cNvPr id="6" name="Text 4"/>
+          <p:cNvSpPr txBox="1"/>
+          <p:nvPr/>
+        </p:nvSpPr>
+        <p:spPr>
+          <a:xfrm>
+            <a:off x="914400" y="2359152"/>
             <a:ext cx="4709160" cy="411480"/>
           </a:xfrm>
           <a:prstGeom prst="rect">
@@ -18342,46 +18381,7 @@
               <a:buNone/>
             </a:pPr>
             <a:r>
-              <a:rPr lang="en-US" sz="2000" b="1" dirty="0">
-                <a:solidFill>
-                  <a:srgbClr val="FFFFFF"/>
-                </a:solidFill>
-                <a:latin typeface="Calibri" pitchFamily="34" charset="0"/>
-                <a:ea typeface="Calibri" pitchFamily="34" charset="-122"/>
-                <a:cs typeface="Calibri" pitchFamily="34" charset="-120"/>
-              </a:rPr>
-              <a:t>Writing the change</a:t>
-            </a:r>
-            <a:endParaRPr lang="en-US" sz="2000" dirty="0"/>
-          </a:p>
-        </p:txBody>
-      </p:sp>
-      <p:sp>
-        <p:nvSpPr>
-          <p:cNvPr id="6" name="Text 4"/>
-          <p:cNvSpPr txBox="1"/>
-          <p:nvPr/>
-        </p:nvSpPr>
-        <p:spPr>
-          <a:xfrm>
-            <a:off x="914400" y="2606040"/>
-            <a:ext cx="4709160" cy="365760"/>
-          </a:xfrm>
-          <a:prstGeom prst="rect">
-            <a:avLst/>
-          </a:prstGeom>
-          <a:noFill/>
-          <a:ln/>
-        </p:spPr>
-        <p:txBody>
-          <a:bodyPr wrap="square" lIns="0" tIns="0" rIns="0" bIns="0" rtlCol="0" anchor="ctr"/>
-          <a:lstStyle/>
-          <a:p>
-            <a:pPr indent="0" marL="0">
-              <a:buNone/>
-            </a:pPr>
-            <a:r>
-              <a:rPr lang="en-US" sz="2200" b="1" spc="100" kern="0" dirty="0">
+              <a:rPr lang="en-US" sz="2400" b="1" spc="100" kern="0" dirty="0">
                 <a:solidFill>
                   <a:srgbClr val="4ADE80"/>
                 </a:solidFill>
@@ -18391,7 +18391,7 @@
               </a:rPr>
               <a:t>MINUTES</a:t>
             </a:r>
-            <a:endParaRPr lang="en-US" sz="2200" dirty="0"/>
+            <a:endParaRPr lang="en-US" sz="2400" dirty="0"/>
           </a:p>
         </p:txBody>
       </p:sp>
@@ -18403,24 +18403,24 @@
         </p:nvSpPr>
         <p:spPr>
           <a:xfrm>
-            <a:off x="914400" y="3063240"/>
-            <a:ext cx="4709160" cy="777240"/>
-          </a:xfrm>
-          <a:prstGeom prst="rect">
-            <a:avLst/>
-          </a:prstGeom>
-          <a:noFill/>
-          <a:ln/>
-        </p:spPr>
-        <p:txBody>
-          <a:bodyPr wrap="square" lIns="0" tIns="0" rIns="0" bIns="0" rtlCol="0" anchor="ctr"/>
-          <a:lstStyle/>
-          <a:p>
-            <a:pPr indent="0" marL="0">
-              <a:buNone/>
-            </a:pPr>
-            <a:r>
-              <a:rPr lang="en-US" sz="1400" dirty="0">
+            <a:off x="914400" y="2852928"/>
+            <a:ext cx="4709160" cy="685800"/>
+          </a:xfrm>
+          <a:prstGeom prst="rect">
+            <a:avLst/>
+          </a:prstGeom>
+          <a:noFill/>
+          <a:ln/>
+        </p:spPr>
+        <p:txBody>
+          <a:bodyPr wrap="square" lIns="0" tIns="0" rIns="0" bIns="0" rtlCol="0" anchor="ctr"/>
+          <a:lstStyle/>
+          <a:p>
+            <a:pPr indent="0" marL="0">
+              <a:buNone/>
+            </a:pPr>
+            <a:r>
+              <a:rPr lang="en-US" sz="1300" dirty="0">
                 <a:solidFill>
                   <a:srgbClr val="C3CAD6"/>
                 </a:solidFill>
@@ -18428,9 +18428,9 @@
                 <a:ea typeface="Calibri" pitchFamily="34" charset="-122"/>
                 <a:cs typeface="Calibri" pitchFamily="34" charset="-120"/>
               </a:rPr>
-              <a:t>AI writes it, reviews it, refactors it. The cost collapsed this year.</a:t>
-            </a:r>
-            <a:endParaRPr lang="en-US" sz="1400" dirty="0"/>
+              <a:t>AI writes it, reviews it, refactors it. That cost collapsed this year.</a:t>
+            </a:r>
+            <a:endParaRPr lang="en-US" sz="1300" dirty="0"/>
           </a:p>
         </p:txBody>
       </p:sp>
@@ -18442,12 +18442,12 @@
         </p:nvSpPr>
         <p:spPr>
           <a:xfrm>
-            <a:off x="6263640" y="1920240"/>
-            <a:ext cx="5257800" cy="2103120"/>
+            <a:off x="6263640" y="1783080"/>
+            <a:ext cx="5257800" cy="1874520"/>
           </a:xfrm>
           <a:prstGeom prst="roundRect">
             <a:avLst>
-              <a:gd name="adj" fmla="val 3913"/>
+              <a:gd name="adj" fmla="val 4390"/>
             </a:avLst>
           </a:prstGeom>
           <a:solidFill>
@@ -18469,7 +18469,46 @@
         </p:nvSpPr>
         <p:spPr>
           <a:xfrm>
-            <a:off x="6537960" y="2148840"/>
+            <a:off x="6537960" y="1965960"/>
+            <a:ext cx="4709160" cy="365760"/>
+          </a:xfrm>
+          <a:prstGeom prst="rect">
+            <a:avLst/>
+          </a:prstGeom>
+          <a:noFill/>
+          <a:ln/>
+        </p:spPr>
+        <p:txBody>
+          <a:bodyPr wrap="square" lIns="0" tIns="0" rIns="0" bIns="0" rtlCol="0" anchor="ctr"/>
+          <a:lstStyle/>
+          <a:p>
+            <a:pPr indent="0" marL="0">
+              <a:buNone/>
+            </a:pPr>
+            <a:r>
+              <a:rPr lang="en-US" sz="1800" b="1" dirty="0">
+                <a:solidFill>
+                  <a:srgbClr val="FFFFFF"/>
+                </a:solidFill>
+                <a:latin typeface="Calibri" pitchFamily="34" charset="0"/>
+                <a:ea typeface="Calibri" pitchFamily="34" charset="-122"/>
+                <a:cs typeface="Calibri" pitchFamily="34" charset="-120"/>
+              </a:rPr>
+              <a:t>Trusting the change</a:t>
+            </a:r>
+            <a:endParaRPr lang="en-US" sz="1800" dirty="0"/>
+          </a:p>
+        </p:txBody>
+      </p:sp>
+      <p:sp>
+        <p:nvSpPr>
+          <p:cNvPr id="10" name="Text 8"/>
+          <p:cNvSpPr txBox="1"/>
+          <p:nvPr/>
+        </p:nvSpPr>
+        <p:spPr>
+          <a:xfrm>
+            <a:off x="6537960" y="2359152"/>
             <a:ext cx="4709160" cy="411480"/>
           </a:xfrm>
           <a:prstGeom prst="rect">
@@ -18486,46 +18525,7 @@
               <a:buNone/>
             </a:pPr>
             <a:r>
-              <a:rPr lang="en-US" sz="2000" b="1" dirty="0">
-                <a:solidFill>
-                  <a:srgbClr val="FFFFFF"/>
-                </a:solidFill>
-                <a:latin typeface="Calibri" pitchFamily="34" charset="0"/>
-                <a:ea typeface="Calibri" pitchFamily="34" charset="-122"/>
-                <a:cs typeface="Calibri" pitchFamily="34" charset="-120"/>
-              </a:rPr>
-              <a:t>Trusting the change</a:t>
-            </a:r>
-            <a:endParaRPr lang="en-US" sz="2000" dirty="0"/>
-          </a:p>
-        </p:txBody>
-      </p:sp>
-      <p:sp>
-        <p:nvSpPr>
-          <p:cNvPr id="10" name="Text 8"/>
-          <p:cNvSpPr txBox="1"/>
-          <p:nvPr/>
-        </p:nvSpPr>
-        <p:spPr>
-          <a:xfrm>
-            <a:off x="6537960" y="2606040"/>
-            <a:ext cx="4709160" cy="365760"/>
-          </a:xfrm>
-          <a:prstGeom prst="rect">
-            <a:avLst/>
-          </a:prstGeom>
-          <a:noFill/>
-          <a:ln/>
-        </p:spPr>
-        <p:txBody>
-          <a:bodyPr wrap="square" lIns="0" tIns="0" rIns="0" bIns="0" rtlCol="0" anchor="ctr"/>
-          <a:lstStyle/>
-          <a:p>
-            <a:pPr indent="0" marL="0">
-              <a:buNone/>
-            </a:pPr>
-            <a:r>
-              <a:rPr lang="en-US" sz="2200" b="1" spc="100" kern="0" dirty="0">
+              <a:rPr lang="en-US" sz="2400" b="1" spc="100" kern="0" dirty="0">
                 <a:solidFill>
                   <a:srgbClr val="FB7185"/>
                 </a:solidFill>
@@ -18533,9 +18533,9 @@
                 <a:ea typeface="Courier New" pitchFamily="34" charset="-122"/>
                 <a:cs typeface="Courier New" pitchFamily="34" charset="-120"/>
               </a:rPr>
-              <a:t>UNCHANGED</a:t>
-            </a:r>
-            <a:endParaRPr lang="en-US" sz="2200" dirty="0"/>
+              <a:t>AN HOUR</a:t>
+            </a:r>
+            <a:endParaRPr lang="en-US" sz="2400" dirty="0"/>
           </a:p>
         </p:txBody>
       </p:sp>
@@ -18547,8 +18547,86 @@
         </p:nvSpPr>
         <p:spPr>
           <a:xfrm>
-            <a:off x="6537960" y="3063240"/>
-            <a:ext cx="4709160" cy="777240"/>
+            <a:off x="6537960" y="2852928"/>
+            <a:ext cx="4709160" cy="685800"/>
+          </a:xfrm>
+          <a:prstGeom prst="rect">
+            <a:avLst/>
+          </a:prstGeom>
+          <a:noFill/>
+          <a:ln/>
+        </p:spPr>
+        <p:txBody>
+          <a:bodyPr wrap="square" lIns="0" tIns="0" rIns="0" bIns="0" rtlCol="0" anchor="ctr"/>
+          <a:lstStyle/>
+          <a:p>
+            <a:pPr indent="0" marL="0">
+              <a:buNone/>
+            </a:pPr>
+            <a:r>
+              <a:rPr lang="en-US" sz="1300" dirty="0">
+                <a:solidFill>
+                  <a:srgbClr val="C3CAD6"/>
+                </a:solidFill>
+                <a:latin typeface="Calibri" pitchFamily="34" charset="0"/>
+                <a:ea typeface="Calibri" pitchFamily="34" charset="-122"/>
+                <a:cs typeface="Calibri" pitchFamily="34" charset="-120"/>
+              </a:rPr>
+              <a:t>Same suite, same nightly run, same shrug. That cost did not move.</a:t>
+            </a:r>
+            <a:endParaRPr lang="en-US" sz="1300" dirty="0"/>
+          </a:p>
+        </p:txBody>
+      </p:sp>
+      <p:sp>
+        <p:nvSpPr>
+          <p:cNvPr id="12" name="Text 10"/>
+          <p:cNvSpPr txBox="1"/>
+          <p:nvPr/>
+        </p:nvSpPr>
+        <p:spPr>
+          <a:xfrm>
+            <a:off x="640080" y="3931920"/>
+            <a:ext cx="10881360" cy="365760"/>
+          </a:xfrm>
+          <a:prstGeom prst="rect">
+            <a:avLst/>
+          </a:prstGeom>
+          <a:noFill/>
+          <a:ln/>
+        </p:spPr>
+        <p:txBody>
+          <a:bodyPr wrap="square" lIns="0" tIns="0" rIns="0" bIns="0" rtlCol="0" anchor="ctr"/>
+          <a:lstStyle/>
+          <a:p>
+            <a:pPr indent="0" marL="0">
+              <a:buNone/>
+            </a:pPr>
+            <a:r>
+              <a:rPr lang="en-US" sz="1600" b="1" dirty="0">
+                <a:solidFill>
+                  <a:srgbClr val="F5A524"/>
+                </a:solidFill>
+                <a:latin typeface="Calibri" pitchFamily="34" charset="0"/>
+                <a:ea typeface="Calibri" pitchFamily="34" charset="-122"/>
+                <a:cs typeface="Calibri" pitchFamily="34" charset="-120"/>
+              </a:rPr>
+              <a:t>What it should cost instead</a:t>
+            </a:r>
+            <a:endParaRPr lang="en-US" sz="1600" dirty="0"/>
+          </a:p>
+        </p:txBody>
+      </p:sp>
+      <p:sp>
+        <p:nvSpPr>
+          <p:cNvPr id="13" name="Text 11"/>
+          <p:cNvSpPr txBox="1"/>
+          <p:nvPr/>
+        </p:nvSpPr>
+        <p:spPr>
+          <a:xfrm>
+            <a:off x="640080" y="4434840"/>
+            <a:ext cx="3931920" cy="384048"/>
           </a:xfrm>
           <a:prstGeom prst="rect">
             <a:avLst/>
@@ -18572,7 +18650,7 @@
                 <a:ea typeface="Calibri" pitchFamily="34" charset="-122"/>
                 <a:cs typeface="Calibri" pitchFamily="34" charset="-120"/>
               </a:rPr>
-              <a:t>Still the same slow suite, still the same nightly run, still the same shrug.</a:t>
+              <a:t>Today — every change runs everything</a:t>
             </a:r>
             <a:endParaRPr lang="en-US" sz="1400" dirty="0"/>
           </a:p>
@@ -18580,53 +18658,185 @@
       </p:sp>
       <p:sp>
         <p:nvSpPr>
-          <p:cNvPr id="12" name="Text 10"/>
-          <p:cNvSpPr txBox="1"/>
-          <p:nvPr/>
-        </p:nvSpPr>
-        <p:spPr>
-          <a:xfrm>
-            <a:off x="640080" y="4434840"/>
-            <a:ext cx="10881360" cy="457200"/>
-          </a:xfrm>
-          <a:prstGeom prst="rect">
-            <a:avLst/>
-          </a:prstGeom>
-          <a:noFill/>
-          <a:ln/>
-        </p:spPr>
-        <p:txBody>
-          <a:bodyPr wrap="square" lIns="0" tIns="0" rIns="0" bIns="0" rtlCol="0" anchor="ctr"/>
-          <a:lstStyle/>
-          <a:p>
-            <a:pPr indent="0" marL="0">
-              <a:buNone/>
-            </a:pPr>
-            <a:r>
-              <a:rPr lang="en-US" sz="1900" b="1" dirty="0">
-                <a:solidFill>
-                  <a:srgbClr val="FFFFFF"/>
-                </a:solidFill>
-                <a:latin typeface="Calibri" pitchFamily="34" charset="0"/>
-                <a:ea typeface="Calibri" pitchFamily="34" charset="-122"/>
-                <a:cs typeface="Calibri" pitchFamily="34" charset="-120"/>
-              </a:rPr>
-              <a:t>A quality gate you can run in a minute is worth more than one you can trust in principle.</a:t>
-            </a:r>
-            <a:endParaRPr lang="en-US" sz="1900" dirty="0"/>
-          </a:p>
-        </p:txBody>
-      </p:sp>
-      <p:sp>
-        <p:nvSpPr>
-          <p:cNvPr id="13" name="Text 11"/>
-          <p:cNvSpPr txBox="1"/>
-          <p:nvPr/>
-        </p:nvSpPr>
-        <p:spPr>
-          <a:xfrm>
-            <a:off x="640080" y="4983480"/>
-            <a:ext cx="10881360" cy="914400"/>
+          <p:cNvPr id="14" name="Shape 12"/>
+          <p:cNvSpPr/>
+          <p:nvPr/>
+        </p:nvSpPr>
+        <p:spPr>
+          <a:xfrm>
+            <a:off x="4754880" y="4498848"/>
+            <a:ext cx="4937760" cy="274320"/>
+          </a:xfrm>
+          <a:prstGeom prst="roundRect">
+            <a:avLst>
+              <a:gd name="adj" fmla="val 13333"/>
+            </a:avLst>
+          </a:prstGeom>
+          <a:solidFill>
+            <a:srgbClr val="F5A524"/>
+          </a:solidFill>
+          <a:ln w="12700">
+            <a:solidFill>
+              <a:srgbClr val="333333"/>
+            </a:solidFill>
+            <a:prstDash val="solid"/>
+          </a:ln>
+        </p:spPr>
+      </p:sp>
+      <p:sp>
+        <p:nvSpPr>
+          <p:cNvPr id="15" name="Text 13"/>
+          <p:cNvSpPr txBox="1"/>
+          <p:nvPr/>
+        </p:nvSpPr>
+        <p:spPr>
+          <a:xfrm>
+            <a:off x="9829800" y="4434840"/>
+            <a:ext cx="1463040" cy="384048"/>
+          </a:xfrm>
+          <a:prstGeom prst="rect">
+            <a:avLst/>
+          </a:prstGeom>
+          <a:noFill/>
+          <a:ln/>
+        </p:spPr>
+        <p:txBody>
+          <a:bodyPr wrap="square" lIns="0" tIns="0" rIns="0" bIns="0" rtlCol="0" anchor="ctr"/>
+          <a:lstStyle/>
+          <a:p>
+            <a:pPr indent="0" marL="0">
+              <a:buNone/>
+            </a:pPr>
+            <a:r>
+              <a:rPr lang="en-US" sz="1500" b="1" dirty="0">
+                <a:solidFill>
+                  <a:srgbClr val="F5A524"/>
+                </a:solidFill>
+                <a:latin typeface="Calibri" pitchFamily="34" charset="0"/>
+                <a:ea typeface="Calibri" pitchFamily="34" charset="-122"/>
+                <a:cs typeface="Calibri" pitchFamily="34" charset="-120"/>
+              </a:rPr>
+              <a:t>60 min</a:t>
+            </a:r>
+            <a:endParaRPr lang="en-US" sz="1500" dirty="0"/>
+          </a:p>
+        </p:txBody>
+      </p:sp>
+      <p:sp>
+        <p:nvSpPr>
+          <p:cNvPr id="16" name="Text 14"/>
+          <p:cNvSpPr txBox="1"/>
+          <p:nvPr/>
+        </p:nvSpPr>
+        <p:spPr>
+          <a:xfrm>
+            <a:off x="640080" y="5093208"/>
+            <a:ext cx="3931920" cy="384048"/>
+          </a:xfrm>
+          <a:prstGeom prst="rect">
+            <a:avLst/>
+          </a:prstGeom>
+          <a:noFill/>
+          <a:ln/>
+        </p:spPr>
+        <p:txBody>
+          <a:bodyPr wrap="square" lIns="0" tIns="0" rIns="0" bIns="0" rtlCol="0" anchor="ctr"/>
+          <a:lstStyle/>
+          <a:p>
+            <a:pPr indent="0" marL="0">
+              <a:buNone/>
+            </a:pPr>
+            <a:r>
+              <a:rPr lang="en-US" sz="1400" dirty="0">
+                <a:solidFill>
+                  <a:srgbClr val="C3CAD6"/>
+                </a:solidFill>
+                <a:latin typeface="Calibri" pitchFamily="34" charset="0"/>
+                <a:ea typeface="Calibri" pitchFamily="34" charset="-122"/>
+                <a:cs typeface="Calibri" pitchFamily="34" charset="-120"/>
+              </a:rPr>
+              <a:t>Target — an isolated change</a:t>
+            </a:r>
+            <a:endParaRPr lang="en-US" sz="1400" dirty="0"/>
+          </a:p>
+        </p:txBody>
+      </p:sp>
+      <p:sp>
+        <p:nvSpPr>
+          <p:cNvPr id="17" name="Shape 15"/>
+          <p:cNvSpPr/>
+          <p:nvPr/>
+        </p:nvSpPr>
+        <p:spPr>
+          <a:xfrm>
+            <a:off x="4754880" y="5157216"/>
+            <a:ext cx="822960" cy="274320"/>
+          </a:xfrm>
+          <a:prstGeom prst="roundRect">
+            <a:avLst>
+              <a:gd name="adj" fmla="val 13333"/>
+            </a:avLst>
+          </a:prstGeom>
+          <a:solidFill>
+            <a:srgbClr val="4ADE80"/>
+          </a:solidFill>
+          <a:ln w="12700">
+            <a:solidFill>
+              <a:srgbClr val="333333"/>
+            </a:solidFill>
+            <a:prstDash val="solid"/>
+          </a:ln>
+        </p:spPr>
+      </p:sp>
+      <p:sp>
+        <p:nvSpPr>
+          <p:cNvPr id="18" name="Text 16"/>
+          <p:cNvSpPr txBox="1"/>
+          <p:nvPr/>
+        </p:nvSpPr>
+        <p:spPr>
+          <a:xfrm>
+            <a:off x="5715000" y="5093208"/>
+            <a:ext cx="1463040" cy="384048"/>
+          </a:xfrm>
+          <a:prstGeom prst="rect">
+            <a:avLst/>
+          </a:prstGeom>
+          <a:noFill/>
+          <a:ln/>
+        </p:spPr>
+        <p:txBody>
+          <a:bodyPr wrap="square" lIns="0" tIns="0" rIns="0" bIns="0" rtlCol="0" anchor="ctr"/>
+          <a:lstStyle/>
+          <a:p>
+            <a:pPr indent="0" marL="0">
+              <a:buNone/>
+            </a:pPr>
+            <a:r>
+              <a:rPr lang="en-US" sz="1500" b="1" dirty="0">
+                <a:solidFill>
+                  <a:srgbClr val="4ADE80"/>
+                </a:solidFill>
+                <a:latin typeface="Calibri" pitchFamily="34" charset="0"/>
+                <a:ea typeface="Calibri" pitchFamily="34" charset="-122"/>
+                <a:cs typeface="Calibri" pitchFamily="34" charset="-120"/>
+              </a:rPr>
+              <a:t>10 min</a:t>
+            </a:r>
+            <a:endParaRPr lang="en-US" sz="1500" dirty="0"/>
+          </a:p>
+        </p:txBody>
+      </p:sp>
+      <p:sp>
+        <p:nvSpPr>
+          <p:cNvPr id="19" name="Text 17"/>
+          <p:cNvSpPr txBox="1"/>
+          <p:nvPr/>
+        </p:nvSpPr>
+        <p:spPr>
+          <a:xfrm>
+            <a:off x="640080" y="5806440"/>
+            <a:ext cx="10881360" cy="548640"/>
           </a:xfrm>
           <a:prstGeom prst="rect">
             <a:avLst/>
@@ -18650,7 +18860,7 @@
                 <a:ea typeface="Calibri" pitchFamily="34" charset="-122"/>
                 <a:cs typeface="Calibri" pitchFamily="34" charset="-120"/>
               </a:rPr>
-              <a:t>When a change costs an afternoon, a twenty-minute suite is a rounding error. When it costs four minutes, the suite is the bottleneck — and the thing standing between you and merging code you did not write line by line.</a:t>
+              <a:t>Ten minutes is a coffee. An hour is a context switch — so the suite moves to nightly, and nightly means nobody is gating on it.</a:t>
             </a:r>
             <a:endParaRPr lang="en-US" sz="1500" dirty="0"/>
           </a:p>

</xml_diff>

<commit_message>
Say what Nx is in Nx's own words, and fix the unclear stat
"1 task, before we start" explained nothing and was wrong at three apps.
It is now "3 tasks that can run them", with a caption naming the tension the
atomizer resolves: thirty spec files, three runnable tasks. Both numbers
checked against the project graph.

The Nx definition moves from a cramped side panel to a quoted strip under the
title, using the line from nx.dev rather than my paraphrase. That also frees
the full width for the dependency graph.
</commit_message>
<xml_diff>
--- a/talk/Scaling-E2E-Tests-with-Nx.pptx
+++ b/talk/Scaling-E2E-Tests-with-Nx.pptx
@@ -2639,7 +2639,7 @@
           <a:p>
             <a:r>
               <a:rPr lang="en-US" dirty="0"/>
-              <a:t>Keep this short — it is orientation, not content. The one thing to point at is that the libs are shared unevenly: formatting by shop and admin, ui by admin and docs. That asymmetry is what makes the affected demo land later. Have `nx graph` open in a tab if you would rather show the real thing.</a:t>
+              <a:t>Orientation, not content — keep it under a minute. Two things to point at. One: the libs are shared unevenly, formatting by shop and admin, ui by admin and docs, which is what makes the affected demo land later. Two: thirty spec files but only three runnable tasks, because nx e2e is one Cypress process per app. That three is the number the atomizer turns into thirty. Have `nx graph` open in a tab if you would rather show the real thing.</a:t>
             </a:r>
             <a:endParaRPr lang="en-US" dirty="0"/>
           </a:p>
@@ -18984,8 +18984,127 @@
         </p:nvSpPr>
         <p:spPr>
           <a:xfrm>
-            <a:off x="1828800" y="2743200"/>
-            <a:ext cx="1463040" cy="1051560"/>
+            <a:off x="640080" y="1572768"/>
+            <a:ext cx="10881360" cy="841248"/>
+          </a:xfrm>
+          <a:prstGeom prst="roundRect">
+            <a:avLst>
+              <a:gd name="adj" fmla="val 8696"/>
+            </a:avLst>
+          </a:prstGeom>
+          <a:solidFill>
+            <a:srgbClr val="FFFFFF"/>
+          </a:solidFill>
+          <a:ln w="12700">
+            <a:solidFill>
+              <a:srgbClr val="E2E6ED"/>
+            </a:solidFill>
+            <a:prstDash val="solid"/>
+          </a:ln>
+        </p:spPr>
+      </p:sp>
+      <p:sp>
+        <p:nvSpPr>
+          <p:cNvPr id="5" name="Text 3"/>
+          <p:cNvSpPr txBox="1"/>
+          <p:nvPr/>
+        </p:nvSpPr>
+        <p:spPr>
+          <a:xfrm>
+            <a:off x="914400" y="1691640"/>
+            <a:ext cx="10332720" cy="320040"/>
+          </a:xfrm>
+          <a:prstGeom prst="rect">
+            <a:avLst/>
+          </a:prstGeom>
+          <a:noFill/>
+          <a:ln/>
+        </p:spPr>
+        <p:txBody>
+          <a:bodyPr wrap="square" lIns="0" tIns="0" rIns="0" bIns="0" rtlCol="0" anchor="ctr"/>
+          <a:lstStyle/>
+          <a:p>
+            <a:pPr indent="0" marL="0">
+              <a:buNone/>
+            </a:pPr>
+            <a:r>
+              <a:rPr lang="en-US" sz="1500" b="1" dirty="0">
+                <a:solidFill>
+                  <a:srgbClr val="10131A"/>
+                </a:solidFill>
+                <a:latin typeface="Calibri" pitchFamily="34" charset="0"/>
+                <a:ea typeface="Calibri" pitchFamily="34" charset="-122"/>
+                <a:cs typeface="Calibri" pitchFamily="34" charset="-120"/>
+              </a:rPr>
+              <a:t>“A build system with smart caching and task orchestration.”</a:t>
+            </a:r>
+            <a:pPr indent="0" marL="0">
+              <a:buNone/>
+            </a:pPr>
+            <a:r>
+              <a:rPr lang="en-US" sz="1200" dirty="0">
+                <a:solidFill>
+                  <a:srgbClr val="8A94A6"/>
+                </a:solidFill>
+                <a:latin typeface="Calibri" pitchFamily="34" charset="0"/>
+                <a:ea typeface="Calibri" pitchFamily="34" charset="-122"/>
+                <a:cs typeface="Calibri" pitchFamily="34" charset="-120"/>
+              </a:rPr>
+              <a:t>   nx.dev</a:t>
+            </a:r>
+            <a:endParaRPr lang="en-US" sz="1500" dirty="0"/>
+          </a:p>
+        </p:txBody>
+      </p:sp>
+      <p:sp>
+        <p:nvSpPr>
+          <p:cNvPr id="6" name="Text 4"/>
+          <p:cNvSpPr txBox="1"/>
+          <p:nvPr/>
+        </p:nvSpPr>
+        <p:spPr>
+          <a:xfrm>
+            <a:off x="914400" y="2011680"/>
+            <a:ext cx="10332720" cy="320040"/>
+          </a:xfrm>
+          <a:prstGeom prst="rect">
+            <a:avLst/>
+          </a:prstGeom>
+          <a:noFill/>
+          <a:ln/>
+        </p:spPr>
+        <p:txBody>
+          <a:bodyPr wrap="square" lIns="0" tIns="0" rIns="0" bIns="0" rtlCol="0" anchor="ctr"/>
+          <a:lstStyle/>
+          <a:p>
+            <a:pPr indent="0" marL="0">
+              <a:buNone/>
+            </a:pPr>
+            <a:r>
+              <a:rPr lang="en-US" sz="1300" dirty="0">
+                <a:solidFill>
+                  <a:srgbClr val="5C6675"/>
+                </a:solidFill>
+                <a:latin typeface="Calibri" pitchFamily="34" charset="0"/>
+                <a:ea typeface="Calibri" pitchFamily="34" charset="-122"/>
+                <a:cs typeface="Calibri" pitchFamily="34" charset="-120"/>
+              </a:rPr>
+              <a:t>It knows what depends on what, so it can skip work. It does not run your tests — Cypress still does that.</a:t>
+            </a:r>
+            <a:endParaRPr lang="en-US" sz="1300" dirty="0"/>
+          </a:p>
+        </p:txBody>
+      </p:sp>
+      <p:sp>
+        <p:nvSpPr>
+          <p:cNvPr id="7" name="Shape 5"/>
+          <p:cNvSpPr/>
+          <p:nvPr/>
+        </p:nvSpPr>
+        <p:spPr>
+          <a:xfrm>
+            <a:off x="2148840" y="3364992"/>
+            <a:ext cx="1965960" cy="731520"/>
           </a:xfrm>
           <a:prstGeom prst="line">
             <a:avLst/>
@@ -19001,14 +19120,14 @@
       </p:sp>
       <p:sp>
         <p:nvSpPr>
-          <p:cNvPr id="5" name="Shape 3"/>
+          <p:cNvPr id="8" name="Shape 6"/>
           <p:cNvSpPr/>
           <p:nvPr/>
         </p:nvSpPr>
         <p:spPr>
           <a:xfrm flipH="1">
-            <a:off x="3291840" y="2743200"/>
-            <a:ext cx="1645920" cy="1051560"/>
+            <a:off x="4114800" y="3364992"/>
+            <a:ext cx="1965960" cy="731520"/>
           </a:xfrm>
           <a:prstGeom prst="line">
             <a:avLst/>
@@ -19024,14 +19143,14 @@
       </p:sp>
       <p:sp>
         <p:nvSpPr>
-          <p:cNvPr id="6" name="Shape 4"/>
+          <p:cNvPr id="9" name="Shape 7"/>
           <p:cNvSpPr/>
           <p:nvPr/>
         </p:nvSpPr>
         <p:spPr>
           <a:xfrm>
-            <a:off x="4937760" y="2743200"/>
-            <a:ext cx="1554480" cy="1051560"/>
+            <a:off x="6080760" y="3364992"/>
+            <a:ext cx="1965960" cy="731520"/>
           </a:xfrm>
           <a:prstGeom prst="line">
             <a:avLst/>
@@ -19047,14 +19166,14 @@
       </p:sp>
       <p:sp>
         <p:nvSpPr>
-          <p:cNvPr id="7" name="Shape 5"/>
+          <p:cNvPr id="10" name="Shape 8"/>
           <p:cNvSpPr/>
           <p:nvPr/>
         </p:nvSpPr>
         <p:spPr>
           <a:xfrm flipH="1">
-            <a:off x="6492240" y="2743200"/>
-            <a:ext cx="1554480" cy="1051560"/>
+            <a:off x="8046720" y="3364992"/>
+            <a:ext cx="1965960" cy="731520"/>
           </a:xfrm>
           <a:prstGeom prst="line">
             <a:avLst/>
@@ -19070,14 +19189,53 @@
       </p:sp>
       <p:sp>
         <p:nvSpPr>
-          <p:cNvPr id="8" name="Shape 6"/>
+          <p:cNvPr id="11" name="Text 9"/>
+          <p:cNvSpPr txBox="1"/>
+          <p:nvPr/>
+        </p:nvSpPr>
+        <p:spPr>
+          <a:xfrm>
+            <a:off x="822960" y="2395728"/>
+            <a:ext cx="2651760" cy="256032"/>
+          </a:xfrm>
+          <a:prstGeom prst="rect">
+            <a:avLst/>
+          </a:prstGeom>
+          <a:noFill/>
+          <a:ln/>
+        </p:spPr>
+        <p:txBody>
+          <a:bodyPr wrap="square" lIns="0" tIns="0" rIns="0" bIns="0" rtlCol="0" anchor="ctr"/>
+          <a:lstStyle/>
+          <a:p>
+            <a:pPr algn="ctr" indent="0" marL="0">
+              <a:buNone/>
+            </a:pPr>
+            <a:r>
+              <a:rPr lang="en-US" sz="1200" dirty="0">
+                <a:solidFill>
+                  <a:srgbClr val="8A94A6"/>
+                </a:solidFill>
+                <a:latin typeface="Calibri" pitchFamily="34" charset="0"/>
+                <a:ea typeface="Calibri" pitchFamily="34" charset="-122"/>
+                <a:cs typeface="Calibri" pitchFamily="34" charset="-120"/>
+              </a:rPr>
+              <a:t>10 specs</a:t>
+            </a:r>
+            <a:endParaRPr lang="en-US" sz="1200" dirty="0"/>
+          </a:p>
+        </p:txBody>
+      </p:sp>
+      <p:sp>
+        <p:nvSpPr>
+          <p:cNvPr id="12" name="Shape 10"/>
           <p:cNvSpPr/>
           <p:nvPr/>
         </p:nvSpPr>
         <p:spPr>
           <a:xfrm>
-            <a:off x="685800" y="2057400"/>
-            <a:ext cx="2286000" cy="685800"/>
+            <a:off x="822960" y="2679192"/>
+            <a:ext cx="2651760" cy="685800"/>
           </a:xfrm>
           <a:prstGeom prst="roundRect">
             <a:avLst>
@@ -19097,14 +19255,14 @@
       </p:sp>
       <p:sp>
         <p:nvSpPr>
-          <p:cNvPr id="9" name="Text 7"/>
-          <p:cNvSpPr txBox="1"/>
-          <p:nvPr/>
-        </p:nvSpPr>
-        <p:spPr>
-          <a:xfrm>
-            <a:off x="685800" y="2057400"/>
-            <a:ext cx="2286000" cy="685800"/>
+          <p:cNvPr id="13" name="Text 11"/>
+          <p:cNvSpPr txBox="1"/>
+          <p:nvPr/>
+        </p:nvSpPr>
+        <p:spPr>
+          <a:xfrm>
+            <a:off x="822960" y="2679192"/>
+            <a:ext cx="2651760" cy="685800"/>
           </a:xfrm>
           <a:prstGeom prst="rect">
             <a:avLst/>
@@ -19136,14 +19294,14 @@
       </p:sp>
       <p:sp>
         <p:nvSpPr>
-          <p:cNvPr id="10" name="Text 8"/>
-          <p:cNvSpPr txBox="1"/>
-          <p:nvPr/>
-        </p:nvSpPr>
-        <p:spPr>
-          <a:xfrm>
-            <a:off x="685800" y="1755648"/>
-            <a:ext cx="2286000" cy="274320"/>
+          <p:cNvPr id="14" name="Text 12"/>
+          <p:cNvSpPr txBox="1"/>
+          <p:nvPr/>
+        </p:nvSpPr>
+        <p:spPr>
+          <a:xfrm>
+            <a:off x="4754880" y="2395728"/>
+            <a:ext cx="2651760" cy="256032"/>
           </a:xfrm>
           <a:prstGeom prst="rect">
             <a:avLst/>
@@ -19175,14 +19333,14 @@
       </p:sp>
       <p:sp>
         <p:nvSpPr>
-          <p:cNvPr id="11" name="Shape 9"/>
+          <p:cNvPr id="15" name="Shape 13"/>
           <p:cNvSpPr/>
           <p:nvPr/>
         </p:nvSpPr>
         <p:spPr>
           <a:xfrm>
-            <a:off x="3794760" y="2057400"/>
-            <a:ext cx="2286000" cy="685800"/>
+            <a:off x="4754880" y="2679192"/>
+            <a:ext cx="2651760" cy="685800"/>
           </a:xfrm>
           <a:prstGeom prst="roundRect">
             <a:avLst>
@@ -19202,14 +19360,14 @@
       </p:sp>
       <p:sp>
         <p:nvSpPr>
-          <p:cNvPr id="12" name="Text 10"/>
-          <p:cNvSpPr txBox="1"/>
-          <p:nvPr/>
-        </p:nvSpPr>
-        <p:spPr>
-          <a:xfrm>
-            <a:off x="3794760" y="2057400"/>
-            <a:ext cx="2286000" cy="685800"/>
+          <p:cNvPr id="16" name="Text 14"/>
+          <p:cNvSpPr txBox="1"/>
+          <p:nvPr/>
+        </p:nvSpPr>
+        <p:spPr>
+          <a:xfrm>
+            <a:off x="4754880" y="2679192"/>
+            <a:ext cx="2651760" cy="685800"/>
           </a:xfrm>
           <a:prstGeom prst="rect">
             <a:avLst/>
@@ -19241,14 +19399,14 @@
       </p:sp>
       <p:sp>
         <p:nvSpPr>
-          <p:cNvPr id="13" name="Text 11"/>
-          <p:cNvSpPr txBox="1"/>
-          <p:nvPr/>
-        </p:nvSpPr>
-        <p:spPr>
-          <a:xfrm>
-            <a:off x="3794760" y="1755648"/>
-            <a:ext cx="2286000" cy="274320"/>
+          <p:cNvPr id="17" name="Text 15"/>
+          <p:cNvSpPr txBox="1"/>
+          <p:nvPr/>
+        </p:nvSpPr>
+        <p:spPr>
+          <a:xfrm>
+            <a:off x="8686800" y="2395728"/>
+            <a:ext cx="2651760" cy="256032"/>
           </a:xfrm>
           <a:prstGeom prst="rect">
             <a:avLst/>
@@ -19280,14 +19438,14 @@
       </p:sp>
       <p:sp>
         <p:nvSpPr>
-          <p:cNvPr id="14" name="Shape 12"/>
+          <p:cNvPr id="18" name="Shape 16"/>
           <p:cNvSpPr/>
           <p:nvPr/>
         </p:nvSpPr>
         <p:spPr>
           <a:xfrm>
-            <a:off x="6903720" y="2057400"/>
-            <a:ext cx="2286000" cy="685800"/>
+            <a:off x="8686800" y="2679192"/>
+            <a:ext cx="2651760" cy="685800"/>
           </a:xfrm>
           <a:prstGeom prst="roundRect">
             <a:avLst>
@@ -19307,14 +19465,14 @@
       </p:sp>
       <p:sp>
         <p:nvSpPr>
-          <p:cNvPr id="15" name="Text 13"/>
-          <p:cNvSpPr txBox="1"/>
-          <p:nvPr/>
-        </p:nvSpPr>
-        <p:spPr>
-          <a:xfrm>
-            <a:off x="6903720" y="2057400"/>
-            <a:ext cx="2286000" cy="685800"/>
+          <p:cNvPr id="19" name="Text 17"/>
+          <p:cNvSpPr txBox="1"/>
+          <p:nvPr/>
+        </p:nvSpPr>
+        <p:spPr>
+          <a:xfrm>
+            <a:off x="8686800" y="2679192"/>
+            <a:ext cx="2651760" cy="685800"/>
           </a:xfrm>
           <a:prstGeom prst="rect">
             <a:avLst/>
@@ -19346,53 +19504,14 @@
       </p:sp>
       <p:sp>
         <p:nvSpPr>
-          <p:cNvPr id="16" name="Text 14"/>
-          <p:cNvSpPr txBox="1"/>
-          <p:nvPr/>
-        </p:nvSpPr>
-        <p:spPr>
-          <a:xfrm>
-            <a:off x="6903720" y="1755648"/>
-            <a:ext cx="2286000" cy="274320"/>
-          </a:xfrm>
-          <a:prstGeom prst="rect">
-            <a:avLst/>
-          </a:prstGeom>
-          <a:noFill/>
-          <a:ln/>
-        </p:spPr>
-        <p:txBody>
-          <a:bodyPr wrap="square" lIns="0" tIns="0" rIns="0" bIns="0" rtlCol="0" anchor="ctr"/>
-          <a:lstStyle/>
-          <a:p>
-            <a:pPr algn="ctr" indent="0" marL="0">
-              <a:buNone/>
-            </a:pPr>
-            <a:r>
-              <a:rPr lang="en-US" sz="1200" dirty="0">
-                <a:solidFill>
-                  <a:srgbClr val="8A94A6"/>
-                </a:solidFill>
-                <a:latin typeface="Calibri" pitchFamily="34" charset="0"/>
-                <a:ea typeface="Calibri" pitchFamily="34" charset="-122"/>
-                <a:cs typeface="Calibri" pitchFamily="34" charset="-120"/>
-              </a:rPr>
-              <a:t>10 specs</a:t>
-            </a:r>
-            <a:endParaRPr lang="en-US" sz="1200" dirty="0"/>
-          </a:p>
-        </p:txBody>
-      </p:sp>
-      <p:sp>
-        <p:nvSpPr>
-          <p:cNvPr id="17" name="Shape 15"/>
+          <p:cNvPr id="20" name="Shape 18"/>
           <p:cNvSpPr/>
           <p:nvPr/>
         </p:nvSpPr>
         <p:spPr>
           <a:xfrm>
-            <a:off x="2148840" y="3794760"/>
-            <a:ext cx="2286000" cy="640080"/>
+            <a:off x="2788920" y="4096512"/>
+            <a:ext cx="2651760" cy="640080"/>
           </a:xfrm>
           <a:prstGeom prst="roundRect">
             <a:avLst>
@@ -19412,14 +19531,14 @@
       </p:sp>
       <p:sp>
         <p:nvSpPr>
-          <p:cNvPr id="18" name="Text 16"/>
-          <p:cNvSpPr txBox="1"/>
-          <p:nvPr/>
-        </p:nvSpPr>
-        <p:spPr>
-          <a:xfrm>
-            <a:off x="2148840" y="3794760"/>
-            <a:ext cx="2286000" cy="640080"/>
+          <p:cNvPr id="21" name="Text 19"/>
+          <p:cNvSpPr txBox="1"/>
+          <p:nvPr/>
+        </p:nvSpPr>
+        <p:spPr>
+          <a:xfrm>
+            <a:off x="2788920" y="4096512"/>
+            <a:ext cx="2651760" cy="640080"/>
           </a:xfrm>
           <a:prstGeom prst="rect">
             <a:avLst/>
@@ -19451,14 +19570,14 @@
       </p:sp>
       <p:sp>
         <p:nvSpPr>
-          <p:cNvPr id="19" name="Shape 17"/>
+          <p:cNvPr id="22" name="Shape 20"/>
           <p:cNvSpPr/>
           <p:nvPr/>
         </p:nvSpPr>
         <p:spPr>
           <a:xfrm>
-            <a:off x="5349240" y="3794760"/>
-            <a:ext cx="2286000" cy="640080"/>
+            <a:off x="6720840" y="4096512"/>
+            <a:ext cx="2651760" cy="640080"/>
           </a:xfrm>
           <a:prstGeom prst="roundRect">
             <a:avLst>
@@ -19478,14 +19597,14 @@
       </p:sp>
       <p:sp>
         <p:nvSpPr>
-          <p:cNvPr id="20" name="Text 18"/>
-          <p:cNvSpPr txBox="1"/>
-          <p:nvPr/>
-        </p:nvSpPr>
-        <p:spPr>
-          <a:xfrm>
-            <a:off x="5349240" y="3794760"/>
-            <a:ext cx="2286000" cy="640080"/>
+          <p:cNvPr id="23" name="Text 21"/>
+          <p:cNvSpPr txBox="1"/>
+          <p:nvPr/>
+        </p:nvSpPr>
+        <p:spPr>
+          <a:xfrm>
+            <a:off x="6720840" y="4096512"/>
+            <a:ext cx="2651760" cy="640080"/>
           </a:xfrm>
           <a:prstGeom prst="rect">
             <a:avLst/>
@@ -19517,14 +19636,14 @@
       </p:sp>
       <p:sp>
         <p:nvSpPr>
-          <p:cNvPr id="21" name="Text 19"/>
-          <p:cNvSpPr txBox="1"/>
-          <p:nvPr/>
-        </p:nvSpPr>
-        <p:spPr>
-          <a:xfrm>
-            <a:off x="685800" y="3931920"/>
-            <a:ext cx="1280160" cy="365760"/>
+          <p:cNvPr id="24" name="Text 22"/>
+          <p:cNvSpPr txBox="1"/>
+          <p:nvPr/>
+        </p:nvSpPr>
+        <p:spPr>
+          <a:xfrm>
+            <a:off x="822960" y="4096512"/>
+            <a:ext cx="1783080" cy="640080"/>
           </a:xfrm>
           <a:prstGeom prst="rect">
             <a:avLst/>
@@ -19556,18 +19675,18 @@
       </p:sp>
       <p:sp>
         <p:nvSpPr>
-          <p:cNvPr id="22" name="Shape 20"/>
+          <p:cNvPr id="25" name="Shape 23"/>
           <p:cNvSpPr/>
           <p:nvPr/>
         </p:nvSpPr>
         <p:spPr>
           <a:xfrm>
-            <a:off x="9418320" y="1783080"/>
-            <a:ext cx="2103120" cy="2743200"/>
+            <a:off x="640080" y="4983480"/>
+            <a:ext cx="3429000" cy="1051560"/>
           </a:xfrm>
           <a:prstGeom prst="roundRect">
             <a:avLst>
-              <a:gd name="adj" fmla="val 3478"/>
+              <a:gd name="adj" fmla="val 7826"/>
             </a:avLst>
           </a:prstGeom>
           <a:solidFill>
@@ -19583,72 +19702,69 @@
       </p:sp>
       <p:sp>
         <p:nvSpPr>
-          <p:cNvPr id="23" name="Text 21"/>
-          <p:cNvSpPr txBox="1"/>
-          <p:nvPr/>
-        </p:nvSpPr>
-        <p:spPr>
-          <a:xfrm>
-            <a:off x="9646920" y="1965960"/>
-            <a:ext cx="1691640" cy="320040"/>
-          </a:xfrm>
-          <a:prstGeom prst="rect">
-            <a:avLst/>
-          </a:prstGeom>
-          <a:noFill/>
-          <a:ln/>
-        </p:spPr>
-        <p:txBody>
-          <a:bodyPr wrap="square" lIns="0" tIns="0" rIns="0" bIns="0" rtlCol="0" anchor="ctr"/>
-          <a:lstStyle/>
-          <a:p>
-            <a:pPr indent="0" marL="0">
-              <a:buNone/>
-            </a:pPr>
-            <a:r>
-              <a:rPr lang="en-US" sz="1500" b="1" dirty="0">
-                <a:solidFill>
-                  <a:srgbClr val="10131A"/>
-                </a:solidFill>
-                <a:latin typeface="Calibri" pitchFamily="34" charset="0"/>
-                <a:ea typeface="Calibri" pitchFamily="34" charset="-122"/>
-                <a:cs typeface="Calibri" pitchFamily="34" charset="-120"/>
-              </a:rPr>
-              <a:t>What Nx is</a:t>
-            </a:r>
-            <a:endParaRPr lang="en-US" sz="1500" dirty="0"/>
-          </a:p>
-        </p:txBody>
-      </p:sp>
-      <p:sp>
-        <p:nvSpPr>
-          <p:cNvPr id="24" name="Text 22"/>
-          <p:cNvSpPr txBox="1"/>
-          <p:nvPr/>
-        </p:nvSpPr>
-        <p:spPr>
-          <a:xfrm>
-            <a:off x="9646920" y="2331720"/>
-            <a:ext cx="1691640" cy="2103120"/>
-          </a:xfrm>
-          <a:prstGeom prst="rect">
-            <a:avLst/>
-          </a:prstGeom>
-          <a:noFill/>
-          <a:ln/>
-        </p:spPr>
-        <p:txBody>
-          <a:bodyPr wrap="square" lIns="0" tIns="0" rIns="0" bIns="0" rtlCol="0" anchor="t"/>
-          <a:lstStyle/>
-          <a:p>
-            <a:pPr indent="0" marL="0">
-              <a:spcAft>
-                <a:spcPts val="800"/>
-              </a:spcAft>
-              <a:buNone/>
-            </a:pPr>
-            <a:r>
-              <a:rPr lang="en-US" sz="1200" dirty="0">
+          <p:cNvPr id="26" name="Text 24"/>
+          <p:cNvSpPr txBox="1"/>
+          <p:nvPr/>
+        </p:nvSpPr>
+        <p:spPr>
+          <a:xfrm>
+            <a:off x="868680" y="5120640"/>
+            <a:ext cx="2971800" cy="548640"/>
+          </a:xfrm>
+          <a:prstGeom prst="rect">
+            <a:avLst/>
+          </a:prstGeom>
+          <a:noFill/>
+          <a:ln/>
+        </p:spPr>
+        <p:txBody>
+          <a:bodyPr wrap="square" lIns="0" tIns="0" rIns="0" bIns="0" rtlCol="0" anchor="ctr"/>
+          <a:lstStyle/>
+          <a:p>
+            <a:pPr indent="0" marL="0">
+              <a:buNone/>
+            </a:pPr>
+            <a:r>
+              <a:rPr lang="en-US" sz="3000" b="1" dirty="0">
+                <a:solidFill>
+                  <a:srgbClr val="0B7A44"/>
+                </a:solidFill>
+                <a:latin typeface="Cambria" pitchFamily="34" charset="0"/>
+                <a:ea typeface="Cambria" pitchFamily="34" charset="-122"/>
+                <a:cs typeface="Cambria" pitchFamily="34" charset="-120"/>
+              </a:rPr>
+              <a:t>30</a:t>
+            </a:r>
+            <a:endParaRPr lang="en-US" sz="3000" dirty="0"/>
+          </a:p>
+        </p:txBody>
+      </p:sp>
+      <p:sp>
+        <p:nvSpPr>
+          <p:cNvPr id="27" name="Text 25"/>
+          <p:cNvSpPr txBox="1"/>
+          <p:nvPr/>
+        </p:nvSpPr>
+        <p:spPr>
+          <a:xfrm>
+            <a:off x="868680" y="5650992"/>
+            <a:ext cx="2971800" cy="301752"/>
+          </a:xfrm>
+          <a:prstGeom prst="rect">
+            <a:avLst/>
+          </a:prstGeom>
+          <a:noFill/>
+          <a:ln/>
+        </p:spPr>
+        <p:txBody>
+          <a:bodyPr wrap="square" lIns="0" tIns="0" rIns="0" bIns="0" rtlCol="0" anchor="ctr"/>
+          <a:lstStyle/>
+          <a:p>
+            <a:pPr indent="0" marL="0">
+              <a:buNone/>
+            </a:pPr>
+            <a:r>
+              <a:rPr lang="en-US" sz="1300" dirty="0">
                 <a:solidFill>
                   <a:srgbClr val="5C6675"/>
                 </a:solidFill>
@@ -19656,63 +19772,26 @@
                 <a:ea typeface="Calibri" pitchFamily="34" charset="-122"/>
                 <a:cs typeface="Calibri" pitchFamily="34" charset="-120"/>
               </a:rPr>
-              <a:t>A task graph over your repo.</a:t>
-            </a:r>
-            <a:endParaRPr lang="en-US" sz="1200" dirty="0"/>
-          </a:p>
-          <a:p>
-            <a:pPr indent="0" marL="0">
-              <a:spcAft>
-                <a:spcPts val="800"/>
-              </a:spcAft>
-              <a:buNone/>
-            </a:pPr>
-            <a:r>
-              <a:rPr lang="en-US" sz="1200" dirty="0">
-                <a:solidFill>
-                  <a:srgbClr val="5C6675"/>
-                </a:solidFill>
-                <a:latin typeface="Calibri" pitchFamily="34" charset="0"/>
-                <a:ea typeface="Calibri" pitchFamily="34" charset="-122"/>
-                <a:cs typeface="Calibri" pitchFamily="34" charset="-120"/>
-              </a:rPr>
-              <a:t>It knows what depends on what, runs tasks in the right order, and caches the results.</a:t>
-            </a:r>
-            <a:endParaRPr lang="en-US" sz="1200" dirty="0"/>
-          </a:p>
-          <a:p>
-            <a:pPr indent="0" marL="0">
-              <a:buNone/>
-            </a:pPr>
-            <a:r>
-              <a:rPr lang="en-US" sz="1200" dirty="0">
-                <a:solidFill>
-                  <a:srgbClr val="5C6675"/>
-                </a:solidFill>
-                <a:latin typeface="Calibri" pitchFamily="34" charset="0"/>
-                <a:ea typeface="Calibri" pitchFamily="34" charset="-122"/>
-                <a:cs typeface="Calibri" pitchFamily="34" charset="-120"/>
-              </a:rPr>
-              <a:t>It is not a test runner. Cypress still runs the tests.</a:t>
-            </a:r>
-            <a:endParaRPr lang="en-US" sz="1200" dirty="0"/>
-          </a:p>
-        </p:txBody>
-      </p:sp>
-      <p:sp>
-        <p:nvSpPr>
-          <p:cNvPr id="25" name="Shape 23"/>
+              <a:t>spec files</a:t>
+            </a:r>
+            <a:endParaRPr lang="en-US" sz="1300" dirty="0"/>
+          </a:p>
+        </p:txBody>
+      </p:sp>
+      <p:sp>
+        <p:nvSpPr>
+          <p:cNvPr id="28" name="Shape 26"/>
           <p:cNvSpPr/>
           <p:nvPr/>
         </p:nvSpPr>
         <p:spPr>
           <a:xfrm>
-            <a:off x="640080" y="4846320"/>
-            <a:ext cx="3429000" cy="1234440"/>
+            <a:off x="4343400" y="4983480"/>
+            <a:ext cx="3429000" cy="1051560"/>
           </a:xfrm>
           <a:prstGeom prst="roundRect">
             <a:avLst>
-              <a:gd name="adj" fmla="val 6667"/>
+              <a:gd name="adj" fmla="val 7826"/>
             </a:avLst>
           </a:prstGeom>
           <a:solidFill>
@@ -19728,69 +19807,69 @@
       </p:sp>
       <p:sp>
         <p:nvSpPr>
-          <p:cNvPr id="26" name="Text 24"/>
-          <p:cNvSpPr txBox="1"/>
-          <p:nvPr/>
-        </p:nvSpPr>
-        <p:spPr>
-          <a:xfrm>
-            <a:off x="868680" y="5010912"/>
-            <a:ext cx="2971800" cy="603504"/>
-          </a:xfrm>
-          <a:prstGeom prst="rect">
-            <a:avLst/>
-          </a:prstGeom>
-          <a:noFill/>
-          <a:ln/>
-        </p:spPr>
-        <p:txBody>
-          <a:bodyPr wrap="square" lIns="0" tIns="0" rIns="0" bIns="0" rtlCol="0" anchor="ctr"/>
-          <a:lstStyle/>
-          <a:p>
-            <a:pPr indent="0" marL="0">
-              <a:buNone/>
-            </a:pPr>
-            <a:r>
-              <a:rPr lang="en-US" sz="3200" b="1" dirty="0">
-                <a:solidFill>
-                  <a:srgbClr val="0B7A44"/>
+          <p:cNvPr id="29" name="Text 27"/>
+          <p:cNvSpPr txBox="1"/>
+          <p:nvPr/>
+        </p:nvSpPr>
+        <p:spPr>
+          <a:xfrm>
+            <a:off x="4572000" y="5120640"/>
+            <a:ext cx="2971800" cy="548640"/>
+          </a:xfrm>
+          <a:prstGeom prst="rect">
+            <a:avLst/>
+          </a:prstGeom>
+          <a:noFill/>
+          <a:ln/>
+        </p:spPr>
+        <p:txBody>
+          <a:bodyPr wrap="square" lIns="0" tIns="0" rIns="0" bIns="0" rtlCol="0" anchor="ctr"/>
+          <a:lstStyle/>
+          <a:p>
+            <a:pPr indent="0" marL="0">
+              <a:buNone/>
+            </a:pPr>
+            <a:r>
+              <a:rPr lang="en-US" sz="3000" b="1" dirty="0">
+                <a:solidFill>
+                  <a:srgbClr val="10131A"/>
                 </a:solidFill>
                 <a:latin typeface="Cambria" pitchFamily="34" charset="0"/>
                 <a:ea typeface="Cambria" pitchFamily="34" charset="-122"/>
                 <a:cs typeface="Cambria" pitchFamily="34" charset="-120"/>
               </a:rPr>
-              <a:t>30</a:t>
-            </a:r>
-            <a:endParaRPr lang="en-US" sz="3200" dirty="0"/>
-          </a:p>
-        </p:txBody>
-      </p:sp>
-      <p:sp>
-        <p:nvSpPr>
-          <p:cNvPr id="27" name="Text 25"/>
-          <p:cNvSpPr txBox="1"/>
-          <p:nvPr/>
-        </p:nvSpPr>
-        <p:spPr>
-          <a:xfrm>
-            <a:off x="868680" y="5614416"/>
-            <a:ext cx="2971800" cy="320040"/>
-          </a:xfrm>
-          <a:prstGeom prst="rect">
-            <a:avLst/>
-          </a:prstGeom>
-          <a:noFill/>
-          <a:ln/>
-        </p:spPr>
-        <p:txBody>
-          <a:bodyPr wrap="square" lIns="0" tIns="0" rIns="0" bIns="0" rtlCol="0" anchor="ctr"/>
-          <a:lstStyle/>
-          <a:p>
-            <a:pPr indent="0" marL="0">
-              <a:buNone/>
-            </a:pPr>
-            <a:r>
-              <a:rPr lang="en-US" sz="1400" dirty="0">
+              <a:t>202</a:t>
+            </a:r>
+            <a:endParaRPr lang="en-US" sz="3000" dirty="0"/>
+          </a:p>
+        </p:txBody>
+      </p:sp>
+      <p:sp>
+        <p:nvSpPr>
+          <p:cNvPr id="30" name="Text 28"/>
+          <p:cNvSpPr txBox="1"/>
+          <p:nvPr/>
+        </p:nvSpPr>
+        <p:spPr>
+          <a:xfrm>
+            <a:off x="4572000" y="5650992"/>
+            <a:ext cx="2971800" cy="301752"/>
+          </a:xfrm>
+          <a:prstGeom prst="rect">
+            <a:avLst/>
+          </a:prstGeom>
+          <a:noFill/>
+          <a:ln/>
+        </p:spPr>
+        <p:txBody>
+          <a:bodyPr wrap="square" lIns="0" tIns="0" rIns="0" bIns="0" rtlCol="0" anchor="ctr"/>
+          <a:lstStyle/>
+          <a:p>
+            <a:pPr indent="0" marL="0">
+              <a:buNone/>
+            </a:pPr>
+            <a:r>
+              <a:rPr lang="en-US" sz="1300" dirty="0">
                 <a:solidFill>
                   <a:srgbClr val="5C6675"/>
                 </a:solidFill>
@@ -19798,26 +19877,26 @@
                 <a:ea typeface="Calibri" pitchFamily="34" charset="-122"/>
                 <a:cs typeface="Calibri" pitchFamily="34" charset="-120"/>
               </a:rPr>
-              <a:t>spec files</a:t>
-            </a:r>
-            <a:endParaRPr lang="en-US" sz="1400" dirty="0"/>
-          </a:p>
-        </p:txBody>
-      </p:sp>
-      <p:sp>
-        <p:nvSpPr>
-          <p:cNvPr id="28" name="Shape 26"/>
+              <a:t>tests</a:t>
+            </a:r>
+            <a:endParaRPr lang="en-US" sz="1300" dirty="0"/>
+          </a:p>
+        </p:txBody>
+      </p:sp>
+      <p:sp>
+        <p:nvSpPr>
+          <p:cNvPr id="31" name="Shape 29"/>
           <p:cNvSpPr/>
           <p:nvPr/>
         </p:nvSpPr>
         <p:spPr>
           <a:xfrm>
-            <a:off x="4343400" y="4846320"/>
-            <a:ext cx="3429000" cy="1234440"/>
+            <a:off x="8046720" y="4983480"/>
+            <a:ext cx="3429000" cy="1051560"/>
           </a:xfrm>
           <a:prstGeom prst="roundRect">
             <a:avLst>
-              <a:gd name="adj" fmla="val 6667"/>
+              <a:gd name="adj" fmla="val 7826"/>
             </a:avLst>
           </a:prstGeom>
           <a:solidFill>
@@ -19833,69 +19912,69 @@
       </p:sp>
       <p:sp>
         <p:nvSpPr>
-          <p:cNvPr id="29" name="Text 27"/>
-          <p:cNvSpPr txBox="1"/>
-          <p:nvPr/>
-        </p:nvSpPr>
-        <p:spPr>
-          <a:xfrm>
-            <a:off x="4572000" y="5010912"/>
-            <a:ext cx="2971800" cy="603504"/>
-          </a:xfrm>
-          <a:prstGeom prst="rect">
-            <a:avLst/>
-          </a:prstGeom>
-          <a:noFill/>
-          <a:ln/>
-        </p:spPr>
-        <p:txBody>
-          <a:bodyPr wrap="square" lIns="0" tIns="0" rIns="0" bIns="0" rtlCol="0" anchor="ctr"/>
-          <a:lstStyle/>
-          <a:p>
-            <a:pPr indent="0" marL="0">
-              <a:buNone/>
-            </a:pPr>
-            <a:r>
-              <a:rPr lang="en-US" sz="3200" b="1" dirty="0">
-                <a:solidFill>
-                  <a:srgbClr val="10131A"/>
+          <p:cNvPr id="32" name="Text 30"/>
+          <p:cNvSpPr txBox="1"/>
+          <p:nvPr/>
+        </p:nvSpPr>
+        <p:spPr>
+          <a:xfrm>
+            <a:off x="8275320" y="5120640"/>
+            <a:ext cx="2971800" cy="548640"/>
+          </a:xfrm>
+          <a:prstGeom prst="rect">
+            <a:avLst/>
+          </a:prstGeom>
+          <a:noFill/>
+          <a:ln/>
+        </p:spPr>
+        <p:txBody>
+          <a:bodyPr wrap="square" lIns="0" tIns="0" rIns="0" bIns="0" rtlCol="0" anchor="ctr"/>
+          <a:lstStyle/>
+          <a:p>
+            <a:pPr indent="0" marL="0">
+              <a:buNone/>
+            </a:pPr>
+            <a:r>
+              <a:rPr lang="en-US" sz="3000" b="1" dirty="0">
+                <a:solidFill>
+                  <a:srgbClr val="B45309"/>
                 </a:solidFill>
                 <a:latin typeface="Cambria" pitchFamily="34" charset="0"/>
                 <a:ea typeface="Cambria" pitchFamily="34" charset="-122"/>
                 <a:cs typeface="Cambria" pitchFamily="34" charset="-120"/>
               </a:rPr>
-              <a:t>202</a:t>
-            </a:r>
-            <a:endParaRPr lang="en-US" sz="3200" dirty="0"/>
-          </a:p>
-        </p:txBody>
-      </p:sp>
-      <p:sp>
-        <p:nvSpPr>
-          <p:cNvPr id="30" name="Text 28"/>
-          <p:cNvSpPr txBox="1"/>
-          <p:nvPr/>
-        </p:nvSpPr>
-        <p:spPr>
-          <a:xfrm>
-            <a:off x="4572000" y="5614416"/>
-            <a:ext cx="2971800" cy="320040"/>
-          </a:xfrm>
-          <a:prstGeom prst="rect">
-            <a:avLst/>
-          </a:prstGeom>
-          <a:noFill/>
-          <a:ln/>
-        </p:spPr>
-        <p:txBody>
-          <a:bodyPr wrap="square" lIns="0" tIns="0" rIns="0" bIns="0" rtlCol="0" anchor="ctr"/>
-          <a:lstStyle/>
-          <a:p>
-            <a:pPr indent="0" marL="0">
-              <a:buNone/>
-            </a:pPr>
-            <a:r>
-              <a:rPr lang="en-US" sz="1400" dirty="0">
+              <a:t>3</a:t>
+            </a:r>
+            <a:endParaRPr lang="en-US" sz="3000" dirty="0"/>
+          </a:p>
+        </p:txBody>
+      </p:sp>
+      <p:sp>
+        <p:nvSpPr>
+          <p:cNvPr id="33" name="Text 31"/>
+          <p:cNvSpPr txBox="1"/>
+          <p:nvPr/>
+        </p:nvSpPr>
+        <p:spPr>
+          <a:xfrm>
+            <a:off x="8275320" y="5650992"/>
+            <a:ext cx="2971800" cy="301752"/>
+          </a:xfrm>
+          <a:prstGeom prst="rect">
+            <a:avLst/>
+          </a:prstGeom>
+          <a:noFill/>
+          <a:ln/>
+        </p:spPr>
+        <p:txBody>
+          <a:bodyPr wrap="square" lIns="0" tIns="0" rIns="0" bIns="0" rtlCol="0" anchor="ctr"/>
+          <a:lstStyle/>
+          <a:p>
+            <a:pPr indent="0" marL="0">
+              <a:buNone/>
+            </a:pPr>
+            <a:r>
+              <a:rPr lang="en-US" sz="1300" dirty="0">
                 <a:solidFill>
                   <a:srgbClr val="5C6675"/>
                 </a:solidFill>
@@ -19903,104 +19982,38 @@
                 <a:ea typeface="Calibri" pitchFamily="34" charset="-122"/>
                 <a:cs typeface="Calibri" pitchFamily="34" charset="-120"/>
               </a:rPr>
-              <a:t>tests</a:t>
-            </a:r>
-            <a:endParaRPr lang="en-US" sz="1400" dirty="0"/>
-          </a:p>
-        </p:txBody>
-      </p:sp>
-      <p:sp>
-        <p:nvSpPr>
-          <p:cNvPr id="31" name="Shape 29"/>
-          <p:cNvSpPr/>
-          <p:nvPr/>
-        </p:nvSpPr>
-        <p:spPr>
-          <a:xfrm>
-            <a:off x="8046720" y="4846320"/>
-            <a:ext cx="3429000" cy="1234440"/>
-          </a:xfrm>
-          <a:prstGeom prst="roundRect">
-            <a:avLst>
-              <a:gd name="adj" fmla="val 6667"/>
-            </a:avLst>
-          </a:prstGeom>
-          <a:solidFill>
-            <a:srgbClr val="FFFFFF"/>
-          </a:solidFill>
-          <a:ln w="12700">
-            <a:solidFill>
-              <a:srgbClr val="E2E6ED"/>
-            </a:solidFill>
-            <a:prstDash val="solid"/>
-          </a:ln>
-        </p:spPr>
-      </p:sp>
-      <p:sp>
-        <p:nvSpPr>
-          <p:cNvPr id="32" name="Text 30"/>
-          <p:cNvSpPr txBox="1"/>
-          <p:nvPr/>
-        </p:nvSpPr>
-        <p:spPr>
-          <a:xfrm>
-            <a:off x="8275320" y="5010912"/>
-            <a:ext cx="2971800" cy="603504"/>
-          </a:xfrm>
-          <a:prstGeom prst="rect">
-            <a:avLst/>
-          </a:prstGeom>
-          <a:noFill/>
-          <a:ln/>
-        </p:spPr>
-        <p:txBody>
-          <a:bodyPr wrap="square" lIns="0" tIns="0" rIns="0" bIns="0" rtlCol="0" anchor="ctr"/>
-          <a:lstStyle/>
-          <a:p>
-            <a:pPr indent="0" marL="0">
-              <a:buNone/>
-            </a:pPr>
-            <a:r>
-              <a:rPr lang="en-US" sz="3200" b="1" dirty="0">
-                <a:solidFill>
-                  <a:srgbClr val="B45309"/>
-                </a:solidFill>
-                <a:latin typeface="Cambria" pitchFamily="34" charset="0"/>
-                <a:ea typeface="Cambria" pitchFamily="34" charset="-122"/>
-                <a:cs typeface="Cambria" pitchFamily="34" charset="-120"/>
-              </a:rPr>
-              <a:t>1</a:t>
-            </a:r>
-            <a:endParaRPr lang="en-US" sz="3200" dirty="0"/>
-          </a:p>
-        </p:txBody>
-      </p:sp>
-      <p:sp>
-        <p:nvSpPr>
-          <p:cNvPr id="33" name="Text 31"/>
-          <p:cNvSpPr txBox="1"/>
-          <p:nvPr/>
-        </p:nvSpPr>
-        <p:spPr>
-          <a:xfrm>
-            <a:off x="8275320" y="5614416"/>
-            <a:ext cx="2971800" cy="320040"/>
-          </a:xfrm>
-          <a:prstGeom prst="rect">
-            <a:avLst/>
-          </a:prstGeom>
-          <a:noFill/>
-          <a:ln/>
-        </p:spPr>
-        <p:txBody>
-          <a:bodyPr wrap="square" lIns="0" tIns="0" rIns="0" bIns="0" rtlCol="0" anchor="ctr"/>
-          <a:lstStyle/>
-          <a:p>
-            <a:pPr indent="0" marL="0">
-              <a:buNone/>
-            </a:pPr>
-            <a:r>
-              <a:rPr lang="en-US" sz="1400" dirty="0">
+              <a:t>tasks that can run them</a:t>
+            </a:r>
+            <a:endParaRPr lang="en-US" sz="1300" dirty="0"/>
+          </a:p>
+        </p:txBody>
+      </p:sp>
+      <p:sp>
+        <p:nvSpPr>
+          <p:cNvPr id="34" name="Text 32"/>
+          <p:cNvSpPr txBox="1"/>
+          <p:nvPr/>
+        </p:nvSpPr>
+        <p:spPr>
+          <a:xfrm>
+            <a:off x="640080" y="6144768"/>
+            <a:ext cx="10881360" cy="365760"/>
+          </a:xfrm>
+          <a:prstGeom prst="rect">
+            <a:avLst/>
+          </a:prstGeom>
+          <a:noFill/>
+          <a:ln/>
+        </p:spPr>
+        <p:txBody>
+          <a:bodyPr wrap="square" lIns="0" tIns="0" rIns="0" bIns="0" rtlCol="0" anchor="ctr"/>
+          <a:lstStyle/>
+          <a:p>
+            <a:pPr indent="0" marL="0">
+              <a:buNone/>
+            </a:pPr>
+            <a:r>
+              <a:rPr lang="en-US" sz="1400" i="1" dirty="0">
                 <a:solidFill>
                   <a:srgbClr val="5C6675"/>
                 </a:solidFill>
@@ -20008,7 +20021,7 @@
                 <a:ea typeface="Calibri" pitchFamily="34" charset="-122"/>
                 <a:cs typeface="Calibri" pitchFamily="34" charset="-120"/>
               </a:rPr>
-              <a:t>task, before we start</a:t>
+              <a:t>Thirty files, but only three things you can actually run — one e2e task per app. Closing that gap is the rest of the talk.</a:t>
             </a:r>
             <a:endParaRPr lang="en-US" sz="1400" dirty="0"/>
           </a:p>

</xml_diff>

<commit_message>
Fold Q&A and the thank-you into one closing slide
One slide to leave up for the whole close, with just the feedback QR. The
prompt topics move into the speaker notes — they were useful to have ready but
did not need to be on screen while people are asking their own questions.
</commit_message>
<xml_diff>
--- a/talk/Scaling-E2E-Tests-with-Nx.pptx
+++ b/talk/Scaling-E2E-Tests-with-Nx.pptx
@@ -30,10 +30,9 @@
     <p:sldId id="278" r:id="rId24"/>
     <p:sldId id="279" r:id="rId25"/>
     <p:sldId id="280" r:id="rId26"/>
-    <p:sldId id="281" r:id="rId27"/>
   </p:sldIdLst>
   <p:notesMasterIdLst>
-    <p:notesMasterId r:id="rId28"/>
+    <p:notesMasterId r:id="rId27"/>
   </p:notesMasterIdLst>
   <p:sldSz cx="12192000" cy="6858000"/>
   <p:notesSz cx="6858000" cy="12192000"/>
@@ -1847,7 +1846,7 @@
           <a:p>
             <a:r>
               <a:rPr lang="en-US" dirty="0"/>
-              <a:t>Leave this up for the whole Q&amp;A. The bullet list is a prompt for the room when nobody wants to go first.</a:t>
+              <a:t>One slide for the whole close. Put it up before the first question so the QR is on screen for the entire Q&amp;A — that is when people actually scan it. The recap is there for the room to read, not for you to read out. If nobody opens, the honest prompts are the Nx Cloud gate, Playwright instead of Cypress, and what the cache does and does not do for flaky tests.</a:t>
             </a:r>
             <a:endParaRPr lang="en-US" dirty="0"/>
           </a:p>
@@ -1935,7 +1934,7 @@
           <a:p>
             <a:r>
               <a:rPr lang="en-US" dirty="0"/>
-              <a:t>Put this up while you answer the last question so people can scan it before they stand. Read the recap only if the room is still settling; otherwise let them read it.</a:t>
+              <a:t>Skip past this unless someone asks. The gotchas slide behind it is the one people photograph.</a:t>
             </a:r>
             <a:endParaRPr lang="en-US" dirty="0"/>
           </a:p>
@@ -2023,7 +2022,7 @@
           <a:p>
             <a:r>
               <a:rPr lang="en-US" dirty="0"/>
-              <a:t>Skip past this unless someone asks. The gotchas slide behind it is the one people photograph.</a:t>
+              <a:t>Good slide to leave up during questions. Items 3 and 4 both bit this repo on its first CI run — worth telling as war stories rather than reading out.</a:t>
             </a:r>
             <a:endParaRPr lang="en-US" dirty="0"/>
           </a:p>
@@ -2047,94 +2046,6 @@
             <a:fld id="{F7021451-1387-4CA6-816F-3879F97B5CBC}" type="slidenum">
               <a:rPr lang="en-US"/>
               <a:t>25</a:t>
-            </a:fld>
-            <a:endParaRPr lang="en-US"/>
-          </a:p>
-        </p:txBody>
-      </p:sp>
-    </p:spTree>
-    <p:extLst>
-      <p:ext uri="{BB962C8B-B14F-4D97-AF65-F5344CB8AC3E}">
-        <p14:creationId xmlns:p14="http://schemas.microsoft.com/office/powerpoint/2010/main" val="1024086991"/>
-      </p:ext>
-    </p:extLst>
-  </p:cSld>
-  <p:clrMapOvr>
-    <a:masterClrMapping/>
-  </p:clrMapOvr>
-</p:notes>
-</file>
-
-<file path=ppt/notesSlides/notesSlide26.xml><?xml version="1.0" encoding="utf-8"?>
-<p:notes xmlns:a="http://schemas.openxmlformats.org/drawingml/2006/main" xmlns:r="http://schemas.openxmlformats.org/officeDocument/2006/relationships" xmlns:p="http://schemas.openxmlformats.org/presentationml/2006/main">
-  <p:cSld>
-    <p:spTree>
-      <p:nvGrpSpPr>
-        <p:cNvPr id="1" name=""/>
-        <p:cNvGrpSpPr/>
-        <p:nvPr/>
-      </p:nvGrpSpPr>
-      <p:grpSpPr>
-        <a:xfrm>
-          <a:off x="0" y="0"/>
-          <a:ext cx="0" cy="0"/>
-          <a:chOff x="0" y="0"/>
-          <a:chExt cx="0" cy="0"/>
-        </a:xfrm>
-      </p:grpSpPr>
-      <p:sp>
-        <p:nvSpPr>
-          <p:cNvPr id="2" name="Slide Image Placeholder 1"/>
-          <p:cNvSpPr>
-            <a:spLocks noGrp="1" noRot="1" noChangeAspect="1"/>
-          </p:cNvSpPr>
-          <p:nvPr>
-            <p:ph type="sldImg"/>
-          </p:nvPr>
-        </p:nvSpPr>
-        <p:spPr/>
-      </p:sp>
-      <p:sp>
-        <p:nvSpPr>
-          <p:cNvPr id="3" name="Notes Placeholder 2"/>
-          <p:cNvSpPr>
-            <a:spLocks noGrp="1"/>
-          </p:cNvSpPr>
-          <p:nvPr>
-            <p:ph type="body" idx="1"/>
-          </p:nvPr>
-        </p:nvSpPr>
-        <p:spPr/>
-        <p:txBody>
-          <a:bodyPr/>
-          <a:lstStyle/>
-          <a:p>
-            <a:r>
-              <a:rPr lang="en-US" dirty="0"/>
-              <a:t>Good slide to leave up during questions. Items 3 and 4 both bit this repo on its first CI run — worth telling as war stories rather than reading out.</a:t>
-            </a:r>
-            <a:endParaRPr lang="en-US" dirty="0"/>
-          </a:p>
-        </p:txBody>
-      </p:sp>
-      <p:sp>
-        <p:nvSpPr>
-          <p:cNvPr id="4" name="Slide Number Placeholder 3"/>
-          <p:cNvSpPr>
-            <a:spLocks noGrp="1"/>
-          </p:cNvSpPr>
-          <p:nvPr>
-            <p:ph type="sldNum" sz="quarter" idx="10"/>
-          </p:nvPr>
-        </p:nvSpPr>
-        <p:spPr/>
-        <p:txBody>
-          <a:bodyPr/>
-          <a:lstStyle/>
-          <a:p>
-            <a:fld id="{F7021451-1387-4CA6-816F-3879F97B5CBC}" type="slidenum">
-              <a:rPr lang="en-US"/>
-              <a:t>26</a:t>
             </a:fld>
             <a:endParaRPr lang="en-US"/>
           </a:p>
@@ -13883,411 +13794,6 @@
     <p:bg>
       <p:bgPr>
         <a:solidFill>
-          <a:srgbClr val="10131A"/>
-        </a:solidFill>
-      </p:bgPr>
-    </p:bg>
-    <p:spTree>
-      <p:nvGrpSpPr>
-        <p:cNvPr id="1" name=""/>
-        <p:cNvGrpSpPr/>
-        <p:nvPr/>
-      </p:nvGrpSpPr>
-      <p:grpSpPr>
-        <a:xfrm>
-          <a:off x="0" y="0"/>
-          <a:ext cx="0" cy="0"/>
-          <a:chOff x="0" y="0"/>
-          <a:chExt cx="0" cy="0"/>
-        </a:xfrm>
-      </p:grpSpPr>
-      <p:sp>
-        <p:nvSpPr>
-          <p:cNvPr id="2" name="Text 0"/>
-          <p:cNvSpPr txBox="1"/>
-          <p:nvPr/>
-        </p:nvSpPr>
-        <p:spPr>
-          <a:xfrm>
-            <a:off x="640080" y="411480"/>
-            <a:ext cx="10881360" cy="274320"/>
-          </a:xfrm>
-          <a:prstGeom prst="rect">
-            <a:avLst/>
-          </a:prstGeom>
-          <a:noFill/>
-          <a:ln/>
-        </p:spPr>
-        <p:txBody>
-          <a:bodyPr wrap="square" lIns="0" tIns="0" rIns="0" bIns="0" rtlCol="0" anchor="ctr"/>
-          <a:lstStyle/>
-          <a:p>
-            <a:pPr indent="0" marL="0">
-              <a:buNone/>
-            </a:pPr>
-            <a:r>
-              <a:rPr lang="en-US" sz="1200" b="1" spc="250" kern="0" dirty="0">
-                <a:solidFill>
-                  <a:srgbClr val="4ADE80"/>
-                </a:solidFill>
-                <a:latin typeface="Calibri" pitchFamily="34" charset="0"/>
-                <a:ea typeface="Calibri" pitchFamily="34" charset="-122"/>
-                <a:cs typeface="Calibri" pitchFamily="34" charset="-120"/>
-              </a:rPr>
-              <a:t>QUESTIONS</a:t>
-            </a:r>
-            <a:endParaRPr lang="en-US" sz="1200" dirty="0"/>
-          </a:p>
-        </p:txBody>
-      </p:sp>
-      <p:sp>
-        <p:nvSpPr>
-          <p:cNvPr id="3" name="Text 1"/>
-          <p:cNvSpPr txBox="1"/>
-          <p:nvPr/>
-        </p:nvSpPr>
-        <p:spPr>
-          <a:xfrm>
-            <a:off x="640080" y="749808"/>
-            <a:ext cx="10881360" cy="731520"/>
-          </a:xfrm>
-          <a:prstGeom prst="rect">
-            <a:avLst/>
-          </a:prstGeom>
-          <a:noFill/>
-          <a:ln/>
-        </p:spPr>
-        <p:txBody>
-          <a:bodyPr wrap="square" lIns="0" tIns="0" rIns="0" bIns="0" rtlCol="0" anchor="ctr"/>
-          <a:lstStyle/>
-          <a:p>
-            <a:pPr indent="0" marL="0">
-              <a:buNone/>
-            </a:pPr>
-            <a:r>
-              <a:rPr lang="en-US" sz="3800" b="1" dirty="0">
-                <a:solidFill>
-                  <a:srgbClr val="FFFFFF"/>
-                </a:solidFill>
-                <a:latin typeface="Cambria" pitchFamily="34" charset="0"/>
-                <a:ea typeface="Cambria" pitchFamily="34" charset="-122"/>
-                <a:cs typeface="Cambria" pitchFamily="34" charset="-120"/>
-              </a:rPr>
-              <a:t>Q&amp;A</a:t>
-            </a:r>
-            <a:endParaRPr lang="en-US" sz="3800" dirty="0"/>
-          </a:p>
-        </p:txBody>
-      </p:sp>
-      <p:sp>
-        <p:nvSpPr>
-          <p:cNvPr id="4" name="Text 2"/>
-          <p:cNvSpPr txBox="1"/>
-          <p:nvPr/>
-        </p:nvSpPr>
-        <p:spPr>
-          <a:xfrm>
-            <a:off x="640080" y="2011680"/>
-            <a:ext cx="6949440" cy="365760"/>
-          </a:xfrm>
-          <a:prstGeom prst="rect">
-            <a:avLst/>
-          </a:prstGeom>
-          <a:noFill/>
-          <a:ln/>
-        </p:spPr>
-        <p:txBody>
-          <a:bodyPr wrap="square" lIns="0" tIns="0" rIns="0" bIns="0" rtlCol="0" anchor="ctr"/>
-          <a:lstStyle/>
-          <a:p>
-            <a:pPr indent="0" marL="0">
-              <a:buNone/>
-            </a:pPr>
-            <a:r>
-              <a:rPr lang="en-US" sz="1500" dirty="0">
-                <a:solidFill>
-                  <a:srgbClr val="C3CAD6"/>
-                </a:solidFill>
-                <a:latin typeface="Calibri" pitchFamily="34" charset="0"/>
-                <a:ea typeface="Calibri" pitchFamily="34" charset="-122"/>
-                <a:cs typeface="Calibri" pitchFamily="34" charset="-120"/>
-              </a:rPr>
-              <a:t>Things I am happy to go deeper on:</a:t>
-            </a:r>
-            <a:endParaRPr lang="en-US" sz="1500" dirty="0"/>
-          </a:p>
-        </p:txBody>
-      </p:sp>
-      <p:sp>
-        <p:nvSpPr>
-          <p:cNvPr id="5" name="Text 3"/>
-          <p:cNvSpPr txBox="1"/>
-          <p:nvPr/>
-        </p:nvSpPr>
-        <p:spPr>
-          <a:xfrm>
-            <a:off x="640080" y="2468880"/>
-            <a:ext cx="6949440" cy="2743200"/>
-          </a:xfrm>
-          <a:prstGeom prst="rect">
-            <a:avLst/>
-          </a:prstGeom>
-          <a:noFill/>
-          <a:ln/>
-        </p:spPr>
-        <p:txBody>
-          <a:bodyPr wrap="square" lIns="0" tIns="0" rIns="0" bIns="0" rtlCol="0" anchor="t"/>
-          <a:lstStyle/>
-          <a:p>
-            <a:pPr marL="342900" indent="-342900">
-              <a:spcAft>
-                <a:spcPts val="1000"/>
-              </a:spcAft>
-              <a:buSzPct val="100000"/>
-              <a:buChar char="•"/>
-            </a:pPr>
-            <a:r>
-              <a:rPr lang="en-US" sz="1500" dirty="0">
-                <a:solidFill>
-                  <a:srgbClr val="C3CAD6"/>
-                </a:solidFill>
-                <a:latin typeface="Calibri" pitchFamily="34" charset="0"/>
-                <a:ea typeface="Calibri" pitchFamily="34" charset="-122"/>
-                <a:cs typeface="Calibri" pitchFamily="34" charset="-120"/>
-              </a:rPr>
-              <a:t>Why the Nx Cloud gate exists, and whether to just pay for it</a:t>
-            </a:r>
-            <a:endParaRPr lang="en-US" sz="1500" dirty="0"/>
-          </a:p>
-          <a:p>
-            <a:pPr marL="342900" indent="-342900">
-              <a:spcAft>
-                <a:spcPts val="1000"/>
-              </a:spcAft>
-              <a:buSzPct val="100000"/>
-              <a:buChar char="•"/>
-            </a:pPr>
-            <a:r>
-              <a:rPr lang="en-US" sz="1500" dirty="0">
-                <a:solidFill>
-                  <a:srgbClr val="C3CAD6"/>
-                </a:solidFill>
-                <a:latin typeface="Calibri" pitchFamily="34" charset="0"/>
-                <a:ea typeface="Calibri" pitchFamily="34" charset="-122"/>
-                <a:cs typeface="Calibri" pitchFamily="34" charset="-120"/>
-              </a:rPr>
-              <a:t>Making this work with Playwright instead of Cypress</a:t>
-            </a:r>
-            <a:endParaRPr lang="en-US" sz="1500" dirty="0"/>
-          </a:p>
-          <a:p>
-            <a:pPr marL="342900" indent="-342900">
-              <a:spcAft>
-                <a:spcPts val="1000"/>
-              </a:spcAft>
-              <a:buSzPct val="100000"/>
-              <a:buChar char="•"/>
-            </a:pPr>
-            <a:r>
-              <a:rPr lang="en-US" sz="1500" dirty="0">
-                <a:solidFill>
-                  <a:srgbClr val="C3CAD6"/>
-                </a:solidFill>
-                <a:latin typeface="Calibri" pitchFamily="34" charset="0"/>
-                <a:ea typeface="Calibri" pitchFamily="34" charset="-122"/>
-                <a:cs typeface="Calibri" pitchFamily="34" charset="-120"/>
-              </a:rPr>
-              <a:t>Flaky tests — what the cache does and does not fix</a:t>
-            </a:r>
-            <a:endParaRPr lang="en-US" sz="1500" dirty="0"/>
-          </a:p>
-          <a:p>
-            <a:pPr marL="342900" indent="-342900">
-              <a:spcAft>
-                <a:spcPts val="1000"/>
-              </a:spcAft>
-              <a:buSzPct val="100000"/>
-              <a:buChar char="•"/>
-            </a:pPr>
-            <a:r>
-              <a:rPr lang="en-US" sz="1500" dirty="0">
-                <a:solidFill>
-                  <a:srgbClr val="C3CAD6"/>
-                </a:solidFill>
-                <a:latin typeface="Calibri" pitchFamily="34" charset="0"/>
-                <a:ea typeface="Calibri" pitchFamily="34" charset="-122"/>
-                <a:cs typeface="Calibri" pitchFamily="34" charset="-120"/>
-              </a:rPr>
-              <a:t>Sharding a single app that dominates the critical path</a:t>
-            </a:r>
-            <a:endParaRPr lang="en-US" sz="1500" dirty="0"/>
-          </a:p>
-          <a:p>
-            <a:pPr marL="342900" indent="-342900">
-              <a:spcAft>
-                <a:spcPts val="1000"/>
-              </a:spcAft>
-              <a:buSzPct val="100000"/>
-              <a:buChar char="•"/>
-            </a:pPr>
-            <a:r>
-              <a:rPr lang="en-US" sz="1500" dirty="0">
-                <a:solidFill>
-                  <a:srgbClr val="C3CAD6"/>
-                </a:solidFill>
-                <a:latin typeface="Calibri" pitchFamily="34" charset="0"/>
-                <a:ea typeface="Calibri" pitchFamily="34" charset="-122"/>
-                <a:cs typeface="Calibri" pitchFamily="34" charset="-120"/>
-              </a:rPr>
-              <a:t>What it took to review 1,000 tests without stopping delivery</a:t>
-            </a:r>
-            <a:endParaRPr lang="en-US" sz="1500" dirty="0"/>
-          </a:p>
-        </p:txBody>
-      </p:sp>
-      <p:sp>
-        <p:nvSpPr>
-          <p:cNvPr id="6" name="Shape 4"/>
-          <p:cNvSpPr/>
-          <p:nvPr/>
-        </p:nvSpPr>
-        <p:spPr>
-          <a:xfrm>
-            <a:off x="8778240" y="2011680"/>
-            <a:ext cx="2468880" cy="2468880"/>
-          </a:xfrm>
-          <a:prstGeom prst="roundRect">
-            <a:avLst>
-              <a:gd name="adj" fmla="val 2222"/>
-            </a:avLst>
-          </a:prstGeom>
-          <a:solidFill>
-            <a:srgbClr val="FFFFFF"/>
-          </a:solidFill>
-          <a:ln w="12700">
-            <a:solidFill>
-              <a:srgbClr val="333333"/>
-            </a:solidFill>
-            <a:prstDash val="solid"/>
-          </a:ln>
-        </p:spPr>
-      </p:sp>
-      <p:pic>
-        <p:nvPicPr>
-          <p:cNvPr id="7" name="Image 0" descr="/Users/vra/IdeaProjects/nx-scaling-e2e-tests-with-atomizer/talk/assets/qr-repo.png">    </p:cNvPr>
-          <p:cNvPicPr>
-            <a:picLocks noChangeAspect="1"/>
-          </p:cNvPicPr>
-          <p:nvPr/>
-        </p:nvPicPr>
-        <p:blipFill>
-          <a:blip r:embed="rId1"/>
-          <a:stretch>
-            <a:fillRect/>
-          </a:stretch>
-        </p:blipFill>
-        <p:spPr>
-          <a:xfrm>
-            <a:off x="8897112" y="2130552"/>
-            <a:ext cx="2231136" cy="2231136"/>
-          </a:xfrm>
-          <a:prstGeom prst="rect">
-            <a:avLst/>
-          </a:prstGeom>
-        </p:spPr>
-      </p:pic>
-      <p:sp>
-        <p:nvSpPr>
-          <p:cNvPr id="8" name="Text 5"/>
-          <p:cNvSpPr txBox="1"/>
-          <p:nvPr/>
-        </p:nvSpPr>
-        <p:spPr>
-          <a:xfrm>
-            <a:off x="8778240" y="4608576"/>
-            <a:ext cx="2468880" cy="320040"/>
-          </a:xfrm>
-          <a:prstGeom prst="rect">
-            <a:avLst/>
-          </a:prstGeom>
-          <a:noFill/>
-          <a:ln/>
-        </p:spPr>
-        <p:txBody>
-          <a:bodyPr wrap="square" lIns="0" tIns="0" rIns="0" bIns="0" rtlCol="0" anchor="ctr"/>
-          <a:lstStyle/>
-          <a:p>
-            <a:pPr algn="ctr" indent="0" marL="0">
-              <a:buNone/>
-            </a:pPr>
-            <a:r>
-              <a:rPr lang="en-US" sz="1200" dirty="0">
-                <a:solidFill>
-                  <a:srgbClr val="8A94A6"/>
-                </a:solidFill>
-                <a:latin typeface="Calibri" pitchFamily="34" charset="0"/>
-                <a:ea typeface="Calibri" pitchFamily="34" charset="-122"/>
-                <a:cs typeface="Calibri" pitchFamily="34" charset="-120"/>
-              </a:rPr>
-              <a:t>The repo</a:t>
-            </a:r>
-            <a:endParaRPr lang="en-US" sz="1200" dirty="0"/>
-          </a:p>
-        </p:txBody>
-      </p:sp>
-      <p:sp>
-        <p:nvSpPr>
-          <p:cNvPr id="9" name="Text 6"/>
-          <p:cNvSpPr txBox="1"/>
-          <p:nvPr/>
-        </p:nvSpPr>
-        <p:spPr>
-          <a:xfrm>
-            <a:off x="640080" y="5669280"/>
-            <a:ext cx="10881360" cy="365760"/>
-          </a:xfrm>
-          <a:prstGeom prst="rect">
-            <a:avLst/>
-          </a:prstGeom>
-          <a:noFill/>
-          <a:ln/>
-        </p:spPr>
-        <p:txBody>
-          <a:bodyPr wrap="square" lIns="0" tIns="0" rIns="0" bIns="0" rtlCol="0" anchor="ctr"/>
-          <a:lstStyle/>
-          <a:p>
-            <a:pPr indent="0" marL="0">
-              <a:buNone/>
-            </a:pPr>
-            <a:r>
-              <a:rPr lang="en-US" sz="1300" dirty="0">
-                <a:solidFill>
-                  <a:srgbClr val="8A94A6"/>
-                </a:solidFill>
-                <a:latin typeface="Courier New" pitchFamily="34" charset="0"/>
-                <a:ea typeface="Courier New" pitchFamily="34" charset="-122"/>
-                <a:cs typeface="Courier New" pitchFamily="34" charset="-120"/>
-              </a:rPr>
-              <a:t>github.com/radzivil/nx-scaling-e2e-tests-with-atomizer</a:t>
-            </a:r>
-            <a:endParaRPr lang="en-US" sz="1300" dirty="0"/>
-          </a:p>
-        </p:txBody>
-      </p:sp>
-    </p:spTree>
-  </p:cSld>
-  <p:clrMapOvr>
-    <a:masterClrMapping/>
-  </p:clrMapOvr>
-</p:sld>
-</file>
-
-<file path=ppt/slides/slide24.xml><?xml version="1.0" encoding="utf-8"?>
-<p:sld xmlns:a="http://schemas.openxmlformats.org/drawingml/2006/main" xmlns:r="http://schemas.openxmlformats.org/officeDocument/2006/relationships" xmlns:p="http://schemas.openxmlformats.org/presentationml/2006/main">
-  <p:cSld name="Slide 24">
-    <p:bg>
-      <p:bgPr>
-        <a:solidFill>
           <a:srgbClr val="F7F8FA"/>
         </a:solidFill>
       </p:bgPr>
@@ -14378,7 +13884,7 @@
                 <a:ea typeface="Cambria" pitchFamily="34" charset="-122"/>
                 <a:cs typeface="Cambria" pitchFamily="34" charset="-120"/>
               </a:rPr>
-              <a:t>How was it?</a:t>
+              <a:t>Feedback &amp; Q&amp;A</a:t>
             </a:r>
             <a:endParaRPr lang="en-US" sz="3800" dirty="0"/>
           </a:p>
@@ -14392,8 +13898,8 @@
         </p:nvSpPr>
         <p:spPr>
           <a:xfrm>
-            <a:off x="640080" y="1965960"/>
-            <a:ext cx="6766560" cy="457200"/>
+            <a:off x="640080" y="1874520"/>
+            <a:ext cx="7223760" cy="457200"/>
           </a:xfrm>
           <a:prstGeom prst="rect">
             <a:avLst/>
@@ -14417,7 +13923,7 @@
                 <a:ea typeface="Calibri" pitchFamily="34" charset="-122"/>
                 <a:cs typeface="Calibri" pitchFamily="34" charset="-120"/>
               </a:rPr>
-              <a:t>Two minutes of feedback makes the next one better.</a:t>
+              <a:t>Take a minute to give your feedback — it makes the next session better.</a:t>
             </a:r>
             <a:endParaRPr lang="en-US" sz="1900" dirty="0"/>
           </a:p>
@@ -14431,8 +13937,8 @@
         </p:nvSpPr>
         <p:spPr>
           <a:xfrm>
-            <a:off x="640080" y="2697480"/>
-            <a:ext cx="6766560" cy="320040"/>
+            <a:off x="640080" y="2651760"/>
+            <a:ext cx="7223760" cy="320040"/>
           </a:xfrm>
           <a:prstGeom prst="rect">
             <a:avLst/>
@@ -14470,8 +13976,8 @@
         </p:nvSpPr>
         <p:spPr>
           <a:xfrm>
-            <a:off x="640080" y="3108960"/>
-            <a:ext cx="6766560" cy="2377440"/>
+            <a:off x="640080" y="3063240"/>
+            <a:ext cx="7223760" cy="2377440"/>
           </a:xfrm>
           <a:prstGeom prst="rect">
             <a:avLst/>
@@ -14597,12 +14103,12 @@
         </p:nvSpPr>
         <p:spPr>
           <a:xfrm>
-            <a:off x="8321040" y="1920240"/>
-            <a:ext cx="2926080" cy="2926080"/>
+            <a:off x="8412480" y="1874520"/>
+            <a:ext cx="2834640" cy="2834640"/>
           </a:xfrm>
           <a:prstGeom prst="roundRect">
             <a:avLst>
-              <a:gd name="adj" fmla="val 1875"/>
+              <a:gd name="adj" fmla="val 1935"/>
             </a:avLst>
           </a:prstGeom>
           <a:solidFill>
@@ -14632,8 +14138,8 @@
         </p:blipFill>
         <p:spPr>
           <a:xfrm>
-            <a:off x="8439912" y="2039112"/>
-            <a:ext cx="2688336" cy="2688336"/>
+            <a:off x="8531352" y="1993392"/>
+            <a:ext cx="2596896" cy="2596896"/>
           </a:xfrm>
           <a:prstGeom prst="rect">
             <a:avLst/>
@@ -14648,8 +14154,8 @@
         </p:nvSpPr>
         <p:spPr>
           <a:xfrm>
-            <a:off x="8321040" y="4974336"/>
-            <a:ext cx="2926080" cy="320040"/>
+            <a:off x="8412480" y="4837176"/>
+            <a:ext cx="2834640" cy="320040"/>
           </a:xfrm>
           <a:prstGeom prst="rect">
             <a:avLst/>
@@ -14688,33 +14194,72 @@
         <p:spPr>
           <a:xfrm>
             <a:off x="640080" y="5806440"/>
-            <a:ext cx="10881360" cy="365760"/>
-          </a:xfrm>
-          <a:prstGeom prst="rect">
-            <a:avLst/>
-          </a:prstGeom>
-          <a:noFill/>
-          <a:ln/>
-        </p:spPr>
-        <p:txBody>
-          <a:bodyPr wrap="square" lIns="0" tIns="0" rIns="0" bIns="0" rtlCol="0" anchor="ctr"/>
-          <a:lstStyle/>
-          <a:p>
-            <a:pPr indent="0" marL="0">
-              <a:buNone/>
-            </a:pPr>
-            <a:r>
-              <a:rPr lang="en-US" sz="1400" dirty="0">
+            <a:ext cx="7223760" cy="320040"/>
+          </a:xfrm>
+          <a:prstGeom prst="rect">
+            <a:avLst/>
+          </a:prstGeom>
+          <a:noFill/>
+          <a:ln/>
+        </p:spPr>
+        <p:txBody>
+          <a:bodyPr wrap="square" lIns="0" tIns="0" rIns="0" bIns="0" rtlCol="0" anchor="ctr"/>
+          <a:lstStyle/>
+          <a:p>
+            <a:pPr indent="0" marL="0">
+              <a:buNone/>
+            </a:pPr>
+            <a:r>
+              <a:rPr lang="en-US" sz="1300" dirty="0">
                 <a:solidFill>
                   <a:srgbClr val="5C6675"/>
                 </a:solidFill>
+                <a:latin typeface="Courier New" pitchFamily="34" charset="0"/>
+                <a:ea typeface="Courier New" pitchFamily="34" charset="-122"/>
+                <a:cs typeface="Courier New" pitchFamily="34" charset="-120"/>
+              </a:rPr>
+              <a:t>github.com/radzivil/nx-scaling-e2e-tests-with-atomizer</a:t>
+            </a:r>
+            <a:endParaRPr lang="en-US" sz="1300" dirty="0"/>
+          </a:p>
+        </p:txBody>
+      </p:sp>
+      <p:sp>
+        <p:nvSpPr>
+          <p:cNvPr id="11" name="Text 8"/>
+          <p:cNvSpPr txBox="1"/>
+          <p:nvPr/>
+        </p:nvSpPr>
+        <p:spPr>
+          <a:xfrm>
+            <a:off x="640080" y="6144768"/>
+            <a:ext cx="7223760" cy="320040"/>
+          </a:xfrm>
+          <a:prstGeom prst="rect">
+            <a:avLst/>
+          </a:prstGeom>
+          <a:noFill/>
+          <a:ln/>
+        </p:spPr>
+        <p:txBody>
+          <a:bodyPr wrap="square" lIns="0" tIns="0" rIns="0" bIns="0" rtlCol="0" anchor="ctr"/>
+          <a:lstStyle/>
+          <a:p>
+            <a:pPr indent="0" marL="0">
+              <a:buNone/>
+            </a:pPr>
+            <a:r>
+              <a:rPr lang="en-US" sz="1300" dirty="0">
+                <a:solidFill>
+                  <a:srgbClr val="8A94A6"/>
+                </a:solidFill>
                 <a:latin typeface="Calibri" pitchFamily="34" charset="0"/>
                 <a:ea typeface="Calibri" pitchFamily="34" charset="-122"/>
                 <a:cs typeface="Calibri" pitchFamily="34" charset="-120"/>
               </a:rPr>
               <a:t>Vladimir Radzivil · linkedin.com/in/vladimirradzivil</a:t>
             </a:r>
-            <a:endParaRPr lang="en-US" sz="1400" dirty="0"/>
+            <a:endParaRPr lang="en-US" sz="1300" dirty="0"/>
           </a:p>
         </p:txBody>
       </p:sp>
@@ -14726,9 +14271,9 @@
 </p:sld>
 </file>
 
-<file path=ppt/slides/slide25.xml><?xml version="1.0" encoding="utf-8"?>
+<file path=ppt/slides/slide24.xml><?xml version="1.0" encoding="utf-8"?>
 <p:sld xmlns:a="http://schemas.openxmlformats.org/drawingml/2006/main" xmlns:r="http://schemas.openxmlformats.org/officeDocument/2006/relationships" xmlns:p="http://schemas.openxmlformats.org/presentationml/2006/main">
-  <p:cSld name="Slide 25">
+  <p:cSld name="Slide 24">
     <p:bg>
       <p:bgPr>
         <a:solidFill>
@@ -14836,9 +14381,9 @@
 </p:sld>
 </file>
 
-<file path=ppt/slides/slide26.xml><?xml version="1.0" encoding="utf-8"?>
+<file path=ppt/slides/slide25.xml><?xml version="1.0" encoding="utf-8"?>
 <p:sld xmlns:a="http://schemas.openxmlformats.org/drawingml/2006/main" xmlns:r="http://schemas.openxmlformats.org/officeDocument/2006/relationships" xmlns:p="http://schemas.openxmlformats.org/presentationml/2006/main">
-  <p:cSld name="Slide 26">
+  <p:cSld name="Slide 25">
     <p:bg>
       <p:bgPr>
         <a:solidFill>

</xml_diff>

<commit_message>
Put the exact demo commands in the speaker notes
Thirteen slides now carry the commands to run while they are up, with the
expected output and measured timing. They live in a DEMO map next to the slides
rather than a separate runbook, so the two cannot drift apart.

Every command was run against this repo to confirm it works and that the
quoted timings hold: cold parallel 40-46s, replay 134ms, seeded failure 39s
then 28s on retry, revert 206ms.

Also updates the Nx Cloud gate slide — with three apps the error is now the
plural form listing all three e2e-ci tasks, not the single-app wording.
</commit_message>
<xml_diff>
--- a/talk/Scaling-E2E-Tests-with-Nx.pptx
+++ b/talk/Scaling-E2E-Tests-with-Nx.pptx
@@ -526,7 +526,13 @@
           <a:p>
             <a:r>
               <a:rPr lang="en-US" dirty="0"/>
-              <a:t>Thirty seconds on who you are, then move. The QR stays useful all talk — people scan it while you set up the demo. Everything in this deck was measured on the repo linked at the end; nothing needs an Nx Cloud account.</a:t>
+              <a:t>Thirty seconds on who you are, then move. The QR stays useful all talk — people scan it while you set up the demo. Everything in this deck was measured on the repo linked at the end; nothing needs an Nx Cloud account.
+BEFORE YOU PRESENT
+  $ cd ~/IdeaProjects/nx-scaling-e2e-tests-with-atomizer
+  $ npm ci &amp;&amp; npx cypress install
+  $ npm run demo:status      → expect buggyDiscount: false
+  $ npx nx reset             → cold cache, so the first number is honest
+  Keep a terminal in the repo root on a second screen or a split.</a:t>
             </a:r>
             <a:endParaRPr lang="en-US" dirty="0"/>
           </a:p>
@@ -702,7 +708,10 @@
           <a:p>
             <a:r>
               <a:rPr lang="en-US" dirty="0"/>
-              <a:t>Stress "generated". Nobody maintains this list — that is the difference from hand-rolled spec sharding.</a:t>
+              <a:t>Stress "generated". Nobody maintains this list — that is the difference from hand-rolled spec sharding.
+DEMO — what the atomizer generated
+  $ npm run e2e:targets
+  30 targets across 3 projects. Point out the names are file paths.</a:t>
             </a:r>
             <a:endParaRPr lang="en-US" dirty="0"/>
           </a:p>
@@ -790,7 +799,12 @@
           <a:p>
             <a:r>
               <a:rPr lang="en-US" dirty="0"/>
-              <a:t>Do this live. Piping through `npm run e2e:targets` gives a cleaner list if the JSON is too wide for the screen.</a:t>
+              <a:t>Do this live. Piping through `npm run e2e:targets` gives a cleaner list if the JSON is too wide for the screen.
+DEMO — where the targets come from
+  $ npx nx show project shop-e2e --json
+  (wide — use `npm run e2e:targets` if the JSON does not fit the screen)
+  $ grep -A8 "cypress/plugin" nx.json
+  Nine lines of config generate all thirty targets.</a:t>
             </a:r>
             <a:endParaRPr lang="en-US" dirty="0"/>
           </a:p>
@@ -878,7 +892,13 @@
           <a:p>
             <a:r>
               <a:rPr lang="en-US" dirty="0"/>
-              <a:t>This is the slide that did not exist last time. Nx 23 added the guard. Show the error live, then immediately run one atomized target directly to prove the split itself is free.</a:t>
+              <a:t>This is the slide that did not exist last time. Nx 23 added the guard. Show the error live, then immediately run one atomized target directly to prove the split itself is free.
+DEMO — hit the gate, then walk around it
+  $ npx nx run-many -t e2e-ci --parallel=5
+  Fails, listing all three e2e-ci tasks. Read it out loud.
+  $ npx nx run "shop-e2e:e2e-ci--src/e2e/catalog.cy.ts"
+  Same plugin, one leaf target, green. ~25s from cold because it builds the
+  app and starts preview first; a couple of seconds once those are cached.</a:t>
             </a:r>
             <a:endParaRPr lang="en-US" dirty="0"/>
           </a:p>
@@ -966,7 +986,12 @@
           <a:p>
             <a:r>
               <a:rPr lang="en-US" dirty="0"/>
-              <a:t>The script is twenty lines and does two things: ask Nx for the target list, hand it to run-many. Do not hand-roll a process pool — you lose the cache and the usual first attempt swallows exit codes. The amber box buys you credibility for the cache claims coming next, so do not rush it.</a:t>
+              <a:t>The script is twenty lines and does two things: ask Nx for the target list, hand it to run-many. Do not hand-roll a process pool — you lose the cache and the usual first attempt swallows exit codes. The amber box buys you credibility for the cache claims coming next, so do not rush it.
+DEMO — parallel on one machine
+  $ npx nx reset
+  $ node tools/run-e2e.mjs --project=shop-e2e --parallel=5
+  ~40-46s across runs, against the 1m 33s baseline from earlier.
+  Whole workspace if you have time: node tools/run-e2e.mjs --parallel=5  (~2m 06s)</a:t>
             </a:r>
             <a:endParaRPr lang="en-US" dirty="0"/>
           </a:p>
@@ -1054,7 +1079,12 @@
           <a:p>
             <a:r>
               <a:rPr lang="en-US" dirty="0"/>
-              <a:t>Sharding by index is the answer people expect, so say why it is the wrong default here and keep it for the case it is good at: one app big enough to dominate. The cross-product point is real — this repo has two login.cy.ts files and the runner refuses the selection rather than quietly running both.</a:t>
+              <a:t>Sharding by index is the answer people expect, so say why it is the wrong default here and keep it for the case it is good at: one app big enough to dominate. The cross-product point is real — this repo has two login.cy.ts files and the runner refuses the selection rather than quietly running both.
+DEMO — the same thing on CI
+  $ gh run list --limit 5
+  $ gh run view --web
+  One job per app, and the matrix is generated from the graph:
+  $ sed -n "1,40p" .github/workflows/e2e.yml</a:t>
             </a:r>
             <a:endParaRPr lang="en-US" dirty="0"/>
           </a:p>
@@ -1142,7 +1172,10 @@
           <a:p>
             <a:r>
               <a:rPr lang="en-US" dirty="0"/>
-              <a:t>Hit up-arrow and enter. The whole point is that it returns before you finish the sentence.</a:t>
+              <a:t>Hit up-arrow and enter. The whole point is that it returns before you finish the sentence.
+DEMO — run it again
+  $ node tools/run-e2e.mjs --project=shop-e2e --parallel=5
+  Up-arrow, enter. Back in ~0.2s with 11/12 cache hits.</a:t>
             </a:r>
             <a:endParaRPr lang="en-US" dirty="0"/>
           </a:p>
@@ -1230,7 +1263,12 @@
           <a:p>
             <a:r>
               <a:rPr lang="en-US" dirty="0"/>
-              <a:t>Be honest about 37→28: the two seeded failures are the two slowest specs and each still boots Cypress. The saving scales with how many specs pass — on 200 specs with 3 failures it is enormous.</a:t>
+              <a:t>Be honest about 37→28: the two seeded failures are the two slowest specs and each still boots Cypress. The saving scales with how many specs pass — on 200 specs with 3 failures it is enormous.
+DEMO — the money moment
+  $ npm run demo:break
+  $ node tools/run-e2e.mjs --project=shop-e2e --parallel=5   → ~40s, 2 fail
+  $ node tools/run-e2e.mjs --project=shop-e2e --parallel=5   → ~28s, 9/10 cached
+  Nothing changed between those two. Only the failures re-executed.</a:t>
             </a:r>
             <a:endParaRPr lang="en-US" dirty="0"/>
           </a:p>
@@ -1318,7 +1356,11 @@
           <a:p>
             <a:r>
               <a:rPr lang="en-US" dirty="0"/>
-              <a:t>If you want the "everything re-runs" version instead, run nx reset before this step. Best real example from this repo: a commit that touched only the slide deck restored the previous commit's cache and reported 33/36 hits and a 119ms run — the single-machine CI job went from 3m44s to 35s without anyone planning it. Inputs, not commits.</a:t>
+              <a:t>If you want the "everything re-runs" version instead, run nx reset before this step. Best real example from this repo: a commit that touched only the slide deck restored the previous commit's cache and reported 33/36 hits and a 119ms run — the single-machine CI job went from 3m44s to 35s without anyone planning it. Inputs, not commits.
+DEMO — undo it
+  $ npm run demo:fix
+  $ node tools/run-e2e.mjs --project=shop-e2e --parallel=5
+  ~0.2s. Reverting restored the old input hash, so the old results came back.</a:t>
             </a:r>
             <a:endParaRPr lang="en-US" dirty="0"/>
           </a:p>
@@ -1406,7 +1448,11 @@
           <a:p>
             <a:r>
               <a:rPr lang="en-US" dirty="0"/>
-              <a:t>The headline is 4m20s to 55s, but do not skip rung 2. Rung 3 is one flag and gets most of the win; rung 4 needs CI to have a matrix. Tell them to climb only as far as their pain justifies. Re-measure with npm run e2e:benchmark before the talk — rung 3 varied between 2m11s and 2m32s on repeats.</a:t>
+              <a:t>The headline is 4m20s to 55s, but do not skip rung 2. Rung 3 is one flag and gets most of the win; rung 4 needs CI to have a matrix. Tell them to climb only as far as their pain justifies. Re-measure with npm run e2e:benchmark before the talk — rung 3 varied between 2m11s and 2m32s on repeats.
+DO NOT RUN THIS LIVE
+  $ npm run e2e:benchmark
+  ~15 minutes — it runs every rung from a cold cache.
+  Run it the morning of the talk and read the numbers off this slide.</a:t>
             </a:r>
             <a:endParaRPr lang="en-US" dirty="0"/>
           </a:p>
@@ -1582,7 +1628,13 @@
           <a:p>
             <a:r>
               <a:rPr lang="en-US" dirty="0"/>
-              <a:t>Run this live: npm run e2e:affected on a clean tree exits green instantly, then touch libs/ui and watch two apps light up. The last row is the one that lands — most CI runs on most days are documentation and config.</a:t>
+              <a:t>Run this live: npm run e2e:affected on a clean tree exits green instantly, then touch libs/ui and watch two apps light up. The last row is the one that lands — most CI runs on most days are documentation and config.
+DEMO — let the graph choose
+  $ npm run e2e:affected                                    → nothing affected, instant
+  $ echo "/* demo */" &gt;&gt; libs/ui/src/styles.css
+  $ node tools/e2e-targets.mjs --affected --projects-json   → ["admin-e2e","docs-e2e"]
+  $ git checkout -- libs/ui/src/styles.css
+  Discovery is instant. Only run the full affected suite (~1m 22s) if you have time.</a:t>
             </a:r>
             <a:endParaRPr lang="en-US" dirty="0"/>
           </a:p>
@@ -2550,7 +2602,11 @@
           <a:p>
             <a:r>
               <a:rPr lang="en-US" dirty="0"/>
-              <a:t>Orientation, not content — keep it under a minute. Two things to point at. One: the libs are shared unevenly, formatting by shop and admin, ui by admin and docs, which is what makes the affected demo land later. Two: thirty spec files but only three runnable tasks, because nx e2e is one Cypress process per app. That three is the number the atomizer turns into thirty. Have `nx graph` open in a tab if you would rather show the real thing.</a:t>
+              <a:t>Orientation, not content — keep it under a minute. Two things to point at. One: the libs are shared unevenly, formatting by shop and admin, ui by admin and docs, which is what makes the affected demo land later. Two: thirty spec files but only three runnable tasks, because nx e2e is one Cypress process per app. That three is the number the atomizer turns into thirty. Have `nx graph` open in a tab if you would rather show the real thing.
+DEMO — show the real graph
+  $ npx nx graph
+  Opens a browser. Click shop, then ui, to show what depends on what.
+  Ctrl+C when done. `npx nx graph --print` if the projector hates the browser.</a:t>
             </a:r>
             <a:endParaRPr lang="en-US" dirty="0"/>
           </a:p>
@@ -2638,7 +2694,11 @@
           <a:p>
             <a:r>
               <a:rPr lang="en-US" dirty="0"/>
-              <a:t>Run this live if the timing works, otherwise show the recording. The number to sit with is 4m20s on a toy repo with 30 specs — the audience can extrapolate to their own suite faster than you can do it for them.</a:t>
+              <a:t>Run this live if the timing works, otherwise show the recording. The number to sit with is 4m20s on a toy repo with 30 specs — the audience can extrapolate to their own suite faster than you can do it for them.
+DEMO — the un-atomized baseline
+  $ npx nx e2e shop-e2e
+  ~1m 33s for ONE app. Start it, keep talking, come back to it.
+  All three serially is 4m 20s — quote that, do not run it.</a:t>
             </a:r>
             <a:endParaRPr lang="en-US" dirty="0"/>
           </a:p>
@@ -5765,11 +5825,11 @@
         <p:spPr>
           <a:xfrm>
             <a:off x="640080" y="2697480"/>
-            <a:ext cx="10881360" cy="1234440"/>
+            <a:ext cx="10881360" cy="1783080"/>
           </a:xfrm>
           <a:prstGeom prst="roundRect">
             <a:avLst>
-              <a:gd name="adj" fmla="val 5185"/>
+              <a:gd name="adj" fmla="val 3590"/>
             </a:avLst>
           </a:prstGeom>
           <a:solidFill>
@@ -5791,8 +5851,8 @@
         </p:nvSpPr>
         <p:spPr>
           <a:xfrm>
-            <a:off x="914400" y="2926080"/>
-            <a:ext cx="10332720" cy="822960"/>
+            <a:off x="914400" y="2880360"/>
+            <a:ext cx="10332720" cy="1463040"/>
           </a:xfrm>
           <a:prstGeom prst="rect">
             <a:avLst/>
@@ -5819,7 +5879,7 @@
                 <a:ea typeface="Courier New" pitchFamily="34" charset="-122"/>
                 <a:cs typeface="Courier New" pitchFamily="34" charset="-120"/>
               </a:rPr>
-              <a:t>NX   The shop-e2e:e2e-ci task should only be run with Nx Cloud.</a:t>
+              <a:t>NX   The following tasks should only be run with Nx Cloud:</a:t>
             </a:r>
             <a:endParaRPr lang="en-US" sz="1400" dirty="0"/>
           </a:p>
@@ -5839,6 +5899,66 @@
                 <a:ea typeface="Courier New" pitchFamily="34" charset="-122"/>
                 <a:cs typeface="Courier New" pitchFamily="34" charset="-120"/>
               </a:rPr>
+              <a:t>       - admin-e2e:e2e-ci</a:t>
+            </a:r>
+            <a:endParaRPr lang="en-US" sz="1400" dirty="0"/>
+          </a:p>
+          <a:p>
+            <a:pPr indent="0" marL="0">
+              <a:lnSpc>
+                <a:spcPct val="130000"/>
+              </a:lnSpc>
+              <a:buNone/>
+            </a:pPr>
+            <a:r>
+              <a:rPr lang="en-US" sz="1400" dirty="0">
+                <a:solidFill>
+                  <a:srgbClr val="F5B7C0"/>
+                </a:solidFill>
+                <a:latin typeface="Courier New" pitchFamily="34" charset="0"/>
+                <a:ea typeface="Courier New" pitchFamily="34" charset="-122"/>
+                <a:cs typeface="Courier New" pitchFamily="34" charset="-120"/>
+              </a:rPr>
+              <a:t>       - docs-e2e:e2e-ci</a:t>
+            </a:r>
+            <a:endParaRPr lang="en-US" sz="1400" dirty="0"/>
+          </a:p>
+          <a:p>
+            <a:pPr indent="0" marL="0">
+              <a:lnSpc>
+                <a:spcPct val="130000"/>
+              </a:lnSpc>
+              <a:buNone/>
+            </a:pPr>
+            <a:r>
+              <a:rPr lang="en-US" sz="1400" dirty="0">
+                <a:solidFill>
+                  <a:srgbClr val="F5B7C0"/>
+                </a:solidFill>
+                <a:latin typeface="Courier New" pitchFamily="34" charset="0"/>
+                <a:ea typeface="Courier New" pitchFamily="34" charset="-122"/>
+                <a:cs typeface="Courier New" pitchFamily="34" charset="-120"/>
+              </a:rPr>
+              <a:t>       - shop-e2e:e2e-ci</a:t>
+            </a:r>
+            <a:endParaRPr lang="en-US" sz="1400" dirty="0"/>
+          </a:p>
+          <a:p>
+            <a:pPr indent="0" marL="0">
+              <a:lnSpc>
+                <a:spcPct val="130000"/>
+              </a:lnSpc>
+              <a:buNone/>
+            </a:pPr>
+            <a:r>
+              <a:rPr lang="en-US" sz="1400" dirty="0">
+                <a:solidFill>
+                  <a:srgbClr val="F5B7C0"/>
+                </a:solidFill>
+                <a:latin typeface="Courier New" pitchFamily="34" charset="0"/>
+                <a:ea typeface="Courier New" pitchFamily="34" charset="-122"/>
+                <a:cs typeface="Courier New" pitchFamily="34" charset="-120"/>
+              </a:rPr>
               <a:t>Please enable Nx Cloud or use the slower "e2e" task.</a:t>
             </a:r>
             <a:endParaRPr lang="en-US" sz="1400" dirty="0"/>
@@ -5853,7 +5973,7 @@
         </p:nvSpPr>
         <p:spPr>
           <a:xfrm>
-            <a:off x="640080" y="4160520"/>
+            <a:off x="640080" y="4663440"/>
             <a:ext cx="10881360" cy="411480"/>
           </a:xfrm>
           <a:prstGeom prst="rect">
@@ -5892,8 +6012,8 @@
         </p:nvSpPr>
         <p:spPr>
           <a:xfrm>
-            <a:off x="640080" y="4663440"/>
-            <a:ext cx="10881360" cy="1554480"/>
+            <a:off x="640080" y="5166360"/>
+            <a:ext cx="10881360" cy="1371600"/>
           </a:xfrm>
           <a:prstGeom prst="rect">
             <a:avLst/>
@@ -5913,7 +6033,7 @@
               <a:buChar char="•"/>
             </a:pPr>
             <a:r>
-              <a:rPr lang="en-US" sz="1500" dirty="0">
+              <a:rPr lang="en-US" sz="1400" dirty="0">
                 <a:solidFill>
                   <a:srgbClr val="C3CAD6"/>
                 </a:solidFill>
@@ -5921,9 +6041,9 @@
                 <a:ea typeface="Calibri" pitchFamily="34" charset="-122"/>
                 <a:cs typeface="Calibri" pitchFamily="34" charset="-120"/>
               </a:rPr>
-              <a:t>e2e-ci is a no-op coordinator that just depends on the ten real tasks</a:t>
-            </a:r>
-            <a:endParaRPr lang="en-US" sz="1500" dirty="0"/>
+              <a:t>e2e-ci is a no-op coordinator that just depends on that app's ten real tasks</a:t>
+            </a:r>
+            <a:endParaRPr lang="en-US" sz="1400" dirty="0"/>
           </a:p>
           <a:p>
             <a:pPr marL="342900" indent="-342900">
@@ -5934,7 +6054,7 @@
               <a:buChar char="•"/>
             </a:pPr>
             <a:r>
-              <a:rPr lang="en-US" sz="1500" dirty="0">
+              <a:rPr lang="en-US" sz="1400" dirty="0">
                 <a:solidFill>
                   <a:srgbClr val="C3CAD6"/>
                 </a:solidFill>
@@ -5944,7 +6064,7 @@
               </a:rPr>
               <a:t>The ten atomized targets are ordinary nx:run-commands tasks</a:t>
             </a:r>
-            <a:endParaRPr lang="en-US" sz="1500" dirty="0"/>
+            <a:endParaRPr lang="en-US" sz="1400" dirty="0"/>
           </a:p>
           <a:p>
             <a:pPr marL="342900" indent="-342900">
@@ -5955,7 +6075,7 @@
               <a:buChar char="•"/>
             </a:pPr>
             <a:r>
-              <a:rPr lang="en-US" sz="1500" dirty="0">
+              <a:rPr lang="en-US" sz="1400" dirty="0">
                 <a:solidFill>
                   <a:srgbClr val="C3CAD6"/>
                 </a:solidFill>
@@ -5965,7 +6085,7 @@
               </a:rPr>
               <a:t>Run one directly and it works, cache and all</a:t>
             </a:r>
-            <a:endParaRPr lang="en-US" sz="1500" dirty="0"/>
+            <a:endParaRPr lang="en-US" sz="1400" dirty="0"/>
           </a:p>
         </p:txBody>
       </p:sp>

</xml_diff>

<commit_message>
Make the Nx Cloud gate a procurement problem, not a technical one
The bullets now escalate: Nx Cloud is paid, is it approved where you work, and
if not you are simply blocked. For a lot of the room that is the real obstacle.

The heading had to change with them. "The gate is on the wrapper, not on the
work" says you are not blocked, which directly contradicts the new third
bullet. That technical point is not lost — the next slide already opens with
"the wrapper is gated, the leaves are not" and then walks around it.
</commit_message>
<xml_diff>
--- a/talk/Scaling-E2E-Tests-with-Nx.pptx
+++ b/talk/Scaling-E2E-Tests-with-Nx.pptx
@@ -892,7 +892,7 @@
           <a:p>
             <a:r>
               <a:rPr lang="en-US" dirty="0"/>
-              <a:t>This is the slide that did not exist last time. Nx 23 added the guard. Show the error live, then immediately run one atomized target directly to prove the split itself is free.
+              <a:t>This is the slide that did not exist last time — Nx 23 added the guard. Do not rush to the workaround: sit on the third bullet. For a lot of the room this is not a technical problem at all, it is a purchase order they are not going to win this quarter. The good news lands on the next slide.
 DEMO — hit the gate, then walk around it
   $ npx nx run-many -t e2e-ci --parallel=5
   Fails, listing all three e2e-ci tasks. Read it out loud.
@@ -5992,13 +5992,13 @@
             <a:r>
               <a:rPr lang="en-US" sz="2400" b="1" dirty="0">
                 <a:solidFill>
-                  <a:srgbClr val="4ADE80"/>
+                  <a:srgbClr val="F5A524"/>
                 </a:solidFill>
                 <a:latin typeface="Cambria" pitchFamily="34" charset="0"/>
                 <a:ea typeface="Cambria" pitchFamily="34" charset="-122"/>
                 <a:cs typeface="Cambria" pitchFamily="34" charset="-120"/>
               </a:rPr>
-              <a:t>The gate is on the wrapper, not on the work.</a:t>
+              <a:t>So now it is a procurement question.</a:t>
             </a:r>
             <a:endParaRPr lang="en-US" sz="2400" dirty="0"/>
           </a:p>
@@ -6033,7 +6033,7 @@
               <a:buChar char="•"/>
             </a:pPr>
             <a:r>
-              <a:rPr lang="en-US" sz="1400" dirty="0">
+              <a:rPr lang="en-US" sz="1500" dirty="0">
                 <a:solidFill>
                   <a:srgbClr val="C3CAD6"/>
                 </a:solidFill>
@@ -6041,9 +6041,9 @@
                 <a:ea typeface="Calibri" pitchFamily="34" charset="-122"/>
                 <a:cs typeface="Calibri" pitchFamily="34" charset="-120"/>
               </a:rPr>
-              <a:t>e2e-ci is a no-op coordinator that just depends on that app's ten real tasks</a:t>
-            </a:r>
-            <a:endParaRPr lang="en-US" sz="1400" dirty="0"/>
+              <a:t>Nx Cloud is a premium service from Nx</a:t>
+            </a:r>
+            <a:endParaRPr lang="en-US" sz="1500" dirty="0"/>
           </a:p>
           <a:p>
             <a:pPr marL="342900" indent="-342900">
@@ -6054,7 +6054,7 @@
               <a:buChar char="•"/>
             </a:pPr>
             <a:r>
-              <a:rPr lang="en-US" sz="1400" dirty="0">
+              <a:rPr lang="en-US" sz="1500" dirty="0">
                 <a:solidFill>
                   <a:srgbClr val="C3CAD6"/>
                 </a:solidFill>
@@ -6062,9 +6062,9 @@
                 <a:ea typeface="Calibri" pitchFamily="34" charset="-122"/>
                 <a:cs typeface="Calibri" pitchFamily="34" charset="-120"/>
               </a:rPr>
-              <a:t>The ten atomized targets are ordinary nx:run-commands tasks</a:t>
-            </a:r>
-            <a:endParaRPr lang="en-US" sz="1400" dirty="0"/>
+              <a:t>Is it approved in your organisation?</a:t>
+            </a:r>
+            <a:endParaRPr lang="en-US" sz="1500" dirty="0"/>
           </a:p>
           <a:p>
             <a:pPr marL="342900" indent="-342900">
@@ -6075,17 +6075,17 @@
               <a:buChar char="•"/>
             </a:pPr>
             <a:r>
-              <a:rPr lang="en-US" sz="1400" dirty="0">
-                <a:solidFill>
-                  <a:srgbClr val="C3CAD6"/>
-                </a:solidFill>
-                <a:latin typeface="Calibri" pitchFamily="34" charset="0"/>
-                <a:ea typeface="Calibri" pitchFamily="34" charset="-122"/>
-                <a:cs typeface="Calibri" pitchFamily="34" charset="-120"/>
-              </a:rPr>
-              <a:t>Run one directly and it works, cache and all</a:t>
-            </a:r>
-            <a:endParaRPr lang="en-US" sz="1400" dirty="0"/>
+              <a:rPr lang="en-US" sz="1500" b="1" dirty="0">
+                <a:solidFill>
+                  <a:srgbClr val="FB7185"/>
+                </a:solidFill>
+                <a:latin typeface="Calibri" pitchFamily="34" charset="0"/>
+                <a:ea typeface="Calibri" pitchFamily="34" charset="-122"/>
+                <a:cs typeface="Calibri" pitchFamily="34" charset="-120"/>
+              </a:rPr>
+              <a:t>If not approved — you are blocked</a:t>
+            </a:r>
+            <a:endParaRPr lang="en-US" sz="1500" dirty="0"/>
           </a:p>
         </p:txBody>
       </p:sp>

</xml_diff>

<commit_message>
Rewrite the cover subtitle without the jargon
"Atomizing, parallelising and caching a Cypress suite" asked the room to know
four things before the talk started. It now says what the talk is for:
"Making your slowest quality gate fast enough to actually use and trust on
every pull request".

Broken explicitly across two lines in the conference deck — left to itself the
wrap orphaned "request".
</commit_message>
<xml_diff>
--- a/talk/Scaling-E2E-Tests-with-Nx.pptx
+++ b/talk/Scaling-E2E-Tests-with-Nx.pptx
@@ -3158,19 +3158,22 @@
         <p:spPr>
           <a:xfrm>
             <a:off x="640080" y="3200400"/>
-            <a:ext cx="7863840" cy="411480"/>
-          </a:xfrm>
-          <a:prstGeom prst="rect">
-            <a:avLst/>
-          </a:prstGeom>
-          <a:noFill/>
-          <a:ln/>
-        </p:spPr>
-        <p:txBody>
-          <a:bodyPr wrap="square" lIns="0" tIns="0" rIns="0" bIns="0" rtlCol="0" anchor="ctr"/>
-          <a:lstStyle/>
-          <a:p>
-            <a:pPr indent="0" marL="0">
+            <a:ext cx="7863840" cy="777240"/>
+          </a:xfrm>
+          <a:prstGeom prst="rect">
+            <a:avLst/>
+          </a:prstGeom>
+          <a:noFill/>
+          <a:ln/>
+        </p:spPr>
+        <p:txBody>
+          <a:bodyPr wrap="square" lIns="0" tIns="0" rIns="0" bIns="0" rtlCol="0" anchor="ctr"/>
+          <a:lstStyle/>
+          <a:p>
+            <a:pPr indent="0" marL="0">
+              <a:lnSpc>
+                <a:spcPct val="115000"/>
+              </a:lnSpc>
               <a:buNone/>
             </a:pPr>
             <a:r>
@@ -3182,7 +3185,27 @@
                 <a:ea typeface="Calibri" pitchFamily="34" charset="-122"/>
                 <a:cs typeface="Calibri" pitchFamily="34" charset="-120"/>
               </a:rPr>
-              <a:t>Atomizing, parallelising and caching a Cypress suite — without Nx Cloud</a:t>
+              <a:t>Making your slowest quality gate fast enough</a:t>
+            </a:r>
+            <a:endParaRPr lang="en-US" sz="1700" dirty="0"/>
+          </a:p>
+          <a:p>
+            <a:pPr indent="0" marL="0">
+              <a:lnSpc>
+                <a:spcPct val="115000"/>
+              </a:lnSpc>
+              <a:buNone/>
+            </a:pPr>
+            <a:r>
+              <a:rPr lang="en-US" sz="1700" dirty="0">
+                <a:solidFill>
+                  <a:srgbClr val="C3CAD6"/>
+                </a:solidFill>
+                <a:latin typeface="Calibri" pitchFamily="34" charset="0"/>
+                <a:ea typeface="Calibri" pitchFamily="34" charset="-122"/>
+                <a:cs typeface="Calibri" pitchFamily="34" charset="-120"/>
+              </a:rPr>
+              <a:t>to actually use and trust on every pull request</a:t>
             </a:r>
             <a:endParaRPr lang="en-US" sz="1700" dirty="0"/>
           </a:p>
@@ -3196,7 +3219,7 @@
         </p:nvSpPr>
         <p:spPr>
           <a:xfrm>
-            <a:off x="640080" y="3977640"/>
+            <a:off x="640080" y="4224528"/>
             <a:ext cx="1005840" cy="32004"/>
           </a:xfrm>
           <a:prstGeom prst="rect">
@@ -3229,7 +3252,7 @@
         </p:blipFill>
         <p:spPr>
           <a:xfrm>
-            <a:off x="640080" y="4224528"/>
+            <a:off x="640080" y="4480560"/>
             <a:ext cx="1234440" cy="1234440"/>
           </a:xfrm>
           <a:prstGeom prst="ellipse">
@@ -3245,7 +3268,7 @@
         </p:nvSpPr>
         <p:spPr>
           <a:xfrm>
-            <a:off x="2148840" y="4416552"/>
+            <a:off x="2148840" y="4672584"/>
             <a:ext cx="6309360" cy="411480"/>
           </a:xfrm>
           <a:prstGeom prst="rect">
@@ -3284,7 +3307,7 @@
         </p:nvSpPr>
         <p:spPr>
           <a:xfrm>
-            <a:off x="2148840" y="4828032"/>
+            <a:off x="2148840" y="5084064"/>
             <a:ext cx="6309360" cy="365760"/>
           </a:xfrm>
           <a:prstGeom prst="rect">

</xml_diff>

<commit_message>
Clean up the audience-question cards
"Who runs E2E tests?" becomes "Who is using E2E tests?", and the grey reaction
lines come off the cards — they were stage directions printed on the projector.
They now live in the speaker notes, where they were half-duplicated already.

Cards shrink to suit the shorter content and the callout moves up with them.
</commit_message>
<xml_diff>
--- a/talk/Scaling-E2E-Tests-with-Nx.pptx
+++ b/talk/Scaling-E2E-Tests-with-Nx.pptx
@@ -2250,7 +2250,7 @@
           <a:p>
             <a:r>
               <a:rPr lang="en-US" dirty="0"/>
-              <a:t>Ask it, then actually wait for the hands. Nearly everyone puts one up, which is the point — this is not a niche problem.</a:t>
+              <a:t>Ask it, then actually wait for the hands. Expect nearly everyone — that is the point, this is not a niche problem.</a:t>
             </a:r>
             <a:endParaRPr lang="en-US" dirty="0"/>
           </a:p>
@@ -2338,7 +2338,7 @@
           <a:p>
             <a:r>
               <a:rPr lang="en-US" dirty="0"/>
-              <a:t>Second question, same room. The hands thin out and someone usually laughs. Do not rush past that laugh, it is the whole talk in one reaction.</a:t>
+              <a:t>Second question, same room. Expect far fewer hands and some laughter. Do not rush past that laugh — it is the whole talk in one reaction.</a:t>
             </a:r>
             <a:endParaRPr lang="en-US" dirty="0"/>
           </a:p>
@@ -2426,7 +2426,7 @@
           <a:p>
             <a:r>
               <a:rPr lang="en-US" dirty="0"/>
-              <a:t>Third question kills it. Almost nobody gates a merge on a suite they cannot trust. Now reveal the line at the bottom and move — you have earned the next ten minutes.</a:t>
+              <a:t>Third question kills it. Expect almost no hands — nobody gates a merge on a suite they cannot trust. Reveal the line at the bottom and move; you have earned the next ten minutes.</a:t>
             </a:r>
             <a:endParaRPr lang="en-US" dirty="0"/>
           </a:p>
@@ -16379,11 +16379,11 @@
         <p:spPr>
           <a:xfrm>
             <a:off x="640080" y="2011680"/>
-            <a:ext cx="3429000" cy="2331720"/>
+            <a:ext cx="3429000" cy="1737360"/>
           </a:xfrm>
           <a:prstGeom prst="roundRect">
             <a:avLst>
-              <a:gd name="adj" fmla="val 3529"/>
+              <a:gd name="adj" fmla="val 4737"/>
             </a:avLst>
           </a:prstGeom>
           <a:solidFill>
@@ -16469,8 +16469,8 @@
         </p:nvSpPr>
         <p:spPr>
           <a:xfrm>
-            <a:off x="868680" y="2971800"/>
-            <a:ext cx="2971800" cy="822960"/>
+            <a:off x="868680" y="2944368"/>
+            <a:ext cx="2971800" cy="731520"/>
           </a:xfrm>
           <a:prstGeom prst="rect">
             <a:avLst/>
@@ -16494,7 +16494,7 @@
                 <a:ea typeface="Calibri" pitchFamily="34" charset="-122"/>
                 <a:cs typeface="Calibri" pitchFamily="34" charset="-120"/>
               </a:rPr>
-              <a:t>Who runs E2E tests?</a:t>
+              <a:t>Who is using E2E tests?</a:t>
             </a:r>
             <a:endParaRPr lang="en-US" sz="1900" dirty="0"/>
           </a:p>
@@ -16502,57 +16502,18 @@
       </p:sp>
       <p:sp>
         <p:nvSpPr>
-          <p:cNvPr id="8" name="Text 6"/>
-          <p:cNvSpPr txBox="1"/>
-          <p:nvPr/>
-        </p:nvSpPr>
-        <p:spPr>
-          <a:xfrm>
-            <a:off x="868680" y="3794760"/>
-            <a:ext cx="2971800" cy="411480"/>
-          </a:xfrm>
-          <a:prstGeom prst="rect">
-            <a:avLst/>
-          </a:prstGeom>
-          <a:noFill/>
-          <a:ln/>
-        </p:spPr>
-        <p:txBody>
-          <a:bodyPr wrap="square" lIns="0" tIns="0" rIns="0" bIns="0" rtlCol="0" anchor="ctr"/>
-          <a:lstStyle/>
-          <a:p>
-            <a:pPr indent="0" marL="0">
-              <a:buNone/>
-            </a:pPr>
-            <a:r>
-              <a:rPr lang="en-US" sz="1300" i="1" dirty="0">
-                <a:solidFill>
-                  <a:srgbClr val="8A94A6"/>
-                </a:solidFill>
-                <a:latin typeface="Calibri" pitchFamily="34" charset="0"/>
-                <a:ea typeface="Calibri" pitchFamily="34" charset="-122"/>
-                <a:cs typeface="Calibri" pitchFamily="34" charset="-120"/>
-              </a:rPr>
-              <a:t>Most hands go up.</a:t>
-            </a:r>
-            <a:endParaRPr lang="en-US" sz="1300" dirty="0"/>
-          </a:p>
-        </p:txBody>
-      </p:sp>
-      <p:sp>
-        <p:nvSpPr>
-          <p:cNvPr id="9" name="Shape 7"/>
+          <p:cNvPr id="8" name="Shape 6"/>
           <p:cNvSpPr/>
           <p:nvPr/>
         </p:nvSpPr>
         <p:spPr>
           <a:xfrm>
             <a:off x="4343400" y="2011680"/>
-            <a:ext cx="3429000" cy="2331720"/>
+            <a:ext cx="3429000" cy="1737360"/>
           </a:xfrm>
           <a:prstGeom prst="roundRect">
             <a:avLst>
-              <a:gd name="adj" fmla="val 3529"/>
+              <a:gd name="adj" fmla="val 4737"/>
             </a:avLst>
           </a:prstGeom>
           <a:solidFill>
@@ -16568,14 +16529,14 @@
       </p:sp>
       <p:sp>
         <p:nvSpPr>
-          <p:cNvPr id="10" name="Text 8"/>
+          <p:cNvPr id="9" name="Text 7"/>
           <p:cNvSpPr txBox="1"/>
           <p:nvPr/>
         </p:nvSpPr>
         <p:spPr>
           <a:xfrm>
             <a:off x="4343400" y="2011680"/>
-            <a:ext cx="3429000" cy="2331720"/>
+            <a:ext cx="3429000" cy="1737360"/>
           </a:xfrm>
           <a:prstGeom prst="rect">
             <a:avLst/>
@@ -16607,18 +16568,18 @@
       </p:sp>
       <p:sp>
         <p:nvSpPr>
-          <p:cNvPr id="11" name="Shape 9"/>
+          <p:cNvPr id="10" name="Shape 8"/>
           <p:cNvSpPr/>
           <p:nvPr/>
         </p:nvSpPr>
         <p:spPr>
           <a:xfrm>
             <a:off x="8046720" y="2011680"/>
-            <a:ext cx="3429000" cy="2331720"/>
+            <a:ext cx="3429000" cy="1737360"/>
           </a:xfrm>
           <a:prstGeom prst="roundRect">
             <a:avLst>
-              <a:gd name="adj" fmla="val 3529"/>
+              <a:gd name="adj" fmla="val 4737"/>
             </a:avLst>
           </a:prstGeom>
           <a:solidFill>
@@ -16634,14 +16595,14 @@
       </p:sp>
       <p:sp>
         <p:nvSpPr>
-          <p:cNvPr id="12" name="Text 10"/>
+          <p:cNvPr id="11" name="Text 9"/>
           <p:cNvSpPr txBox="1"/>
           <p:nvPr/>
         </p:nvSpPr>
         <p:spPr>
           <a:xfrm>
             <a:off x="8046720" y="2011680"/>
-            <a:ext cx="3429000" cy="2331720"/>
+            <a:ext cx="3429000" cy="1737360"/>
           </a:xfrm>
           <a:prstGeom prst="rect">
             <a:avLst/>
@@ -16790,11 +16751,11 @@
         <p:spPr>
           <a:xfrm>
             <a:off x="640080" y="2011680"/>
-            <a:ext cx="3429000" cy="2331720"/>
+            <a:ext cx="3429000" cy="1737360"/>
           </a:xfrm>
           <a:prstGeom prst="roundRect">
             <a:avLst>
-              <a:gd name="adj" fmla="val 3529"/>
+              <a:gd name="adj" fmla="val 4737"/>
             </a:avLst>
           </a:prstGeom>
           <a:solidFill>
@@ -16880,8 +16841,8 @@
         </p:nvSpPr>
         <p:spPr>
           <a:xfrm>
-            <a:off x="868680" y="2971800"/>
-            <a:ext cx="2971800" cy="822960"/>
+            <a:off x="868680" y="2944368"/>
+            <a:ext cx="2971800" cy="731520"/>
           </a:xfrm>
           <a:prstGeom prst="rect">
             <a:avLst/>
@@ -16905,7 +16866,7 @@
                 <a:ea typeface="Calibri" pitchFamily="34" charset="-122"/>
                 <a:cs typeface="Calibri" pitchFamily="34" charset="-120"/>
               </a:rPr>
-              <a:t>Who runs E2E tests?</a:t>
+              <a:t>Who is using E2E tests?</a:t>
             </a:r>
             <a:endParaRPr lang="en-US" sz="1900" dirty="0"/>
           </a:p>
@@ -16913,57 +16874,18 @@
       </p:sp>
       <p:sp>
         <p:nvSpPr>
-          <p:cNvPr id="8" name="Text 6"/>
-          <p:cNvSpPr txBox="1"/>
-          <p:nvPr/>
-        </p:nvSpPr>
-        <p:spPr>
-          <a:xfrm>
-            <a:off x="868680" y="3794760"/>
-            <a:ext cx="2971800" cy="411480"/>
-          </a:xfrm>
-          <a:prstGeom prst="rect">
-            <a:avLst/>
-          </a:prstGeom>
-          <a:noFill/>
-          <a:ln/>
-        </p:spPr>
-        <p:txBody>
-          <a:bodyPr wrap="square" lIns="0" tIns="0" rIns="0" bIns="0" rtlCol="0" anchor="ctr"/>
-          <a:lstStyle/>
-          <a:p>
-            <a:pPr indent="0" marL="0">
-              <a:buNone/>
-            </a:pPr>
-            <a:r>
-              <a:rPr lang="en-US" sz="1300" i="1" dirty="0">
-                <a:solidFill>
-                  <a:srgbClr val="8A94A6"/>
-                </a:solidFill>
-                <a:latin typeface="Calibri" pitchFamily="34" charset="0"/>
-                <a:ea typeface="Calibri" pitchFamily="34" charset="-122"/>
-                <a:cs typeface="Calibri" pitchFamily="34" charset="-120"/>
-              </a:rPr>
-              <a:t>Most hands go up.</a:t>
-            </a:r>
-            <a:endParaRPr lang="en-US" sz="1300" dirty="0"/>
-          </a:p>
-        </p:txBody>
-      </p:sp>
-      <p:sp>
-        <p:nvSpPr>
-          <p:cNvPr id="9" name="Shape 7"/>
+          <p:cNvPr id="8" name="Shape 6"/>
           <p:cNvSpPr/>
           <p:nvPr/>
         </p:nvSpPr>
         <p:spPr>
           <a:xfrm>
             <a:off x="4343400" y="2011680"/>
-            <a:ext cx="3429000" cy="2331720"/>
+            <a:ext cx="3429000" cy="1737360"/>
           </a:xfrm>
           <a:prstGeom prst="roundRect">
             <a:avLst>
-              <a:gd name="adj" fmla="val 3529"/>
+              <a:gd name="adj" fmla="val 4737"/>
             </a:avLst>
           </a:prstGeom>
           <a:solidFill>
@@ -16979,7 +16901,7 @@
       </p:sp>
       <p:sp>
         <p:nvSpPr>
-          <p:cNvPr id="10" name="Shape 8"/>
+          <p:cNvPr id="9" name="Shape 7"/>
           <p:cNvSpPr/>
           <p:nvPr/>
         </p:nvSpPr>
@@ -17004,7 +16926,7 @@
       </p:sp>
       <p:sp>
         <p:nvSpPr>
-          <p:cNvPr id="11" name="Text 9"/>
+          <p:cNvPr id="10" name="Text 8"/>
           <p:cNvSpPr txBox="1"/>
           <p:nvPr/>
         </p:nvSpPr>
@@ -17043,14 +16965,14 @@
       </p:sp>
       <p:sp>
         <p:nvSpPr>
-          <p:cNvPr id="12" name="Text 10"/>
-          <p:cNvSpPr txBox="1"/>
-          <p:nvPr/>
-        </p:nvSpPr>
-        <p:spPr>
-          <a:xfrm>
-            <a:off x="4572000" y="2971800"/>
-            <a:ext cx="2971800" cy="822960"/>
+          <p:cNvPr id="11" name="Text 9"/>
+          <p:cNvSpPr txBox="1"/>
+          <p:nvPr/>
+        </p:nvSpPr>
+        <p:spPr>
+          <a:xfrm>
+            <a:off x="4572000" y="2944368"/>
+            <a:ext cx="2971800" cy="731520"/>
           </a:xfrm>
           <a:prstGeom prst="rect">
             <a:avLst/>
@@ -17082,57 +17004,18 @@
       </p:sp>
       <p:sp>
         <p:nvSpPr>
-          <p:cNvPr id="13" name="Text 11"/>
-          <p:cNvSpPr txBox="1"/>
-          <p:nvPr/>
-        </p:nvSpPr>
-        <p:spPr>
-          <a:xfrm>
-            <a:off x="4572000" y="3794760"/>
-            <a:ext cx="2971800" cy="411480"/>
-          </a:xfrm>
-          <a:prstGeom prst="rect">
-            <a:avLst/>
-          </a:prstGeom>
-          <a:noFill/>
-          <a:ln/>
-        </p:spPr>
-        <p:txBody>
-          <a:bodyPr wrap="square" lIns="0" tIns="0" rIns="0" bIns="0" rtlCol="0" anchor="ctr"/>
-          <a:lstStyle/>
-          <a:p>
-            <a:pPr indent="0" marL="0">
-              <a:buNone/>
-            </a:pPr>
-            <a:r>
-              <a:rPr lang="en-US" sz="1300" i="1" dirty="0">
-                <a:solidFill>
-                  <a:srgbClr val="8A94A6"/>
-                </a:solidFill>
-                <a:latin typeface="Calibri" pitchFamily="34" charset="0"/>
-                <a:ea typeface="Calibri" pitchFamily="34" charset="-122"/>
-                <a:cs typeface="Calibri" pitchFamily="34" charset="-120"/>
-              </a:rPr>
-              <a:t>Fewer hands. Some laughter.</a:t>
-            </a:r>
-            <a:endParaRPr lang="en-US" sz="1300" dirty="0"/>
-          </a:p>
-        </p:txBody>
-      </p:sp>
-      <p:sp>
-        <p:nvSpPr>
-          <p:cNvPr id="14" name="Shape 12"/>
+          <p:cNvPr id="12" name="Shape 10"/>
           <p:cNvSpPr/>
           <p:nvPr/>
         </p:nvSpPr>
         <p:spPr>
           <a:xfrm>
             <a:off x="8046720" y="2011680"/>
-            <a:ext cx="3429000" cy="2331720"/>
+            <a:ext cx="3429000" cy="1737360"/>
           </a:xfrm>
           <a:prstGeom prst="roundRect">
             <a:avLst>
-              <a:gd name="adj" fmla="val 3529"/>
+              <a:gd name="adj" fmla="val 4737"/>
             </a:avLst>
           </a:prstGeom>
           <a:solidFill>
@@ -17148,14 +17031,14 @@
       </p:sp>
       <p:sp>
         <p:nvSpPr>
-          <p:cNvPr id="15" name="Text 13"/>
+          <p:cNvPr id="13" name="Text 11"/>
           <p:cNvSpPr txBox="1"/>
           <p:nvPr/>
         </p:nvSpPr>
         <p:spPr>
           <a:xfrm>
             <a:off x="8046720" y="2011680"/>
-            <a:ext cx="3429000" cy="2331720"/>
+            <a:ext cx="3429000" cy="1737360"/>
           </a:xfrm>
           <a:prstGeom prst="rect">
             <a:avLst/>
@@ -17304,11 +17187,11 @@
         <p:spPr>
           <a:xfrm>
             <a:off x="640080" y="2011680"/>
-            <a:ext cx="3429000" cy="2331720"/>
+            <a:ext cx="3429000" cy="1737360"/>
           </a:xfrm>
           <a:prstGeom prst="roundRect">
             <a:avLst>
-              <a:gd name="adj" fmla="val 3529"/>
+              <a:gd name="adj" fmla="val 4737"/>
             </a:avLst>
           </a:prstGeom>
           <a:solidFill>
@@ -17394,8 +17277,8 @@
         </p:nvSpPr>
         <p:spPr>
           <a:xfrm>
-            <a:off x="868680" y="2971800"/>
-            <a:ext cx="2971800" cy="822960"/>
+            <a:off x="868680" y="2944368"/>
+            <a:ext cx="2971800" cy="731520"/>
           </a:xfrm>
           <a:prstGeom prst="rect">
             <a:avLst/>
@@ -17419,7 +17302,7 @@
                 <a:ea typeface="Calibri" pitchFamily="34" charset="-122"/>
                 <a:cs typeface="Calibri" pitchFamily="34" charset="-120"/>
               </a:rPr>
-              <a:t>Who runs E2E tests?</a:t>
+              <a:t>Who is using E2E tests?</a:t>
             </a:r>
             <a:endParaRPr lang="en-US" sz="1900" dirty="0"/>
           </a:p>
@@ -17427,57 +17310,18 @@
       </p:sp>
       <p:sp>
         <p:nvSpPr>
-          <p:cNvPr id="8" name="Text 6"/>
-          <p:cNvSpPr txBox="1"/>
-          <p:nvPr/>
-        </p:nvSpPr>
-        <p:spPr>
-          <a:xfrm>
-            <a:off x="868680" y="3794760"/>
-            <a:ext cx="2971800" cy="411480"/>
-          </a:xfrm>
-          <a:prstGeom prst="rect">
-            <a:avLst/>
-          </a:prstGeom>
-          <a:noFill/>
-          <a:ln/>
-        </p:spPr>
-        <p:txBody>
-          <a:bodyPr wrap="square" lIns="0" tIns="0" rIns="0" bIns="0" rtlCol="0" anchor="ctr"/>
-          <a:lstStyle/>
-          <a:p>
-            <a:pPr indent="0" marL="0">
-              <a:buNone/>
-            </a:pPr>
-            <a:r>
-              <a:rPr lang="en-US" sz="1300" i="1" dirty="0">
-                <a:solidFill>
-                  <a:srgbClr val="8A94A6"/>
-                </a:solidFill>
-                <a:latin typeface="Calibri" pitchFamily="34" charset="0"/>
-                <a:ea typeface="Calibri" pitchFamily="34" charset="-122"/>
-                <a:cs typeface="Calibri" pitchFamily="34" charset="-120"/>
-              </a:rPr>
-              <a:t>Most hands go up.</a:t>
-            </a:r>
-            <a:endParaRPr lang="en-US" sz="1300" dirty="0"/>
-          </a:p>
-        </p:txBody>
-      </p:sp>
-      <p:sp>
-        <p:nvSpPr>
-          <p:cNvPr id="9" name="Shape 7"/>
+          <p:cNvPr id="8" name="Shape 6"/>
           <p:cNvSpPr/>
           <p:nvPr/>
         </p:nvSpPr>
         <p:spPr>
           <a:xfrm>
             <a:off x="4343400" y="2011680"/>
-            <a:ext cx="3429000" cy="2331720"/>
+            <a:ext cx="3429000" cy="1737360"/>
           </a:xfrm>
           <a:prstGeom prst="roundRect">
             <a:avLst>
-              <a:gd name="adj" fmla="val 3529"/>
+              <a:gd name="adj" fmla="val 4737"/>
             </a:avLst>
           </a:prstGeom>
           <a:solidFill>
@@ -17493,7 +17337,7 @@
       </p:sp>
       <p:sp>
         <p:nvSpPr>
-          <p:cNvPr id="10" name="Shape 8"/>
+          <p:cNvPr id="9" name="Shape 7"/>
           <p:cNvSpPr/>
           <p:nvPr/>
         </p:nvSpPr>
@@ -17518,7 +17362,7 @@
       </p:sp>
       <p:sp>
         <p:nvSpPr>
-          <p:cNvPr id="11" name="Text 9"/>
+          <p:cNvPr id="10" name="Text 8"/>
           <p:cNvSpPr txBox="1"/>
           <p:nvPr/>
         </p:nvSpPr>
@@ -17557,14 +17401,14 @@
       </p:sp>
       <p:sp>
         <p:nvSpPr>
-          <p:cNvPr id="12" name="Text 10"/>
-          <p:cNvSpPr txBox="1"/>
-          <p:nvPr/>
-        </p:nvSpPr>
-        <p:spPr>
-          <a:xfrm>
-            <a:off x="4572000" y="2971800"/>
-            <a:ext cx="2971800" cy="822960"/>
+          <p:cNvPr id="11" name="Text 9"/>
+          <p:cNvSpPr txBox="1"/>
+          <p:nvPr/>
+        </p:nvSpPr>
+        <p:spPr>
+          <a:xfrm>
+            <a:off x="4572000" y="2944368"/>
+            <a:ext cx="2971800" cy="731520"/>
           </a:xfrm>
           <a:prstGeom prst="rect">
             <a:avLst/>
@@ -17596,57 +17440,18 @@
       </p:sp>
       <p:sp>
         <p:nvSpPr>
-          <p:cNvPr id="13" name="Text 11"/>
-          <p:cNvSpPr txBox="1"/>
-          <p:nvPr/>
-        </p:nvSpPr>
-        <p:spPr>
-          <a:xfrm>
-            <a:off x="4572000" y="3794760"/>
-            <a:ext cx="2971800" cy="411480"/>
-          </a:xfrm>
-          <a:prstGeom prst="rect">
-            <a:avLst/>
-          </a:prstGeom>
-          <a:noFill/>
-          <a:ln/>
-        </p:spPr>
-        <p:txBody>
-          <a:bodyPr wrap="square" lIns="0" tIns="0" rIns="0" bIns="0" rtlCol="0" anchor="ctr"/>
-          <a:lstStyle/>
-          <a:p>
-            <a:pPr indent="0" marL="0">
-              <a:buNone/>
-            </a:pPr>
-            <a:r>
-              <a:rPr lang="en-US" sz="1300" i="1" dirty="0">
-                <a:solidFill>
-                  <a:srgbClr val="8A94A6"/>
-                </a:solidFill>
-                <a:latin typeface="Calibri" pitchFamily="34" charset="0"/>
-                <a:ea typeface="Calibri" pitchFamily="34" charset="-122"/>
-                <a:cs typeface="Calibri" pitchFamily="34" charset="-120"/>
-              </a:rPr>
-              <a:t>Fewer hands. Some laughter.</a:t>
-            </a:r>
-            <a:endParaRPr lang="en-US" sz="1300" dirty="0"/>
-          </a:p>
-        </p:txBody>
-      </p:sp>
-      <p:sp>
-        <p:nvSpPr>
-          <p:cNvPr id="14" name="Shape 12"/>
+          <p:cNvPr id="12" name="Shape 10"/>
           <p:cNvSpPr/>
           <p:nvPr/>
         </p:nvSpPr>
         <p:spPr>
           <a:xfrm>
             <a:off x="8046720" y="2011680"/>
-            <a:ext cx="3429000" cy="2331720"/>
+            <a:ext cx="3429000" cy="1737360"/>
           </a:xfrm>
           <a:prstGeom prst="roundRect">
             <a:avLst>
-              <a:gd name="adj" fmla="val 3529"/>
+              <a:gd name="adj" fmla="val 4737"/>
             </a:avLst>
           </a:prstGeom>
           <a:solidFill>
@@ -17662,7 +17467,7 @@
       </p:sp>
       <p:sp>
         <p:nvSpPr>
-          <p:cNvPr id="15" name="Shape 13"/>
+          <p:cNvPr id="13" name="Shape 11"/>
           <p:cNvSpPr/>
           <p:nvPr/>
         </p:nvSpPr>
@@ -17687,7 +17492,7 @@
       </p:sp>
       <p:sp>
         <p:nvSpPr>
-          <p:cNvPr id="16" name="Text 14"/>
+          <p:cNvPr id="14" name="Text 12"/>
           <p:cNvSpPr txBox="1"/>
           <p:nvPr/>
         </p:nvSpPr>
@@ -17726,14 +17531,14 @@
       </p:sp>
       <p:sp>
         <p:nvSpPr>
-          <p:cNvPr id="17" name="Text 15"/>
-          <p:cNvSpPr txBox="1"/>
-          <p:nvPr/>
-        </p:nvSpPr>
-        <p:spPr>
-          <a:xfrm>
-            <a:off x="8275320" y="2971800"/>
-            <a:ext cx="2971800" cy="822960"/>
+          <p:cNvPr id="15" name="Text 13"/>
+          <p:cNvSpPr txBox="1"/>
+          <p:nvPr/>
+        </p:nvSpPr>
+        <p:spPr>
+          <a:xfrm>
+            <a:off x="8275320" y="2944368"/>
+            <a:ext cx="2971800" cy="731520"/>
           </a:xfrm>
           <a:prstGeom prst="rect">
             <a:avLst/>
@@ -17765,52 +17570,13 @@
       </p:sp>
       <p:sp>
         <p:nvSpPr>
-          <p:cNvPr id="18" name="Text 16"/>
-          <p:cNvSpPr txBox="1"/>
-          <p:nvPr/>
-        </p:nvSpPr>
-        <p:spPr>
-          <a:xfrm>
-            <a:off x="8275320" y="3794760"/>
-            <a:ext cx="2971800" cy="411480"/>
-          </a:xfrm>
-          <a:prstGeom prst="rect">
-            <a:avLst/>
-          </a:prstGeom>
-          <a:noFill/>
-          <a:ln/>
-        </p:spPr>
-        <p:txBody>
-          <a:bodyPr wrap="square" lIns="0" tIns="0" rIns="0" bIns="0" rtlCol="0" anchor="ctr"/>
-          <a:lstStyle/>
-          <a:p>
-            <a:pPr indent="0" marL="0">
-              <a:buNone/>
-            </a:pPr>
-            <a:r>
-              <a:rPr lang="en-US" sz="1300" i="1" dirty="0">
-                <a:solidFill>
-                  <a:srgbClr val="8A94A6"/>
-                </a:solidFill>
-                <a:latin typeface="Calibri" pitchFamily="34" charset="0"/>
-                <a:ea typeface="Calibri" pitchFamily="34" charset="-122"/>
-                <a:cs typeface="Calibri" pitchFamily="34" charset="-120"/>
-              </a:rPr>
-              <a:t>Almost none.</a:t>
-            </a:r>
-            <a:endParaRPr lang="en-US" sz="1300" dirty="0"/>
-          </a:p>
-        </p:txBody>
-      </p:sp>
-      <p:sp>
-        <p:nvSpPr>
-          <p:cNvPr id="19" name="Shape 17"/>
+          <p:cNvPr id="16" name="Shape 14"/>
           <p:cNvSpPr/>
           <p:nvPr/>
         </p:nvSpPr>
         <p:spPr>
           <a:xfrm>
-            <a:off x="640080" y="4800600"/>
+            <a:off x="640080" y="4343400"/>
             <a:ext cx="10881360" cy="1051560"/>
           </a:xfrm>
           <a:prstGeom prst="roundRect">
@@ -17831,13 +17597,13 @@
       </p:sp>
       <p:sp>
         <p:nvSpPr>
-          <p:cNvPr id="20" name="Text 18"/>
-          <p:cNvSpPr txBox="1"/>
-          <p:nvPr/>
-        </p:nvSpPr>
-        <p:spPr>
-          <a:xfrm>
-            <a:off x="914400" y="4983480"/>
+          <p:cNvPr id="17" name="Text 15"/>
+          <p:cNvSpPr txBox="1"/>
+          <p:nvPr/>
+        </p:nvSpPr>
+        <p:spPr>
+          <a:xfrm>
+            <a:off x="914400" y="4526280"/>
             <a:ext cx="10332720" cy="731520"/>
           </a:xfrm>
           <a:prstGeom prst="rect">

</xml_diff>

<commit_message>
Record that parallelism has a ceiling
Measured over all 30 targets on a 10-core M1 Pro: --parallel=8 and --parallel=5
both average 141s, but 8 went red in 2 of 5 runs while 5 stayed green. The spec
that failed passes alone in 13s, so it is contention against Cypress's default
timeouts rather than a bug.

Worth saying out loud, because "just raise --parallel" is exactly what people
will try when they get home.
</commit_message>
<xml_diff>
--- a/talk/Scaling-E2E-Tests-with-Nx.pptx
+++ b/talk/Scaling-E2E-Tests-with-Nx.pptx
@@ -2074,7 +2074,7 @@
           <a:p>
             <a:r>
               <a:rPr lang="en-US" dirty="0"/>
-              <a:t>Good slide to leave up during questions. Items 3 and 4 both bit this repo on its first CI run — worth telling as war stories rather than reading out.</a:t>
+              <a:t>Good slide to leave up during questions. Items 3, 4 and 5 all bit this repo for real — worth telling as war stories rather than reading out. On item 2: five and eight came out at the same 141s mean, but eight failed two runs in five, and the spec that failed passes on its own in 13s. That is contention, not a bug — each atomized target is a Cypress process plus a browser, so the ceiling is well under your core count.</a:t>
             </a:r>
             <a:endParaRPr lang="en-US" dirty="0"/>
           </a:p>
@@ -14620,7 +14620,7 @@
                 <a:ea typeface="Cambria" pitchFamily="34" charset="-122"/>
                 <a:cs typeface="Cambria" pitchFamily="34" charset="-120"/>
               </a:rPr>
-              <a:t>Six things that will bite you</a:t>
+              <a:t>Seven things that will bite you</a:t>
             </a:r>
             <a:endParaRPr lang="en-US" sz="3800" dirty="0"/>
           </a:p>
@@ -14634,7 +14634,7 @@
         </p:nvSpPr>
         <p:spPr>
           <a:xfrm>
-            <a:off x="640080" y="1929384"/>
+            <a:off x="640080" y="1837944"/>
             <a:ext cx="365760" cy="365760"/>
           </a:xfrm>
           <a:prstGeom prst="ellipse">
@@ -14654,7 +14654,7 @@
         </p:nvSpPr>
         <p:spPr>
           <a:xfrm>
-            <a:off x="640080" y="1929384"/>
+            <a:off x="640080" y="1837944"/>
             <a:ext cx="365760" cy="365760"/>
           </a:xfrm>
           <a:prstGeom prst="rect">
@@ -14693,7 +14693,7 @@
         </p:nvSpPr>
         <p:spPr>
           <a:xfrm>
-            <a:off x="1188720" y="1874520"/>
+            <a:off x="1188720" y="1783080"/>
             <a:ext cx="4023360" cy="365760"/>
           </a:xfrm>
           <a:prstGeom prst="rect">
@@ -14732,7 +14732,7 @@
         </p:nvSpPr>
         <p:spPr>
           <a:xfrm>
-            <a:off x="5303520" y="1874520"/>
+            <a:off x="5303520" y="1783080"/>
             <a:ext cx="6217920" cy="457200"/>
           </a:xfrm>
           <a:prstGeom prst="rect">
@@ -14771,7 +14771,7 @@
         </p:nvSpPr>
         <p:spPr>
           <a:xfrm>
-            <a:off x="640080" y="2706624"/>
+            <a:off x="640080" y="2514600"/>
             <a:ext cx="365760" cy="365760"/>
           </a:xfrm>
           <a:prstGeom prst="ellipse">
@@ -14791,7 +14791,7 @@
         </p:nvSpPr>
         <p:spPr>
           <a:xfrm>
-            <a:off x="640080" y="2706624"/>
+            <a:off x="640080" y="2514600"/>
             <a:ext cx="365760" cy="365760"/>
           </a:xfrm>
           <a:prstGeom prst="rect">
@@ -14830,7 +14830,7 @@
         </p:nvSpPr>
         <p:spPr>
           <a:xfrm>
-            <a:off x="1188720" y="2651760"/>
+            <a:off x="1188720" y="2459736"/>
             <a:ext cx="4023360" cy="365760"/>
           </a:xfrm>
           <a:prstGeom prst="rect">
@@ -14855,7 +14855,7 @@
                 <a:ea typeface="Calibri" pitchFamily="34" charset="-122"/>
                 <a:cs typeface="Calibri" pitchFamily="34" charset="-120"/>
               </a:rPr>
-              <a:t>e2e-ci is gated on Nx 23</a:t>
+              <a:t>More parallel is not more faster</a:t>
             </a:r>
             <a:endParaRPr lang="en-US" sz="1600" dirty="0"/>
           </a:p>
@@ -14869,7 +14869,7 @@
         </p:nvSpPr>
         <p:spPr>
           <a:xfrm>
-            <a:off x="5303520" y="2651760"/>
+            <a:off x="5303520" y="2459736"/>
             <a:ext cx="6217920" cy="457200"/>
           </a:xfrm>
           <a:prstGeom prst="rect">
@@ -14894,7 +14894,7 @@
                 <a:ea typeface="Calibri" pitchFamily="34" charset="-122"/>
                 <a:cs typeface="Calibri" pitchFamily="34" charset="-120"/>
               </a:rPr>
-              <a:t>The wrapper needs Nx Cloud. The leaf targets do not.</a:t>
+              <a:t>On a 10-core laptop --parallel=8 was no quicker than 5, and went red 2 runs in 5. Each target is a browser too.</a:t>
             </a:r>
             <a:endParaRPr lang="en-US" sz="1400" dirty="0"/>
           </a:p>
@@ -14908,7 +14908,7 @@
         </p:nvSpPr>
         <p:spPr>
           <a:xfrm>
-            <a:off x="640080" y="3483864"/>
+            <a:off x="640080" y="3191256"/>
             <a:ext cx="365760" cy="365760"/>
           </a:xfrm>
           <a:prstGeom prst="ellipse">
@@ -14928,7 +14928,7 @@
         </p:nvSpPr>
         <p:spPr>
           <a:xfrm>
-            <a:off x="640080" y="3483864"/>
+            <a:off x="640080" y="3191256"/>
             <a:ext cx="365760" cy="365760"/>
           </a:xfrm>
           <a:prstGeom prst="rect">
@@ -14967,7 +14967,7 @@
         </p:nvSpPr>
         <p:spPr>
           <a:xfrm>
-            <a:off x="1188720" y="3429000"/>
+            <a:off x="1188720" y="3136392"/>
             <a:ext cx="4023360" cy="365760"/>
           </a:xfrm>
           <a:prstGeom prst="rect">
@@ -14992,7 +14992,7 @@
                 <a:ea typeface="Calibri" pitchFamily="34" charset="-122"/>
                 <a:cs typeface="Calibri" pitchFamily="34" charset="-120"/>
               </a:rPr>
-              <a:t>The cache is not in .nx/cache</a:t>
+              <a:t>e2e-ci is gated on Nx 23</a:t>
             </a:r>
             <a:endParaRPr lang="en-US" sz="1600" dirty="0"/>
           </a:p>
@@ -15006,7 +15006,7 @@
         </p:nvSpPr>
         <p:spPr>
           <a:xfrm>
-            <a:off x="5303520" y="3429000"/>
+            <a:off x="5303520" y="3136392"/>
             <a:ext cx="6217920" cy="457200"/>
           </a:xfrm>
           <a:prstGeom prst="rect">
@@ -15031,7 +15031,7 @@
                 <a:ea typeface="Calibri" pitchFamily="34" charset="-122"/>
                 <a:cs typeface="Calibri" pitchFamily="34" charset="-120"/>
               </a:rPr>
-              <a:t>Nx 23 puts it in ~/.nx/&lt;hash&gt;/cache. Every CI recipe online caches the wrong path.</a:t>
+              <a:t>The wrapper needs Nx Cloud. The leaf targets do not.</a:t>
             </a:r>
             <a:endParaRPr lang="en-US" sz="1400" dirty="0"/>
           </a:p>
@@ -15045,7 +15045,7 @@
         </p:nvSpPr>
         <p:spPr>
           <a:xfrm>
-            <a:off x="640080" y="4261104"/>
+            <a:off x="640080" y="3867912"/>
             <a:ext cx="365760" cy="365760"/>
           </a:xfrm>
           <a:prstGeom prst="ellipse">
@@ -15065,7 +15065,7 @@
         </p:nvSpPr>
         <p:spPr>
           <a:xfrm>
-            <a:off x="640080" y="4261104"/>
+            <a:off x="640080" y="3867912"/>
             <a:ext cx="365760" cy="365760"/>
           </a:xfrm>
           <a:prstGeom prst="rect">
@@ -15104,7 +15104,7 @@
         </p:nvSpPr>
         <p:spPr>
           <a:xfrm>
-            <a:off x="1188720" y="4206240"/>
+            <a:off x="1188720" y="3813048"/>
             <a:ext cx="4023360" cy="365760"/>
           </a:xfrm>
           <a:prstGeom prst="rect">
@@ -15129,7 +15129,7 @@
                 <a:ea typeface="Calibri" pitchFamily="34" charset="-122"/>
                 <a:cs typeface="Calibri" pitchFamily="34" charset="-120"/>
               </a:rPr>
-              <a:t>Parallel Cypress fights over :99</a:t>
+              <a:t>The cache is not in .nx/cache</a:t>
             </a:r>
             <a:endParaRPr lang="en-US" sz="1600" dirty="0"/>
           </a:p>
@@ -15143,7 +15143,7 @@
         </p:nvSpPr>
         <p:spPr>
           <a:xfrm>
-            <a:off x="5303520" y="4206240"/>
+            <a:off x="5303520" y="3813048"/>
             <a:ext cx="6217920" cy="457200"/>
           </a:xfrm>
           <a:prstGeom prst="rect">
@@ -15168,7 +15168,7 @@
                 <a:ea typeface="Calibri" pitchFamily="34" charset="-122"/>
                 <a:cs typeface="Calibri" pitchFamily="34" charset="-120"/>
               </a:rPr>
-              <a:t>Each process spawns its own Xvfb. Start one and export DISPLAY.</a:t>
+              <a:t>Nx 23 puts it in ~/.nx/&lt;hash&gt;/cache. Every CI recipe online caches the wrong path.</a:t>
             </a:r>
             <a:endParaRPr lang="en-US" sz="1400" dirty="0"/>
           </a:p>
@@ -15182,7 +15182,7 @@
         </p:nvSpPr>
         <p:spPr>
           <a:xfrm>
-            <a:off x="640080" y="5038344"/>
+            <a:off x="640080" y="4544568"/>
             <a:ext cx="365760" cy="365760"/>
           </a:xfrm>
           <a:prstGeom prst="ellipse">
@@ -15202,7 +15202,7 @@
         </p:nvSpPr>
         <p:spPr>
           <a:xfrm>
-            <a:off x="640080" y="5038344"/>
+            <a:off x="640080" y="4544568"/>
             <a:ext cx="365760" cy="365760"/>
           </a:xfrm>
           <a:prstGeom prst="rect">
@@ -15241,7 +15241,7 @@
         </p:nvSpPr>
         <p:spPr>
           <a:xfrm>
-            <a:off x="1188720" y="4983480"/>
+            <a:off x="1188720" y="4489704"/>
             <a:ext cx="4023360" cy="365760"/>
           </a:xfrm>
           <a:prstGeom prst="rect">
@@ -15266,7 +15266,7 @@
                 <a:ea typeface="Calibri" pitchFamily="34" charset="-122"/>
                 <a:cs typeface="Calibri" pitchFamily="34" charset="-120"/>
               </a:rPr>
-              <a:t>Cache the Cypress binary</a:t>
+              <a:t>Parallel Cypress fights over :99</a:t>
             </a:r>
             <a:endParaRPr lang="en-US" sz="1600" dirty="0"/>
           </a:p>
@@ -15280,7 +15280,7 @@
         </p:nvSpPr>
         <p:spPr>
           <a:xfrm>
-            <a:off x="5303520" y="4983480"/>
+            <a:off x="5303520" y="4489704"/>
             <a:ext cx="6217920" cy="457200"/>
           </a:xfrm>
           <a:prstGeom prst="rect">
@@ -15305,7 +15305,7 @@
                 <a:ea typeface="Calibri" pitchFamily="34" charset="-122"/>
                 <a:cs typeface="Calibri" pitchFamily="34" charset="-120"/>
               </a:rPr>
-              <a:t>Otherwise every CI shard re-downloads ~200 MB.</a:t>
+              <a:t>Each process spawns its own Xvfb. Start one and export DISPLAY.</a:t>
             </a:r>
             <a:endParaRPr lang="en-US" sz="1400" dirty="0"/>
           </a:p>
@@ -15319,7 +15319,7 @@
         </p:nvSpPr>
         <p:spPr>
           <a:xfrm>
-            <a:off x="640080" y="5815584"/>
+            <a:off x="640080" y="5221224"/>
             <a:ext cx="365760" cy="365760"/>
           </a:xfrm>
           <a:prstGeom prst="ellipse">
@@ -15339,7 +15339,7 @@
         </p:nvSpPr>
         <p:spPr>
           <a:xfrm>
-            <a:off x="640080" y="5815584"/>
+            <a:off x="640080" y="5221224"/>
             <a:ext cx="365760" cy="365760"/>
           </a:xfrm>
           <a:prstGeom prst="rect">
@@ -15378,7 +15378,7 @@
         </p:nvSpPr>
         <p:spPr>
           <a:xfrm>
-            <a:off x="1188720" y="5760720"/>
+            <a:off x="1188720" y="5166360"/>
             <a:ext cx="4023360" cy="365760"/>
           </a:xfrm>
           <a:prstGeom prst="rect">
@@ -15403,6 +15403,143 @@
                 <a:ea typeface="Calibri" pitchFamily="34" charset="-122"/>
                 <a:cs typeface="Calibri" pitchFamily="34" charset="-120"/>
               </a:rPr>
+              <a:t>Cache the Cypress binary</a:t>
+            </a:r>
+            <a:endParaRPr lang="en-US" sz="1600" dirty="0"/>
+          </a:p>
+        </p:txBody>
+      </p:sp>
+      <p:sp>
+        <p:nvSpPr>
+          <p:cNvPr id="27" name="Text 25"/>
+          <p:cNvSpPr txBox="1"/>
+          <p:nvPr/>
+        </p:nvSpPr>
+        <p:spPr>
+          <a:xfrm>
+            <a:off x="5303520" y="5166360"/>
+            <a:ext cx="6217920" cy="457200"/>
+          </a:xfrm>
+          <a:prstGeom prst="rect">
+            <a:avLst/>
+          </a:prstGeom>
+          <a:noFill/>
+          <a:ln/>
+        </p:spPr>
+        <p:txBody>
+          <a:bodyPr wrap="square" lIns="0" tIns="0" rIns="0" bIns="0" rtlCol="0" anchor="ctr"/>
+          <a:lstStyle/>
+          <a:p>
+            <a:pPr indent="0" marL="0">
+              <a:buNone/>
+            </a:pPr>
+            <a:r>
+              <a:rPr lang="en-US" sz="1400" dirty="0">
+                <a:solidFill>
+                  <a:srgbClr val="55607A"/>
+                </a:solidFill>
+                <a:latin typeface="Calibri" pitchFamily="34" charset="0"/>
+                <a:ea typeface="Calibri" pitchFamily="34" charset="-122"/>
+                <a:cs typeface="Calibri" pitchFamily="34" charset="-120"/>
+              </a:rPr>
+              <a:t>Otherwise every CI shard re-downloads ~200 MB.</a:t>
+            </a:r>
+            <a:endParaRPr lang="en-US" sz="1400" dirty="0"/>
+          </a:p>
+        </p:txBody>
+      </p:sp>
+      <p:sp>
+        <p:nvSpPr>
+          <p:cNvPr id="28" name="Shape 26"/>
+          <p:cNvSpPr/>
+          <p:nvPr/>
+        </p:nvSpPr>
+        <p:spPr>
+          <a:xfrm>
+            <a:off x="640080" y="5897880"/>
+            <a:ext cx="365760" cy="365760"/>
+          </a:xfrm>
+          <a:prstGeom prst="ellipse">
+            <a:avLst/>
+          </a:prstGeom>
+          <a:solidFill>
+            <a:srgbClr val="B45309"/>
+          </a:solidFill>
+          <a:ln/>
+        </p:spPr>
+      </p:sp>
+      <p:sp>
+        <p:nvSpPr>
+          <p:cNvPr id="29" name="Text 27"/>
+          <p:cNvSpPr txBox="1"/>
+          <p:nvPr/>
+        </p:nvSpPr>
+        <p:spPr>
+          <a:xfrm>
+            <a:off x="640080" y="5897880"/>
+            <a:ext cx="365760" cy="365760"/>
+          </a:xfrm>
+          <a:prstGeom prst="rect">
+            <a:avLst/>
+          </a:prstGeom>
+          <a:noFill/>
+          <a:ln/>
+        </p:spPr>
+        <p:txBody>
+          <a:bodyPr wrap="square" lIns="0" tIns="0" rIns="0" bIns="0" rtlCol="0" anchor="ctr"/>
+          <a:lstStyle/>
+          <a:p>
+            <a:pPr algn="ctr" indent="0" marL="0">
+              <a:buNone/>
+            </a:pPr>
+            <a:r>
+              <a:rPr lang="en-US" sz="1400" b="1" dirty="0">
+                <a:solidFill>
+                  <a:srgbClr val="FFFFFF"/>
+                </a:solidFill>
+                <a:latin typeface="Calibri" pitchFamily="34" charset="0"/>
+                <a:ea typeface="Calibri" pitchFamily="34" charset="-122"/>
+                <a:cs typeface="Calibri" pitchFamily="34" charset="-120"/>
+              </a:rPr>
+              <a:t>7</a:t>
+            </a:r>
+            <a:endParaRPr lang="en-US" sz="1400" dirty="0"/>
+          </a:p>
+        </p:txBody>
+      </p:sp>
+      <p:sp>
+        <p:nvSpPr>
+          <p:cNvPr id="30" name="Text 28"/>
+          <p:cNvSpPr txBox="1"/>
+          <p:nvPr/>
+        </p:nvSpPr>
+        <p:spPr>
+          <a:xfrm>
+            <a:off x="1188720" y="5843016"/>
+            <a:ext cx="4023360" cy="365760"/>
+          </a:xfrm>
+          <a:prstGeom prst="rect">
+            <a:avLst/>
+          </a:prstGeom>
+          <a:noFill/>
+          <a:ln/>
+        </p:spPr>
+        <p:txBody>
+          <a:bodyPr wrap="square" lIns="0" tIns="0" rIns="0" bIns="0" rtlCol="0" anchor="ctr"/>
+          <a:lstStyle/>
+          <a:p>
+            <a:pPr indent="0" marL="0">
+              <a:buNone/>
+            </a:pPr>
+            <a:r>
+              <a:rPr lang="en-US" sz="1600" b="1" dirty="0">
+                <a:solidFill>
+                  <a:srgbClr val="10131A"/>
+                </a:solidFill>
+                <a:latin typeface="Calibri" pitchFamily="34" charset="0"/>
+                <a:ea typeface="Calibri" pitchFamily="34" charset="-122"/>
+                <a:cs typeface="Calibri" pitchFamily="34" charset="-120"/>
+              </a:rPr>
               <a:t>App changes invalidate everything</a:t>
             </a:r>
             <a:endParaRPr lang="en-US" sz="1600" dirty="0"/>
@@ -15411,13 +15548,13 @@
       </p:sp>
       <p:sp>
         <p:nvSpPr>
-          <p:cNvPr id="27" name="Text 25"/>
-          <p:cNvSpPr txBox="1"/>
-          <p:nvPr/>
-        </p:nvSpPr>
-        <p:spPr>
-          <a:xfrm>
-            <a:off x="5303520" y="5760720"/>
+          <p:cNvPr id="31" name="Text 29"/>
+          <p:cNvSpPr txBox="1"/>
+          <p:nvPr/>
+        </p:nvSpPr>
+        <p:spPr>
+          <a:xfrm>
+            <a:off x="5303520" y="5843016"/>
             <a:ext cx="6217920" cy="457200"/>
           </a:xfrm>
           <a:prstGeom prst="rect">

</xml_diff>

<commit_message>
Show both machines on the ladder slide
Bars stay on the M1 Pro, because that is the laptop the live demo runs on and
the numbers should match what the room just watched. An M5 column sits beside
them for contrast.

The callout gains the inversion: on 18 cores rung 3 (48s) beats rung 4 (55s),
so distribution only pays once one machine runs out of cores. CI still needs
rung 4 — a CI runner is small.
</commit_message>
<xml_diff>
--- a/talk/Scaling-E2E-Tests-with-Nx.pptx
+++ b/talk/Scaling-E2E-Tests-with-Nx.pptx
@@ -1448,7 +1448,7 @@
           <a:p>
             <a:r>
               <a:rPr lang="en-US" dirty="0"/>
-              <a:t>The headline is 4m20s to 55s, but do not skip rung 2. Rung 3 is one flag and gets most of the win; rung 4 needs CI to have a matrix. Tell them to climb only as far as their pain justifies. Re-measure with npm run e2e:benchmark before the talk — rung 3 varied between 2m11s and 2m32s on repeats.
+              <a:t>The bars are this laptop — the same machine they just watched the demo on — so the numbers match what they saw. The right column is an 18-core M5 for contrast. Two things to land. One: rung 2 is slower than not splitting on both machines, 31% here and 22% there, so the startup tax is real and not a quirk of old hardware. Two: on the M5 rung 3 beats rung 4, 48s against 55s. More cores beat more machines until you run out of cores — which is why CI still needs rung 4, because a CI runner is small.
 DO NOT RUN THIS LIVE
   $ npm run e2e:benchmark
   ~15 minutes — it runs every rung from a cold cache.
@@ -10163,7 +10163,110 @@
         </p:nvSpPr>
         <p:spPr>
           <a:xfrm>
-            <a:off x="640080" y="1920240"/>
+            <a:off x="4617720" y="1627632"/>
+            <a:ext cx="4572000" cy="274320"/>
+          </a:xfrm>
+          <a:prstGeom prst="rect">
+            <a:avLst/>
+          </a:prstGeom>
+          <a:noFill/>
+          <a:ln/>
+        </p:spPr>
+        <p:txBody>
+          <a:bodyPr wrap="square" lIns="0" tIns="0" rIns="0" bIns="0" rtlCol="0" anchor="ctr"/>
+          <a:lstStyle/>
+          <a:p>
+            <a:pPr indent="0" marL="0">
+              <a:buNone/>
+            </a:pPr>
+            <a:r>
+              <a:rPr lang="en-US" sz="1100" b="1" spc="100" kern="0" dirty="0">
+                <a:solidFill>
+                  <a:srgbClr val="0B7A44"/>
+                </a:solidFill>
+                <a:latin typeface="Calibri" pitchFamily="34" charset="0"/>
+                <a:ea typeface="Calibri" pitchFamily="34" charset="-122"/>
+                <a:cs typeface="Calibri" pitchFamily="34" charset="-120"/>
+              </a:rPr>
+              <a:t>M1 PRO · 10 CORES · LIVE DEMO</a:t>
+            </a:r>
+            <a:endParaRPr lang="en-US" sz="1100" dirty="0"/>
+          </a:p>
+        </p:txBody>
+      </p:sp>
+      <p:sp>
+        <p:nvSpPr>
+          <p:cNvPr id="5" name="Text 3"/>
+          <p:cNvSpPr txBox="1"/>
+          <p:nvPr/>
+        </p:nvSpPr>
+        <p:spPr>
+          <a:xfrm>
+            <a:off x="10104120" y="1627632"/>
+            <a:ext cx="1645920" cy="274320"/>
+          </a:xfrm>
+          <a:prstGeom prst="rect">
+            <a:avLst/>
+          </a:prstGeom>
+          <a:noFill/>
+          <a:ln/>
+        </p:spPr>
+        <p:txBody>
+          <a:bodyPr wrap="square" lIns="0" tIns="0" rIns="0" bIns="0" rtlCol="0" anchor="ctr"/>
+          <a:lstStyle/>
+          <a:p>
+            <a:pPr indent="0" marL="0">
+              <a:buNone/>
+            </a:pPr>
+            <a:r>
+              <a:rPr lang="en-US" sz="1100" b="1" spc="100" kern="0" dirty="0">
+                <a:solidFill>
+                  <a:srgbClr val="8A94A6"/>
+                </a:solidFill>
+                <a:latin typeface="Calibri" pitchFamily="34" charset="0"/>
+                <a:ea typeface="Calibri" pitchFamily="34" charset="-122"/>
+                <a:cs typeface="Calibri" pitchFamily="34" charset="-120"/>
+              </a:rPr>
+              <a:t>M5 · 18 CORES</a:t>
+            </a:r>
+            <a:endParaRPr lang="en-US" sz="1100" dirty="0"/>
+          </a:p>
+        </p:txBody>
+      </p:sp>
+      <p:sp>
+        <p:nvSpPr>
+          <p:cNvPr id="6" name="Shape 4"/>
+          <p:cNvSpPr/>
+          <p:nvPr/>
+        </p:nvSpPr>
+        <p:spPr>
+          <a:xfrm>
+            <a:off x="9829800" y="1572768"/>
+            <a:ext cx="10973" cy="3886200"/>
+          </a:xfrm>
+          <a:prstGeom prst="rect">
+            <a:avLst/>
+          </a:prstGeom>
+          <a:solidFill>
+            <a:srgbClr val="E2E6ED"/>
+          </a:solidFill>
+          <a:ln w="12700">
+            <a:solidFill>
+              <a:srgbClr val="333333"/>
+            </a:solidFill>
+            <a:prstDash val="solid"/>
+          </a:ln>
+        </p:spPr>
+      </p:sp>
+      <p:sp>
+        <p:nvSpPr>
+          <p:cNvPr id="7" name="Text 5"/>
+          <p:cNvSpPr txBox="1"/>
+          <p:nvPr/>
+        </p:nvSpPr>
+        <p:spPr>
+          <a:xfrm>
+            <a:off x="640080" y="2011680"/>
             <a:ext cx="365760" cy="365760"/>
           </a:xfrm>
           <a:prstGeom prst="rect">
@@ -10196,14 +10299,14 @@
       </p:sp>
       <p:sp>
         <p:nvSpPr>
-          <p:cNvPr id="5" name="Text 3"/>
-          <p:cNvSpPr txBox="1"/>
-          <p:nvPr/>
-        </p:nvSpPr>
-        <p:spPr>
-          <a:xfrm>
-            <a:off x="1051560" y="1920240"/>
-            <a:ext cx="3657600" cy="365760"/>
+          <p:cNvPr id="8" name="Text 6"/>
+          <p:cNvSpPr txBox="1"/>
+          <p:nvPr/>
+        </p:nvSpPr>
+        <p:spPr>
+          <a:xfrm>
+            <a:off x="1051560" y="2011680"/>
+            <a:ext cx="3520440" cy="365760"/>
           </a:xfrm>
           <a:prstGeom prst="rect">
             <a:avLst/>
@@ -10235,14 +10338,14 @@
       </p:sp>
       <p:sp>
         <p:nvSpPr>
-          <p:cNvPr id="6" name="Shape 4"/>
+          <p:cNvPr id="9" name="Shape 7"/>
           <p:cNvSpPr/>
           <p:nvPr/>
         </p:nvSpPr>
         <p:spPr>
           <a:xfrm>
-            <a:off x="4754880" y="1984248"/>
-            <a:ext cx="4824805" cy="292608"/>
+            <a:off x="4617720" y="2075688"/>
+            <a:ext cx="3146612" cy="292608"/>
           </a:xfrm>
           <a:prstGeom prst="roundRect">
             <a:avLst>
@@ -10262,13 +10365,52 @@
       </p:sp>
       <p:sp>
         <p:nvSpPr>
-          <p:cNvPr id="7" name="Text 5"/>
-          <p:cNvSpPr txBox="1"/>
-          <p:nvPr/>
-        </p:nvSpPr>
-        <p:spPr>
-          <a:xfrm>
-            <a:off x="9671125" y="1920240"/>
+          <p:cNvPr id="10" name="Text 8"/>
+          <p:cNvSpPr txBox="1"/>
+          <p:nvPr/>
+        </p:nvSpPr>
+        <p:spPr>
+          <a:xfrm>
+            <a:off x="7855772" y="2011680"/>
+            <a:ext cx="1280160" cy="365760"/>
+          </a:xfrm>
+          <a:prstGeom prst="rect">
+            <a:avLst/>
+          </a:prstGeom>
+          <a:noFill/>
+          <a:ln/>
+        </p:spPr>
+        <p:txBody>
+          <a:bodyPr wrap="square" lIns="0" tIns="0" rIns="0" bIns="0" rtlCol="0" anchor="ctr"/>
+          <a:lstStyle/>
+          <a:p>
+            <a:pPr indent="0" marL="0">
+              <a:buNone/>
+            </a:pPr>
+            <a:r>
+              <a:rPr lang="en-US" sz="1400" b="1" dirty="0">
+                <a:solidFill>
+                  <a:srgbClr val="10131A"/>
+                </a:solidFill>
+                <a:latin typeface="Calibri" pitchFamily="34" charset="0"/>
+                <a:ea typeface="Calibri" pitchFamily="34" charset="-122"/>
+                <a:cs typeface="Calibri" pitchFamily="34" charset="-120"/>
+              </a:rPr>
+              <a:t>4m 20s</a:t>
+            </a:r>
+            <a:endParaRPr lang="en-US" sz="1400" dirty="0"/>
+          </a:p>
+        </p:txBody>
+      </p:sp>
+      <p:sp>
+        <p:nvSpPr>
+          <p:cNvPr id="11" name="Text 9"/>
+          <p:cNvSpPr txBox="1"/>
+          <p:nvPr/>
+        </p:nvSpPr>
+        <p:spPr>
+          <a:xfrm>
+            <a:off x="10104120" y="2011680"/>
             <a:ext cx="1371600" cy="365760"/>
           </a:xfrm>
           <a:prstGeom prst="rect">
@@ -10285,15 +10427,15 @@
               <a:buNone/>
             </a:pPr>
             <a:r>
-              <a:rPr lang="en-US" sz="1400" b="1" dirty="0">
-                <a:solidFill>
-                  <a:srgbClr val="10131A"/>
-                </a:solidFill>
-                <a:latin typeface="Calibri" pitchFamily="34" charset="0"/>
-                <a:ea typeface="Calibri" pitchFamily="34" charset="-122"/>
-                <a:cs typeface="Calibri" pitchFamily="34" charset="-120"/>
-              </a:rPr>
-              <a:t>4m 20s</a:t>
+              <a:rPr lang="en-US" sz="1400" dirty="0">
+                <a:solidFill>
+                  <a:srgbClr val="5C6675"/>
+                </a:solidFill>
+                <a:latin typeface="Calibri" pitchFamily="34" charset="0"/>
+                <a:ea typeface="Calibri" pitchFamily="34" charset="-122"/>
+                <a:cs typeface="Calibri" pitchFamily="34" charset="-120"/>
+              </a:rPr>
+              <a:t>3m 16s</a:t>
             </a:r>
             <a:endParaRPr lang="en-US" sz="1400" dirty="0"/>
           </a:p>
@@ -10301,13 +10443,13 @@
       </p:sp>
       <p:sp>
         <p:nvSpPr>
-          <p:cNvPr id="8" name="Text 6"/>
-          <p:cNvSpPr txBox="1"/>
-          <p:nvPr/>
-        </p:nvSpPr>
-        <p:spPr>
-          <a:xfrm>
-            <a:off x="640080" y="2670048"/>
+          <p:cNvPr id="12" name="Text 10"/>
+          <p:cNvSpPr txBox="1"/>
+          <p:nvPr/>
+        </p:nvSpPr>
+        <p:spPr>
+          <a:xfrm>
+            <a:off x="640080" y="2724912"/>
             <a:ext cx="365760" cy="365760"/>
           </a:xfrm>
           <a:prstGeom prst="rect">
@@ -10340,14 +10482,14 @@
       </p:sp>
       <p:sp>
         <p:nvSpPr>
-          <p:cNvPr id="9" name="Text 7"/>
-          <p:cNvSpPr txBox="1"/>
-          <p:nvPr/>
-        </p:nvSpPr>
-        <p:spPr>
-          <a:xfrm>
-            <a:off x="1051560" y="2670048"/>
-            <a:ext cx="3657600" cy="365760"/>
+          <p:cNvPr id="13" name="Text 11"/>
+          <p:cNvSpPr txBox="1"/>
+          <p:nvPr/>
+        </p:nvSpPr>
+        <p:spPr>
+          <a:xfrm>
+            <a:off x="1051560" y="2724912"/>
+            <a:ext cx="3520440" cy="365760"/>
           </a:xfrm>
           <a:prstGeom prst="rect">
             <a:avLst/>
@@ -10379,14 +10521,14 @@
       </p:sp>
       <p:sp>
         <p:nvSpPr>
-          <p:cNvPr id="10" name="Shape 8"/>
+          <p:cNvPr id="14" name="Shape 12"/>
           <p:cNvSpPr/>
           <p:nvPr/>
         </p:nvSpPr>
         <p:spPr>
           <a:xfrm>
-            <a:off x="4754880" y="2734056"/>
-            <a:ext cx="6309360" cy="292608"/>
+            <a:off x="4617720" y="2788920"/>
+            <a:ext cx="4114800" cy="292608"/>
           </a:xfrm>
           <a:prstGeom prst="roundRect">
             <a:avLst>
@@ -10406,13 +10548,52 @@
       </p:sp>
       <p:sp>
         <p:nvSpPr>
-          <p:cNvPr id="11" name="Text 9"/>
-          <p:cNvSpPr txBox="1"/>
-          <p:nvPr/>
-        </p:nvSpPr>
-        <p:spPr>
-          <a:xfrm>
-            <a:off x="11155680" y="2670048"/>
+          <p:cNvPr id="15" name="Text 13"/>
+          <p:cNvSpPr txBox="1"/>
+          <p:nvPr/>
+        </p:nvSpPr>
+        <p:spPr>
+          <a:xfrm>
+            <a:off x="8823960" y="2724912"/>
+            <a:ext cx="1280160" cy="365760"/>
+          </a:xfrm>
+          <a:prstGeom prst="rect">
+            <a:avLst/>
+          </a:prstGeom>
+          <a:noFill/>
+          <a:ln/>
+        </p:spPr>
+        <p:txBody>
+          <a:bodyPr wrap="square" lIns="0" tIns="0" rIns="0" bIns="0" rtlCol="0" anchor="ctr"/>
+          <a:lstStyle/>
+          <a:p>
+            <a:pPr indent="0" marL="0">
+              <a:buNone/>
+            </a:pPr>
+            <a:r>
+              <a:rPr lang="en-US" sz="1400" b="1" dirty="0">
+                <a:solidFill>
+                  <a:srgbClr val="10131A"/>
+                </a:solidFill>
+                <a:latin typeface="Calibri" pitchFamily="34" charset="0"/>
+                <a:ea typeface="Calibri" pitchFamily="34" charset="-122"/>
+                <a:cs typeface="Calibri" pitchFamily="34" charset="-120"/>
+              </a:rPr>
+              <a:t>5m 40s</a:t>
+            </a:r>
+            <a:endParaRPr lang="en-US" sz="1400" dirty="0"/>
+          </a:p>
+        </p:txBody>
+      </p:sp>
+      <p:sp>
+        <p:nvSpPr>
+          <p:cNvPr id="16" name="Text 14"/>
+          <p:cNvSpPr txBox="1"/>
+          <p:nvPr/>
+        </p:nvSpPr>
+        <p:spPr>
+          <a:xfrm>
+            <a:off x="10104120" y="2724912"/>
             <a:ext cx="1371600" cy="365760"/>
           </a:xfrm>
           <a:prstGeom prst="rect">
@@ -10429,15 +10610,15 @@
               <a:buNone/>
             </a:pPr>
             <a:r>
-              <a:rPr lang="en-US" sz="1400" b="1" dirty="0">
-                <a:solidFill>
-                  <a:srgbClr val="10131A"/>
-                </a:solidFill>
-                <a:latin typeface="Calibri" pitchFamily="34" charset="0"/>
-                <a:ea typeface="Calibri" pitchFamily="34" charset="-122"/>
-                <a:cs typeface="Calibri" pitchFamily="34" charset="-120"/>
-              </a:rPr>
-              <a:t>5m 40s</a:t>
+              <a:rPr lang="en-US" sz="1400" dirty="0">
+                <a:solidFill>
+                  <a:srgbClr val="5C6675"/>
+                </a:solidFill>
+                <a:latin typeface="Calibri" pitchFamily="34" charset="0"/>
+                <a:ea typeface="Calibri" pitchFamily="34" charset="-122"/>
+                <a:cs typeface="Calibri" pitchFamily="34" charset="-120"/>
+              </a:rPr>
+              <a:t>4m 00s</a:t>
             </a:r>
             <a:endParaRPr lang="en-US" sz="1400" dirty="0"/>
           </a:p>
@@ -10445,13 +10626,13 @@
       </p:sp>
       <p:sp>
         <p:nvSpPr>
-          <p:cNvPr id="12" name="Text 10"/>
-          <p:cNvSpPr txBox="1"/>
-          <p:nvPr/>
-        </p:nvSpPr>
-        <p:spPr>
-          <a:xfrm>
-            <a:off x="640080" y="3419856"/>
+          <p:cNvPr id="17" name="Text 15"/>
+          <p:cNvSpPr txBox="1"/>
+          <p:nvPr/>
+        </p:nvSpPr>
+        <p:spPr>
+          <a:xfrm>
+            <a:off x="640080" y="3438144"/>
             <a:ext cx="365760" cy="365760"/>
           </a:xfrm>
           <a:prstGeom prst="rect">
@@ -10484,14 +10665,14 @@
       </p:sp>
       <p:sp>
         <p:nvSpPr>
-          <p:cNvPr id="13" name="Text 11"/>
-          <p:cNvSpPr txBox="1"/>
-          <p:nvPr/>
-        </p:nvSpPr>
-        <p:spPr>
-          <a:xfrm>
-            <a:off x="1051560" y="3419856"/>
-            <a:ext cx="3657600" cy="365760"/>
+          <p:cNvPr id="18" name="Text 16"/>
+          <p:cNvSpPr txBox="1"/>
+          <p:nvPr/>
+        </p:nvSpPr>
+        <p:spPr>
+          <a:xfrm>
+            <a:off x="1051560" y="3438144"/>
+            <a:ext cx="3520440" cy="365760"/>
           </a:xfrm>
           <a:prstGeom prst="rect">
             <a:avLst/>
@@ -10515,7 +10696,7 @@
                 <a:ea typeface="Calibri" pitchFamily="34" charset="-122"/>
                 <a:cs typeface="Calibri" pitchFamily="34" charset="-120"/>
               </a:rPr>
-              <a:t>Atomized, 5 at a time, one machine</a:t>
+              <a:t>Atomized, half your cores at once</a:t>
             </a:r>
             <a:endParaRPr lang="en-US" sz="1300" dirty="0"/>
           </a:p>
@@ -10523,14 +10704,14 @@
       </p:sp>
       <p:sp>
         <p:nvSpPr>
-          <p:cNvPr id="14" name="Shape 12"/>
+          <p:cNvPr id="19" name="Shape 17"/>
           <p:cNvSpPr/>
           <p:nvPr/>
         </p:nvSpPr>
         <p:spPr>
           <a:xfrm>
-            <a:off x="4754880" y="3483864"/>
-            <a:ext cx="2597972" cy="292608"/>
+            <a:off x="4617720" y="3502152"/>
+            <a:ext cx="1694329" cy="292608"/>
           </a:xfrm>
           <a:prstGeom prst="roundRect">
             <a:avLst>
@@ -10550,13 +10731,52 @@
       </p:sp>
       <p:sp>
         <p:nvSpPr>
-          <p:cNvPr id="15" name="Text 13"/>
-          <p:cNvSpPr txBox="1"/>
-          <p:nvPr/>
-        </p:nvSpPr>
-        <p:spPr>
-          <a:xfrm>
-            <a:off x="7444292" y="3419856"/>
+          <p:cNvPr id="20" name="Text 18"/>
+          <p:cNvSpPr txBox="1"/>
+          <p:nvPr/>
+        </p:nvSpPr>
+        <p:spPr>
+          <a:xfrm>
+            <a:off x="6403489" y="3438144"/>
+            <a:ext cx="1280160" cy="365760"/>
+          </a:xfrm>
+          <a:prstGeom prst="rect">
+            <a:avLst/>
+          </a:prstGeom>
+          <a:noFill/>
+          <a:ln/>
+        </p:spPr>
+        <p:txBody>
+          <a:bodyPr wrap="square" lIns="0" tIns="0" rIns="0" bIns="0" rtlCol="0" anchor="ctr"/>
+          <a:lstStyle/>
+          <a:p>
+            <a:pPr indent="0" marL="0">
+              <a:buNone/>
+            </a:pPr>
+            <a:r>
+              <a:rPr lang="en-US" sz="1400" b="1" dirty="0">
+                <a:solidFill>
+                  <a:srgbClr val="10131A"/>
+                </a:solidFill>
+                <a:latin typeface="Calibri" pitchFamily="34" charset="0"/>
+                <a:ea typeface="Calibri" pitchFamily="34" charset="-122"/>
+                <a:cs typeface="Calibri" pitchFamily="34" charset="-120"/>
+              </a:rPr>
+              <a:t>2m 20s</a:t>
+            </a:r>
+            <a:endParaRPr lang="en-US" sz="1400" dirty="0"/>
+          </a:p>
+        </p:txBody>
+      </p:sp>
+      <p:sp>
+        <p:nvSpPr>
+          <p:cNvPr id="21" name="Text 19"/>
+          <p:cNvSpPr txBox="1"/>
+          <p:nvPr/>
+        </p:nvSpPr>
+        <p:spPr>
+          <a:xfrm>
+            <a:off x="10104120" y="3438144"/>
             <a:ext cx="1371600" cy="365760"/>
           </a:xfrm>
           <a:prstGeom prst="rect">
@@ -10575,13 +10795,13 @@
             <a:r>
               <a:rPr lang="en-US" sz="1400" b="1" dirty="0">
                 <a:solidFill>
-                  <a:srgbClr val="10131A"/>
-                </a:solidFill>
-                <a:latin typeface="Calibri" pitchFamily="34" charset="0"/>
-                <a:ea typeface="Calibri" pitchFamily="34" charset="-122"/>
-                <a:cs typeface="Calibri" pitchFamily="34" charset="-120"/>
-              </a:rPr>
-              <a:t>2m 20s</a:t>
+                  <a:srgbClr val="0B7A44"/>
+                </a:solidFill>
+                <a:latin typeface="Calibri" pitchFamily="34" charset="0"/>
+                <a:ea typeface="Calibri" pitchFamily="34" charset="-122"/>
+                <a:cs typeface="Calibri" pitchFamily="34" charset="-120"/>
+              </a:rPr>
+              <a:t>48s</a:t>
             </a:r>
             <a:endParaRPr lang="en-US" sz="1400" dirty="0"/>
           </a:p>
@@ -10589,13 +10809,13 @@
       </p:sp>
       <p:sp>
         <p:nvSpPr>
-          <p:cNvPr id="16" name="Text 14"/>
-          <p:cNvSpPr txBox="1"/>
-          <p:nvPr/>
-        </p:nvSpPr>
-        <p:spPr>
-          <a:xfrm>
-            <a:off x="640080" y="4169664"/>
+          <p:cNvPr id="22" name="Text 20"/>
+          <p:cNvSpPr txBox="1"/>
+          <p:nvPr/>
+        </p:nvSpPr>
+        <p:spPr>
+          <a:xfrm>
+            <a:off x="640080" y="4151376"/>
             <a:ext cx="365760" cy="365760"/>
           </a:xfrm>
           <a:prstGeom prst="rect">
@@ -10628,14 +10848,14 @@
       </p:sp>
       <p:sp>
         <p:nvSpPr>
-          <p:cNvPr id="17" name="Text 15"/>
-          <p:cNvSpPr txBox="1"/>
-          <p:nvPr/>
-        </p:nvSpPr>
-        <p:spPr>
-          <a:xfrm>
-            <a:off x="1051560" y="4169664"/>
-            <a:ext cx="3657600" cy="365760"/>
+          <p:cNvPr id="23" name="Text 21"/>
+          <p:cNvSpPr txBox="1"/>
+          <p:nvPr/>
+        </p:nvSpPr>
+        <p:spPr>
+          <a:xfrm>
+            <a:off x="1051560" y="4151376"/>
+            <a:ext cx="3520440" cy="365760"/>
           </a:xfrm>
           <a:prstGeom prst="rect">
             <a:avLst/>
@@ -10667,14 +10887,14 @@
       </p:sp>
       <p:sp>
         <p:nvSpPr>
-          <p:cNvPr id="18" name="Shape 16"/>
+          <p:cNvPr id="24" name="Shape 22"/>
           <p:cNvSpPr/>
           <p:nvPr/>
         </p:nvSpPr>
         <p:spPr>
           <a:xfrm>
-            <a:off x="4754880" y="4233672"/>
-            <a:ext cx="1020632" cy="292608"/>
+            <a:off x="4617720" y="4215384"/>
+            <a:ext cx="665629" cy="292608"/>
           </a:xfrm>
           <a:prstGeom prst="roundRect">
             <a:avLst>
@@ -10694,13 +10914,52 @@
       </p:sp>
       <p:sp>
         <p:nvSpPr>
-          <p:cNvPr id="19" name="Text 17"/>
-          <p:cNvSpPr txBox="1"/>
-          <p:nvPr/>
-        </p:nvSpPr>
-        <p:spPr>
-          <a:xfrm>
-            <a:off x="5866952" y="4169664"/>
+          <p:cNvPr id="25" name="Text 23"/>
+          <p:cNvSpPr txBox="1"/>
+          <p:nvPr/>
+        </p:nvSpPr>
+        <p:spPr>
+          <a:xfrm>
+            <a:off x="5374789" y="4151376"/>
+            <a:ext cx="1280160" cy="365760"/>
+          </a:xfrm>
+          <a:prstGeom prst="rect">
+            <a:avLst/>
+          </a:prstGeom>
+          <a:noFill/>
+          <a:ln/>
+        </p:spPr>
+        <p:txBody>
+          <a:bodyPr wrap="square" lIns="0" tIns="0" rIns="0" bIns="0" rtlCol="0" anchor="ctr"/>
+          <a:lstStyle/>
+          <a:p>
+            <a:pPr indent="0" marL="0">
+              <a:buNone/>
+            </a:pPr>
+            <a:r>
+              <a:rPr lang="en-US" sz="1400" b="1" dirty="0">
+                <a:solidFill>
+                  <a:srgbClr val="10131A"/>
+                </a:solidFill>
+                <a:latin typeface="Calibri" pitchFamily="34" charset="0"/>
+                <a:ea typeface="Calibri" pitchFamily="34" charset="-122"/>
+                <a:cs typeface="Calibri" pitchFamily="34" charset="-120"/>
+              </a:rPr>
+              <a:t>55s</a:t>
+            </a:r>
+            <a:endParaRPr lang="en-US" sz="1400" dirty="0"/>
+          </a:p>
+        </p:txBody>
+      </p:sp>
+      <p:sp>
+        <p:nvSpPr>
+          <p:cNvPr id="26" name="Text 24"/>
+          <p:cNvSpPr txBox="1"/>
+          <p:nvPr/>
+        </p:nvSpPr>
+        <p:spPr>
+          <a:xfrm>
+            <a:off x="10104120" y="4151376"/>
             <a:ext cx="1371600" cy="365760"/>
           </a:xfrm>
           <a:prstGeom prst="rect">
@@ -10717,9 +10976,9 @@
               <a:buNone/>
             </a:pPr>
             <a:r>
-              <a:rPr lang="en-US" sz="1400" b="1" dirty="0">
-                <a:solidFill>
-                  <a:srgbClr val="10131A"/>
+              <a:rPr lang="en-US" sz="1400" dirty="0">
+                <a:solidFill>
+                  <a:srgbClr val="5C6675"/>
                 </a:solidFill>
                 <a:latin typeface="Calibri" pitchFamily="34" charset="0"/>
                 <a:ea typeface="Calibri" pitchFamily="34" charset="-122"/>
@@ -10733,13 +10992,13 @@
       </p:sp>
       <p:sp>
         <p:nvSpPr>
-          <p:cNvPr id="20" name="Text 18"/>
-          <p:cNvSpPr txBox="1"/>
-          <p:nvPr/>
-        </p:nvSpPr>
-        <p:spPr>
-          <a:xfrm>
-            <a:off x="640080" y="4919472"/>
+          <p:cNvPr id="27" name="Text 25"/>
+          <p:cNvSpPr txBox="1"/>
+          <p:nvPr/>
+        </p:nvSpPr>
+        <p:spPr>
+          <a:xfrm>
+            <a:off x="640080" y="4864608"/>
             <a:ext cx="365760" cy="365760"/>
           </a:xfrm>
           <a:prstGeom prst="rect">
@@ -10772,14 +11031,14 @@
       </p:sp>
       <p:sp>
         <p:nvSpPr>
-          <p:cNvPr id="21" name="Text 19"/>
-          <p:cNvSpPr txBox="1"/>
-          <p:nvPr/>
-        </p:nvSpPr>
-        <p:spPr>
-          <a:xfrm>
-            <a:off x="1051560" y="4919472"/>
-            <a:ext cx="3657600" cy="365760"/>
+          <p:cNvPr id="28" name="Text 26"/>
+          <p:cNvSpPr txBox="1"/>
+          <p:nvPr/>
+        </p:nvSpPr>
+        <p:spPr>
+          <a:xfrm>
+            <a:off x="1051560" y="4864608"/>
+            <a:ext cx="3520440" cy="365760"/>
           </a:xfrm>
           <a:prstGeom prst="rect">
             <a:avLst/>
@@ -10811,18 +11070,18 @@
       </p:sp>
       <p:sp>
         <p:nvSpPr>
-          <p:cNvPr id="22" name="Shape 20"/>
+          <p:cNvPr id="29" name="Shape 27"/>
           <p:cNvSpPr/>
           <p:nvPr/>
         </p:nvSpPr>
         <p:spPr>
           <a:xfrm>
-            <a:off x="4754880" y="4983480"/>
-            <a:ext cx="92785" cy="292608"/>
+            <a:off x="4617720" y="4928616"/>
+            <a:ext cx="73152" cy="292608"/>
           </a:xfrm>
           <a:prstGeom prst="roundRect">
             <a:avLst>
-              <a:gd name="adj" fmla="val 39420"/>
+              <a:gd name="adj" fmla="val 50000"/>
             </a:avLst>
           </a:prstGeom>
           <a:solidFill>
@@ -10838,13 +11097,52 @@
       </p:sp>
       <p:sp>
         <p:nvSpPr>
-          <p:cNvPr id="23" name="Text 21"/>
-          <p:cNvSpPr txBox="1"/>
-          <p:nvPr/>
-        </p:nvSpPr>
-        <p:spPr>
-          <a:xfrm>
-            <a:off x="4939105" y="4919472"/>
+          <p:cNvPr id="30" name="Text 28"/>
+          <p:cNvSpPr txBox="1"/>
+          <p:nvPr/>
+        </p:nvSpPr>
+        <p:spPr>
+          <a:xfrm>
+            <a:off x="4782312" y="4864608"/>
+            <a:ext cx="1280160" cy="365760"/>
+          </a:xfrm>
+          <a:prstGeom prst="rect">
+            <a:avLst/>
+          </a:prstGeom>
+          <a:noFill/>
+          <a:ln/>
+        </p:spPr>
+        <p:txBody>
+          <a:bodyPr wrap="square" lIns="0" tIns="0" rIns="0" bIns="0" rtlCol="0" anchor="ctr"/>
+          <a:lstStyle/>
+          <a:p>
+            <a:pPr indent="0" marL="0">
+              <a:buNone/>
+            </a:pPr>
+            <a:r>
+              <a:rPr lang="en-US" sz="1400" b="1" dirty="0">
+                <a:solidFill>
+                  <a:srgbClr val="10131A"/>
+                </a:solidFill>
+                <a:latin typeface="Calibri" pitchFamily="34" charset="0"/>
+                <a:ea typeface="Calibri" pitchFamily="34" charset="-122"/>
+                <a:cs typeface="Calibri" pitchFamily="34" charset="-120"/>
+              </a:rPr>
+              <a:t>5s</a:t>
+            </a:r>
+            <a:endParaRPr lang="en-US" sz="1400" dirty="0"/>
+          </a:p>
+        </p:txBody>
+      </p:sp>
+      <p:sp>
+        <p:nvSpPr>
+          <p:cNvPr id="31" name="Text 29"/>
+          <p:cNvSpPr txBox="1"/>
+          <p:nvPr/>
+        </p:nvSpPr>
+        <p:spPr>
+          <a:xfrm>
+            <a:off x="10104120" y="4864608"/>
             <a:ext cx="1371600" cy="365760"/>
           </a:xfrm>
           <a:prstGeom prst="rect">
@@ -10861,9 +11159,9 @@
               <a:buNone/>
             </a:pPr>
             <a:r>
-              <a:rPr lang="en-US" sz="1400" b="1" dirty="0">
-                <a:solidFill>
-                  <a:srgbClr val="10131A"/>
+              <a:rPr lang="en-US" sz="1400" dirty="0">
+                <a:solidFill>
+                  <a:srgbClr val="5C6675"/>
                 </a:solidFill>
                 <a:latin typeface="Calibri" pitchFamily="34" charset="0"/>
                 <a:ea typeface="Calibri" pitchFamily="34" charset="-122"/>
@@ -10877,18 +11175,18 @@
       </p:sp>
       <p:sp>
         <p:nvSpPr>
-          <p:cNvPr id="24" name="Shape 22"/>
+          <p:cNvPr id="32" name="Shape 30"/>
           <p:cNvSpPr/>
           <p:nvPr/>
         </p:nvSpPr>
         <p:spPr>
           <a:xfrm>
-            <a:off x="640080" y="5760720"/>
-            <a:ext cx="10881360" cy="685800"/>
+            <a:off x="640080" y="5623560"/>
+            <a:ext cx="10881360" cy="914400"/>
           </a:xfrm>
           <a:prstGeom prst="roundRect">
             <a:avLst>
-              <a:gd name="adj" fmla="val 9333"/>
+              <a:gd name="adj" fmla="val 7000"/>
             </a:avLst>
           </a:prstGeom>
           <a:solidFill>
@@ -10904,30 +11202,33 @@
       </p:sp>
       <p:sp>
         <p:nvSpPr>
-          <p:cNvPr id="25" name="Text 23"/>
-          <p:cNvSpPr txBox="1"/>
-          <p:nvPr/>
-        </p:nvSpPr>
-        <p:spPr>
-          <a:xfrm>
-            <a:off x="914400" y="5916168"/>
-            <a:ext cx="10332720" cy="411480"/>
-          </a:xfrm>
-          <a:prstGeom prst="rect">
-            <a:avLst/>
-          </a:prstGeom>
-          <a:noFill/>
-          <a:ln/>
-        </p:spPr>
-        <p:txBody>
-          <a:bodyPr wrap="square" lIns="0" tIns="0" rIns="0" bIns="0" rtlCol="0" anchor="ctr"/>
-          <a:lstStyle/>
-          <a:p>
-            <a:pPr indent="0" marL="0">
-              <a:buNone/>
-            </a:pPr>
-            <a:r>
-              <a:rPr lang="en-US" sz="1400" dirty="0">
+          <p:cNvPr id="33" name="Text 31"/>
+          <p:cNvSpPr txBox="1"/>
+          <p:nvPr/>
+        </p:nvSpPr>
+        <p:spPr>
+          <a:xfrm>
+            <a:off x="914400" y="5760720"/>
+            <a:ext cx="10332720" cy="685800"/>
+          </a:xfrm>
+          <a:prstGeom prst="rect">
+            <a:avLst/>
+          </a:prstGeom>
+          <a:noFill/>
+          <a:ln/>
+        </p:spPr>
+        <p:txBody>
+          <a:bodyPr wrap="square" lIns="0" tIns="0" rIns="0" bIns="0" rtlCol="0" anchor="ctr"/>
+          <a:lstStyle/>
+          <a:p>
+            <a:pPr indent="0" marL="0">
+              <a:lnSpc>
+                <a:spcPct val="115000"/>
+              </a:lnSpc>
+              <a:buNone/>
+            </a:pPr>
+            <a:r>
+              <a:rPr lang="en-US" sz="1300" b="1" dirty="0">
                 <a:solidFill>
                   <a:srgbClr val="5B4308"/>
                 </a:solidFill>
@@ -10935,9 +11236,63 @@
                 <a:ea typeface="Calibri" pitchFamily="34" charset="-122"/>
                 <a:cs typeface="Calibri" pitchFamily="34" charset="-120"/>
               </a:rPr>
-              <a:t>Rung 2 is still the honest one: at 30 specs, atomizing without parallelism is 31% slower than not atomizing at all.</a:t>
-            </a:r>
-            <a:endParaRPr lang="en-US" sz="1400" dirty="0"/>
+              <a:t>Rung 2 is the honest one — </a:t>
+            </a:r>
+            <a:pPr indent="0" marL="0">
+              <a:lnSpc>
+                <a:spcPct val="115000"/>
+              </a:lnSpc>
+              <a:buNone/>
+            </a:pPr>
+            <a:r>
+              <a:rPr lang="en-US" sz="1300" dirty="0">
+                <a:solidFill>
+                  <a:srgbClr val="5B4308"/>
+                </a:solidFill>
+                <a:latin typeface="Calibri" pitchFamily="34" charset="0"/>
+                <a:ea typeface="Calibri" pitchFamily="34" charset="-122"/>
+                <a:cs typeface="Calibri" pitchFamily="34" charset="-120"/>
+              </a:rPr>
+              <a:t>atomizing without parallelism is slower than not atomizing at all. On both machines.</a:t>
+            </a:r>
+            <a:endParaRPr lang="en-US" sz="1300" dirty="0"/>
+          </a:p>
+          <a:p>
+            <a:pPr indent="0" marL="0">
+              <a:lnSpc>
+                <a:spcPct val="115000"/>
+              </a:lnSpc>
+              <a:buNone/>
+            </a:pPr>
+            <a:r>
+              <a:rPr lang="en-US" sz="1300" b="1" dirty="0">
+                <a:solidFill>
+                  <a:srgbClr val="5B4308"/>
+                </a:solidFill>
+                <a:latin typeface="Calibri" pitchFamily="34" charset="0"/>
+                <a:ea typeface="Calibri" pitchFamily="34" charset="-122"/>
+                <a:cs typeface="Calibri" pitchFamily="34" charset="-120"/>
+              </a:rPr>
+              <a:t>Rung 4 is not always a rung — </a:t>
+            </a:r>
+            <a:pPr indent="0" marL="0">
+              <a:lnSpc>
+                <a:spcPct val="115000"/>
+              </a:lnSpc>
+              <a:buNone/>
+            </a:pPr>
+            <a:r>
+              <a:rPr lang="en-US" sz="1300" dirty="0">
+                <a:solidFill>
+                  <a:srgbClr val="5B4308"/>
+                </a:solidFill>
+                <a:latin typeface="Calibri" pitchFamily="34" charset="0"/>
+                <a:ea typeface="Calibri" pitchFamily="34" charset="-122"/>
+                <a:cs typeface="Calibri" pitchFamily="34" charset="-120"/>
+              </a:rPr>
+              <a:t>on 18 cores, nine local processes beat three runners. Distribution pays once one machine runs out of cores.</a:t>
+            </a:r>
+            <a:endParaRPr lang="en-US" sz="1300" dirty="0"/>
           </a:p>
         </p:txBody>
       </p:sp>

</xml_diff>

<commit_message>
Record the all-cores M5 run, and stop overclaiming the ceiling
--parallel=18 on the 18-core M5 took the same 30 targets to 34s, against 48s at
9. The same move on the 10-core M1 cost speed and reliability, so the gotcha as
written was wrong: it is not that more parallel never helps, it is that the
ceiling is machine-specific.

Retitled to "Parallelism has a ceiling — find yours" and carrying both
measurements, since one alone misleads. Half your cores stays the default: safe
everywhere, optimal nowhere.
</commit_message>
<xml_diff>
--- a/talk/Scaling-E2E-Tests-with-Nx.pptx
+++ b/talk/Scaling-E2E-Tests-with-Nx.pptx
@@ -10242,7 +10242,7 @@
         <p:spPr>
           <a:xfrm>
             <a:off x="9829800" y="1572768"/>
-            <a:ext cx="10973" cy="3886200"/>
+            <a:ext cx="10973" cy="3703320"/>
           </a:xfrm>
           <a:prstGeom prst="rect">
             <a:avLst/>
@@ -11181,12 +11181,12 @@
         </p:nvSpPr>
         <p:spPr>
           <a:xfrm>
-            <a:off x="640080" y="5623560"/>
-            <a:ext cx="10881360" cy="914400"/>
+            <a:off x="640080" y="5440680"/>
+            <a:ext cx="10881360" cy="1170432"/>
           </a:xfrm>
           <a:prstGeom prst="roundRect">
             <a:avLst>
-              <a:gd name="adj" fmla="val 7000"/>
+              <a:gd name="adj" fmla="val 5469"/>
             </a:avLst>
           </a:prstGeom>
           <a:solidFill>
@@ -11208,8 +11208,8 @@
         </p:nvSpPr>
         <p:spPr>
           <a:xfrm>
-            <a:off x="914400" y="5760720"/>
-            <a:ext cx="10332720" cy="685800"/>
+            <a:off x="914400" y="5577840"/>
+            <a:ext cx="10332720" cy="914400"/>
           </a:xfrm>
           <a:prstGeom prst="rect">
             <a:avLst/>
@@ -11291,6 +11291,43 @@
                 <a:cs typeface="Calibri" pitchFamily="34" charset="-120"/>
               </a:rPr>
               <a:t>on 18 cores, nine local processes beat three runners. Distribution pays once one machine runs out of cores.</a:t>
+            </a:r>
+            <a:endParaRPr lang="en-US" sz="1300" dirty="0"/>
+          </a:p>
+          <a:p>
+            <a:pPr indent="0" marL="0">
+              <a:lnSpc>
+                <a:spcPct val="115000"/>
+              </a:lnSpc>
+              <a:buNone/>
+            </a:pPr>
+            <a:r>
+              <a:rPr lang="en-US" sz="1300" b="1" dirty="0">
+                <a:solidFill>
+                  <a:srgbClr val="5B4308"/>
+                </a:solidFill>
+                <a:latin typeface="Calibri" pitchFamily="34" charset="0"/>
+                <a:ea typeface="Calibri" pitchFamily="34" charset="-122"/>
+                <a:cs typeface="Calibri" pitchFamily="34" charset="-120"/>
+              </a:rPr>
+              <a:t>And the ceiling moves — </a:t>
+            </a:r>
+            <a:pPr indent="0" marL="0">
+              <a:lnSpc>
+                <a:spcPct val="115000"/>
+              </a:lnSpc>
+              <a:buNone/>
+            </a:pPr>
+            <a:r>
+              <a:rPr lang="en-US" sz="1300" dirty="0">
+                <a:solidFill>
+                  <a:srgbClr val="5B4308"/>
+                </a:solidFill>
+                <a:latin typeface="Calibri" pitchFamily="34" charset="0"/>
+                <a:ea typeface="Calibri" pitchFamily="34" charset="-122"/>
+                <a:cs typeface="Calibri" pitchFamily="34" charset="-120"/>
+              </a:rPr>
+              <a:t>the M5 at all 18 cores reached 34s, while this laptop got slower and flakier past 5. Measure your own.</a:t>
             </a:r>
             <a:endParaRPr lang="en-US" sz="1300" dirty="0"/>
           </a:p>
@@ -15210,7 +15247,7 @@
                 <a:ea typeface="Calibri" pitchFamily="34" charset="-122"/>
                 <a:cs typeface="Calibri" pitchFamily="34" charset="-120"/>
               </a:rPr>
-              <a:t>More parallel is not more faster</a:t>
+              <a:t>Parallelism has a ceiling — find yours</a:t>
             </a:r>
             <a:endParaRPr lang="en-US" sz="1600" dirty="0"/>
           </a:p>
@@ -15249,7 +15286,7 @@
                 <a:ea typeface="Calibri" pitchFamily="34" charset="-122"/>
                 <a:cs typeface="Calibri" pitchFamily="34" charset="-120"/>
               </a:rPr>
-              <a:t>On a 10-core laptop --parallel=8 was no quicker than 5, and went red 2 runs in 5. Each target is a browser too.</a:t>
+              <a:t>10-core M1: 8 was no faster than 5, and went red 2 runs in 5. 18-core M5: 18 beat 9 by 29%. Measure, do not assume.</a:t>
             </a:r>
             <a:endParaRPr lang="en-US" sz="1400" dirty="0"/>
           </a:p>

</xml_diff>

<commit_message>
Answer the Playwright question in the repo and the appendix
@nx/playwright has the same atomizer — verified against 23.2.0, not assumed:
same target naming, same nonAtomizedTarget marker behind the Nx Cloud gate, and
run-e2e.mjs needs no changes because it only reads the graph.

The honest part is that the trade is weaker. Cypress runs specs serially, which
is where most of the win here comes from; Playwright already has a worker pool,
so atomizing swaps it for one cold browser launch per target. What survives is
the cache, failure-only retries and affected — none of which Playwright has an
answer for.

New appendix slide in both decks, and a section in the README.
</commit_message>
<xml_diff>
--- a/talk/Scaling-E2E-Tests-with-Nx.pptx
+++ b/talk/Scaling-E2E-Tests-with-Nx.pptx
@@ -30,9 +30,10 @@
     <p:sldId id="278" r:id="rId24"/>
     <p:sldId id="279" r:id="rId25"/>
     <p:sldId id="280" r:id="rId26"/>
+    <p:sldId id="281" r:id="rId27"/>
   </p:sldIdLst>
   <p:notesMasterIdLst>
-    <p:notesMasterId r:id="rId27"/>
+    <p:notesMasterId r:id="rId28"/>
   </p:notesMasterIdLst>
   <p:sldSz cx="12192000" cy="6858000"/>
   <p:notesSz cx="6858000" cy="12192000"/>
@@ -2098,6 +2099,94 @@
             <a:fld id="{F7021451-1387-4CA6-816F-3879F97B5CBC}" type="slidenum">
               <a:rPr lang="en-US"/>
               <a:t>25</a:t>
+            </a:fld>
+            <a:endParaRPr lang="en-US"/>
+          </a:p>
+        </p:txBody>
+      </p:sp>
+    </p:spTree>
+    <p:extLst>
+      <p:ext uri="{BB962C8B-B14F-4D97-AF65-F5344CB8AC3E}">
+        <p14:creationId xmlns:p14="http://schemas.microsoft.com/office/powerpoint/2010/main" val="1024086991"/>
+      </p:ext>
+    </p:extLst>
+  </p:cSld>
+  <p:clrMapOvr>
+    <a:masterClrMapping/>
+  </p:clrMapOvr>
+</p:notes>
+</file>
+
+<file path=ppt/notesSlides/notesSlide26.xml><?xml version="1.0" encoding="utf-8"?>
+<p:notes xmlns:a="http://schemas.openxmlformats.org/drawingml/2006/main" xmlns:r="http://schemas.openxmlformats.org/officeDocument/2006/relationships" xmlns:p="http://schemas.openxmlformats.org/presentationml/2006/main">
+  <p:cSld>
+    <p:spTree>
+      <p:nvGrpSpPr>
+        <p:cNvPr id="1" name=""/>
+        <p:cNvGrpSpPr/>
+        <p:nvPr/>
+      </p:nvGrpSpPr>
+      <p:grpSpPr>
+        <a:xfrm>
+          <a:off x="0" y="0"/>
+          <a:ext cx="0" cy="0"/>
+          <a:chOff x="0" y="0"/>
+          <a:chExt cx="0" cy="0"/>
+        </a:xfrm>
+      </p:grpSpPr>
+      <p:sp>
+        <p:nvSpPr>
+          <p:cNvPr id="2" name="Slide Image Placeholder 1"/>
+          <p:cNvSpPr>
+            <a:spLocks noGrp="1" noRot="1" noChangeAspect="1"/>
+          </p:cNvSpPr>
+          <p:nvPr>
+            <p:ph type="sldImg"/>
+          </p:nvPr>
+        </p:nvSpPr>
+        <p:spPr/>
+      </p:sp>
+      <p:sp>
+        <p:nvSpPr>
+          <p:cNvPr id="3" name="Notes Placeholder 2"/>
+          <p:cNvSpPr>
+            <a:spLocks noGrp="1"/>
+          </p:cNvSpPr>
+          <p:nvPr>
+            <p:ph type="body" idx="1"/>
+          </p:nvPr>
+        </p:nvSpPr>
+        <p:spPr/>
+        <p:txBody>
+          <a:bodyPr/>
+          <a:lstStyle/>
+          <a:p>
+            <a:r>
+              <a:rPr lang="en-US" dirty="0"/>
+              <a:t>Checked against @nx/playwright 23.2.0 rather than from memory: the plugin builds target names as `${ciTargetName}--${relativeSpecFilePath}` and sets the same nonAtomizedTarget marker, which is what triggers the Nx Cloud refusal. One extra detail if someone digs: Playwright's plugin also emits an e2e-ci--wait-for-webserver target, because it coordinates the shared dev server across atomized runs differently from Cypress. If the questioner owns a Playwright suite, the honest advice is to take section 05 and skip section 04.</a:t>
+            </a:r>
+            <a:endParaRPr lang="en-US" dirty="0"/>
+          </a:p>
+        </p:txBody>
+      </p:sp>
+      <p:sp>
+        <p:nvSpPr>
+          <p:cNvPr id="4" name="Slide Number Placeholder 3"/>
+          <p:cNvSpPr>
+            <a:spLocks noGrp="1"/>
+          </p:cNvSpPr>
+          <p:nvPr>
+            <p:ph type="sldNum" sz="quarter" idx="10"/>
+          </p:nvPr>
+        </p:nvSpPr>
+        <p:spPr/>
+        <p:txBody>
+          <a:bodyPr/>
+          <a:lstStyle/>
+          <a:p>
+            <a:fld id="{F7021451-1387-4CA6-816F-3879F97B5CBC}" type="slidenum">
+              <a:rPr lang="en-US"/>
+              <a:t>26</a:t>
             </a:fld>
             <a:endParaRPr lang="en-US"/>
           </a:p>
@@ -15985,6 +16074,802 @@
 </p:sld>
 </file>
 
+<file path=ppt/slides/slide26.xml><?xml version="1.0" encoding="utf-8"?>
+<p:sld xmlns:a="http://schemas.openxmlformats.org/drawingml/2006/main" xmlns:r="http://schemas.openxmlformats.org/officeDocument/2006/relationships" xmlns:p="http://schemas.openxmlformats.org/presentationml/2006/main">
+  <p:cSld name="Slide 26">
+    <p:bg>
+      <p:bgPr>
+        <a:solidFill>
+          <a:srgbClr val="F7F8FA"/>
+        </a:solidFill>
+      </p:bgPr>
+    </p:bg>
+    <p:spTree>
+      <p:nvGrpSpPr>
+        <p:cNvPr id="1" name=""/>
+        <p:cNvGrpSpPr/>
+        <p:nvPr/>
+      </p:nvGrpSpPr>
+      <p:grpSpPr>
+        <a:xfrm>
+          <a:off x="0" y="0"/>
+          <a:ext cx="0" cy="0"/>
+          <a:chOff x="0" y="0"/>
+          <a:chExt cx="0" cy="0"/>
+        </a:xfrm>
+      </p:grpSpPr>
+      <p:sp>
+        <p:nvSpPr>
+          <p:cNvPr id="2" name="Text 0"/>
+          <p:cNvSpPr txBox="1"/>
+          <p:nvPr/>
+        </p:nvSpPr>
+        <p:spPr>
+          <a:xfrm>
+            <a:off x="640080" y="411480"/>
+            <a:ext cx="10881360" cy="274320"/>
+          </a:xfrm>
+          <a:prstGeom prst="rect">
+            <a:avLst/>
+          </a:prstGeom>
+          <a:noFill/>
+          <a:ln/>
+        </p:spPr>
+        <p:txBody>
+          <a:bodyPr wrap="square" lIns="0" tIns="0" rIns="0" bIns="0" rtlCol="0" anchor="ctr"/>
+          <a:lstStyle/>
+          <a:p>
+            <a:pPr indent="0" marL="0">
+              <a:buNone/>
+            </a:pPr>
+            <a:r>
+              <a:rPr lang="en-US" sz="1200" b="1" spc="250" kern="0" dirty="0">
+                <a:solidFill>
+                  <a:srgbClr val="B45309"/>
+                </a:solidFill>
+                <a:latin typeface="Calibri" pitchFamily="34" charset="0"/>
+                <a:ea typeface="Calibri" pitchFamily="34" charset="-122"/>
+                <a:cs typeface="Calibri" pitchFamily="34" charset="-120"/>
+              </a:rPr>
+              <a:t>APPENDIX · THE QUESTION THAT ALWAYS COMES</a:t>
+            </a:r>
+            <a:endParaRPr lang="en-US" sz="1200" dirty="0"/>
+          </a:p>
+        </p:txBody>
+      </p:sp>
+      <p:sp>
+        <p:nvSpPr>
+          <p:cNvPr id="3" name="Text 1"/>
+          <p:cNvSpPr txBox="1"/>
+          <p:nvPr/>
+        </p:nvSpPr>
+        <p:spPr>
+          <a:xfrm>
+            <a:off x="640080" y="749808"/>
+            <a:ext cx="10881360" cy="731520"/>
+          </a:xfrm>
+          <a:prstGeom prst="rect">
+            <a:avLst/>
+          </a:prstGeom>
+          <a:noFill/>
+          <a:ln/>
+        </p:spPr>
+        <p:txBody>
+          <a:bodyPr wrap="square" lIns="0" tIns="0" rIns="0" bIns="0" rtlCol="0" anchor="ctr"/>
+          <a:lstStyle/>
+          <a:p>
+            <a:pPr indent="0" marL="0">
+              <a:buNone/>
+            </a:pPr>
+            <a:r>
+              <a:rPr lang="en-US" sz="3800" b="1" dirty="0">
+                <a:solidFill>
+                  <a:srgbClr val="10131A"/>
+                </a:solidFill>
+                <a:latin typeface="Cambria" pitchFamily="34" charset="0"/>
+                <a:ea typeface="Cambria" pitchFamily="34" charset="-122"/>
+                <a:cs typeface="Cambria" pitchFamily="34" charset="-120"/>
+              </a:rPr>
+              <a:t>What about Playwright?</a:t>
+            </a:r>
+            <a:endParaRPr lang="en-US" sz="3800" dirty="0"/>
+          </a:p>
+        </p:txBody>
+      </p:sp>
+      <p:sp>
+        <p:nvSpPr>
+          <p:cNvPr id="4" name="Shape 2"/>
+          <p:cNvSpPr/>
+          <p:nvPr/>
+        </p:nvSpPr>
+        <p:spPr>
+          <a:xfrm>
+            <a:off x="640080" y="1828800"/>
+            <a:ext cx="5349240" cy="3200400"/>
+          </a:xfrm>
+          <a:prstGeom prst="roundRect">
+            <a:avLst>
+              <a:gd name="adj" fmla="val 2286"/>
+            </a:avLst>
+          </a:prstGeom>
+          <a:solidFill>
+            <a:srgbClr val="F1FAF5"/>
+          </a:solidFill>
+          <a:ln w="12700">
+            <a:solidFill>
+              <a:srgbClr val="0B7A44"/>
+            </a:solidFill>
+            <a:prstDash val="solid"/>
+          </a:ln>
+        </p:spPr>
+      </p:sp>
+      <p:sp>
+        <p:nvSpPr>
+          <p:cNvPr id="5" name="Text 3"/>
+          <p:cNvSpPr txBox="1"/>
+          <p:nvPr/>
+        </p:nvSpPr>
+        <p:spPr>
+          <a:xfrm>
+            <a:off x="914400" y="2011680"/>
+            <a:ext cx="4800600" cy="320040"/>
+          </a:xfrm>
+          <a:prstGeom prst="rect">
+            <a:avLst/>
+          </a:prstGeom>
+          <a:noFill/>
+          <a:ln/>
+        </p:spPr>
+        <p:txBody>
+          <a:bodyPr wrap="square" lIns="0" tIns="0" rIns="0" bIns="0" rtlCol="0" anchor="ctr"/>
+          <a:lstStyle/>
+          <a:p>
+            <a:pPr indent="0" marL="0">
+              <a:buNone/>
+            </a:pPr>
+            <a:r>
+              <a:rPr lang="en-US" sz="1600" b="1" dirty="0">
+                <a:solidFill>
+                  <a:srgbClr val="0B7A44"/>
+                </a:solidFill>
+                <a:latin typeface="Calibri" pitchFamily="34" charset="0"/>
+                <a:ea typeface="Calibri" pitchFamily="34" charset="-122"/>
+                <a:cs typeface="Calibri" pitchFamily="34" charset="-120"/>
+              </a:rPr>
+              <a:t>Carries over unchanged</a:t>
+            </a:r>
+            <a:endParaRPr lang="en-US" sz="1600" dirty="0"/>
+          </a:p>
+        </p:txBody>
+      </p:sp>
+      <p:sp>
+        <p:nvSpPr>
+          <p:cNvPr id="6" name="Shape 4"/>
+          <p:cNvSpPr/>
+          <p:nvPr/>
+        </p:nvSpPr>
+        <p:spPr>
+          <a:xfrm>
+            <a:off x="932688" y="2500884"/>
+            <a:ext cx="82296" cy="82296"/>
+          </a:xfrm>
+          <a:prstGeom prst="ellipse">
+            <a:avLst/>
+          </a:prstGeom>
+          <a:solidFill>
+            <a:srgbClr val="0B7A44"/>
+          </a:solidFill>
+          <a:ln w="12700">
+            <a:solidFill>
+              <a:srgbClr val="333333"/>
+            </a:solidFill>
+            <a:prstDash val="solid"/>
+          </a:ln>
+        </p:spPr>
+      </p:sp>
+      <p:sp>
+        <p:nvSpPr>
+          <p:cNvPr id="7" name="Text 5"/>
+          <p:cNvSpPr txBox="1"/>
+          <p:nvPr/>
+        </p:nvSpPr>
+        <p:spPr>
+          <a:xfrm>
+            <a:off x="1170432" y="2450592"/>
+            <a:ext cx="4526280" cy="566928"/>
+          </a:xfrm>
+          <a:prstGeom prst="rect">
+            <a:avLst/>
+          </a:prstGeom>
+          <a:noFill/>
+          <a:ln/>
+        </p:spPr>
+        <p:txBody>
+          <a:bodyPr wrap="square" lIns="0" tIns="0" rIns="0" bIns="0" rtlCol="0" anchor="t"/>
+          <a:lstStyle/>
+          <a:p>
+            <a:pPr indent="0" marL="0">
+              <a:buNone/>
+            </a:pPr>
+            <a:r>
+              <a:rPr lang="en-US" sz="1200" dirty="0">
+                <a:solidFill>
+                  <a:srgbClr val="10131A"/>
+                </a:solidFill>
+                <a:latin typeface="Calibri" pitchFamily="34" charset="0"/>
+                <a:ea typeface="Calibri" pitchFamily="34" charset="-122"/>
+                <a:cs typeface="Calibri" pitchFamily="34" charset="-120"/>
+              </a:rPr>
+              <a:t>@nx/playwright has the same atomizer — one target per spec file</a:t>
+            </a:r>
+            <a:endParaRPr lang="en-US" sz="1200" dirty="0"/>
+          </a:p>
+        </p:txBody>
+      </p:sp>
+      <p:sp>
+        <p:nvSpPr>
+          <p:cNvPr id="8" name="Shape 6"/>
+          <p:cNvSpPr/>
+          <p:nvPr/>
+        </p:nvSpPr>
+        <p:spPr>
+          <a:xfrm>
+            <a:off x="932688" y="3122676"/>
+            <a:ext cx="82296" cy="82296"/>
+          </a:xfrm>
+          <a:prstGeom prst="ellipse">
+            <a:avLst/>
+          </a:prstGeom>
+          <a:solidFill>
+            <a:srgbClr val="0B7A44"/>
+          </a:solidFill>
+          <a:ln w="12700">
+            <a:solidFill>
+              <a:srgbClr val="333333"/>
+            </a:solidFill>
+            <a:prstDash val="solid"/>
+          </a:ln>
+        </p:spPr>
+      </p:sp>
+      <p:sp>
+        <p:nvSpPr>
+          <p:cNvPr id="9" name="Text 7"/>
+          <p:cNvSpPr txBox="1"/>
+          <p:nvPr/>
+        </p:nvSpPr>
+        <p:spPr>
+          <a:xfrm>
+            <a:off x="1170432" y="3072384"/>
+            <a:ext cx="4526280" cy="566928"/>
+          </a:xfrm>
+          <a:prstGeom prst="rect">
+            <a:avLst/>
+          </a:prstGeom>
+          <a:noFill/>
+          <a:ln/>
+        </p:spPr>
+        <p:txBody>
+          <a:bodyPr wrap="square" lIns="0" tIns="0" rIns="0" bIns="0" rtlCol="0" anchor="t"/>
+          <a:lstStyle/>
+          <a:p>
+            <a:pPr indent="0" marL="0">
+              <a:buNone/>
+            </a:pPr>
+            <a:r>
+              <a:rPr lang="en-US" sz="1200" dirty="0">
+                <a:solidFill>
+                  <a:srgbClr val="10131A"/>
+                </a:solidFill>
+                <a:latin typeface="Calibri" pitchFamily="34" charset="0"/>
+                <a:ea typeface="Calibri" pitchFamily="34" charset="-122"/>
+                <a:cs typeface="Calibri" pitchFamily="34" charset="-120"/>
+              </a:rPr>
+              <a:t>Same names: e2e-ci--src/e2e/checkout.spec.ts</a:t>
+            </a:r>
+            <a:endParaRPr lang="en-US" sz="1200" dirty="0"/>
+          </a:p>
+        </p:txBody>
+      </p:sp>
+      <p:sp>
+        <p:nvSpPr>
+          <p:cNvPr id="10" name="Shape 8"/>
+          <p:cNvSpPr/>
+          <p:nvPr/>
+        </p:nvSpPr>
+        <p:spPr>
+          <a:xfrm>
+            <a:off x="932688" y="3744468"/>
+            <a:ext cx="82296" cy="82296"/>
+          </a:xfrm>
+          <a:prstGeom prst="ellipse">
+            <a:avLst/>
+          </a:prstGeom>
+          <a:solidFill>
+            <a:srgbClr val="0B7A44"/>
+          </a:solidFill>
+          <a:ln w="12700">
+            <a:solidFill>
+              <a:srgbClr val="333333"/>
+            </a:solidFill>
+            <a:prstDash val="solid"/>
+          </a:ln>
+        </p:spPr>
+      </p:sp>
+      <p:sp>
+        <p:nvSpPr>
+          <p:cNvPr id="11" name="Text 9"/>
+          <p:cNvSpPr txBox="1"/>
+          <p:nvPr/>
+        </p:nvSpPr>
+        <p:spPr>
+          <a:xfrm>
+            <a:off x="1170432" y="3694176"/>
+            <a:ext cx="4526280" cy="566928"/>
+          </a:xfrm>
+          <a:prstGeom prst="rect">
+            <a:avLst/>
+          </a:prstGeom>
+          <a:noFill/>
+          <a:ln/>
+        </p:spPr>
+        <p:txBody>
+          <a:bodyPr wrap="square" lIns="0" tIns="0" rIns="0" bIns="0" rtlCol="0" anchor="t"/>
+          <a:lstStyle/>
+          <a:p>
+            <a:pPr indent="0" marL="0">
+              <a:buNone/>
+            </a:pPr>
+            <a:r>
+              <a:rPr lang="en-US" sz="1200" dirty="0">
+                <a:solidFill>
+                  <a:srgbClr val="10131A"/>
+                </a:solidFill>
+                <a:latin typeface="Calibri" pitchFamily="34" charset="0"/>
+                <a:ea typeface="Calibri" pitchFamily="34" charset="-122"/>
+                <a:cs typeface="Calibri" pitchFamily="34" charset="-120"/>
+              </a:rPr>
+              <a:t>Same Nx Cloud gate on the e2e-ci wrapper</a:t>
+            </a:r>
+            <a:endParaRPr lang="en-US" sz="1200" dirty="0"/>
+          </a:p>
+        </p:txBody>
+      </p:sp>
+      <p:sp>
+        <p:nvSpPr>
+          <p:cNvPr id="12" name="Shape 10"/>
+          <p:cNvSpPr/>
+          <p:nvPr/>
+        </p:nvSpPr>
+        <p:spPr>
+          <a:xfrm>
+            <a:off x="932688" y="4366260"/>
+            <a:ext cx="82296" cy="82296"/>
+          </a:xfrm>
+          <a:prstGeom prst="ellipse">
+            <a:avLst/>
+          </a:prstGeom>
+          <a:solidFill>
+            <a:srgbClr val="0B7A44"/>
+          </a:solidFill>
+          <a:ln w="12700">
+            <a:solidFill>
+              <a:srgbClr val="333333"/>
+            </a:solidFill>
+            <a:prstDash val="solid"/>
+          </a:ln>
+        </p:spPr>
+      </p:sp>
+      <p:sp>
+        <p:nvSpPr>
+          <p:cNvPr id="13" name="Text 11"/>
+          <p:cNvSpPr txBox="1"/>
+          <p:nvPr/>
+        </p:nvSpPr>
+        <p:spPr>
+          <a:xfrm>
+            <a:off x="1170432" y="4315968"/>
+            <a:ext cx="4526280" cy="566928"/>
+          </a:xfrm>
+          <a:prstGeom prst="rect">
+            <a:avLst/>
+          </a:prstGeom>
+          <a:noFill/>
+          <a:ln/>
+        </p:spPr>
+        <p:txBody>
+          <a:bodyPr wrap="square" lIns="0" tIns="0" rIns="0" bIns="0" rtlCol="0" anchor="t"/>
+          <a:lstStyle/>
+          <a:p>
+            <a:pPr indent="0" marL="0">
+              <a:buNone/>
+            </a:pPr>
+            <a:r>
+              <a:rPr lang="en-US" sz="1200" dirty="0">
+                <a:solidFill>
+                  <a:srgbClr val="10131A"/>
+                </a:solidFill>
+                <a:latin typeface="Calibri" pitchFamily="34" charset="0"/>
+                <a:ea typeface="Calibri" pitchFamily="34" charset="-122"/>
+                <a:cs typeface="Calibri" pitchFamily="34" charset="-120"/>
+              </a:rPr>
+              <a:t>run-e2e.mjs needs no changes — it only reads the graph</a:t>
+            </a:r>
+            <a:endParaRPr lang="en-US" sz="1200" dirty="0"/>
+          </a:p>
+        </p:txBody>
+      </p:sp>
+      <p:sp>
+        <p:nvSpPr>
+          <p:cNvPr id="14" name="Shape 12"/>
+          <p:cNvSpPr/>
+          <p:nvPr/>
+        </p:nvSpPr>
+        <p:spPr>
+          <a:xfrm>
+            <a:off x="6263640" y="1828800"/>
+            <a:ext cx="5349240" cy="3200400"/>
+          </a:xfrm>
+          <a:prstGeom prst="roundRect">
+            <a:avLst>
+              <a:gd name="adj" fmla="val 2286"/>
+            </a:avLst>
+          </a:prstGeom>
+          <a:solidFill>
+            <a:srgbClr val="FFF7E6"/>
+          </a:solidFill>
+          <a:ln w="12700">
+            <a:solidFill>
+              <a:srgbClr val="B45309"/>
+            </a:solidFill>
+            <a:prstDash val="solid"/>
+          </a:ln>
+        </p:spPr>
+      </p:sp>
+      <p:sp>
+        <p:nvSpPr>
+          <p:cNvPr id="15" name="Text 13"/>
+          <p:cNvSpPr txBox="1"/>
+          <p:nvPr/>
+        </p:nvSpPr>
+        <p:spPr>
+          <a:xfrm>
+            <a:off x="6537960" y="2011680"/>
+            <a:ext cx="4800600" cy="320040"/>
+          </a:xfrm>
+          <a:prstGeom prst="rect">
+            <a:avLst/>
+          </a:prstGeom>
+          <a:noFill/>
+          <a:ln/>
+        </p:spPr>
+        <p:txBody>
+          <a:bodyPr wrap="square" lIns="0" tIns="0" rIns="0" bIns="0" rtlCol="0" anchor="ctr"/>
+          <a:lstStyle/>
+          <a:p>
+            <a:pPr indent="0" marL="0">
+              <a:buNone/>
+            </a:pPr>
+            <a:r>
+              <a:rPr lang="en-US" sz="1600" b="1" dirty="0">
+                <a:solidFill>
+                  <a:srgbClr val="B45309"/>
+                </a:solidFill>
+                <a:latin typeface="Calibri" pitchFamily="34" charset="0"/>
+                <a:ea typeface="Calibri" pitchFamily="34" charset="-122"/>
+                <a:cs typeface="Calibri" pitchFamily="34" charset="-120"/>
+              </a:rPr>
+              <a:t>What changes</a:t>
+            </a:r>
+            <a:endParaRPr lang="en-US" sz="1600" dirty="0"/>
+          </a:p>
+        </p:txBody>
+      </p:sp>
+      <p:sp>
+        <p:nvSpPr>
+          <p:cNvPr id="16" name="Shape 14"/>
+          <p:cNvSpPr/>
+          <p:nvPr/>
+        </p:nvSpPr>
+        <p:spPr>
+          <a:xfrm>
+            <a:off x="6556248" y="2500884"/>
+            <a:ext cx="82296" cy="82296"/>
+          </a:xfrm>
+          <a:prstGeom prst="ellipse">
+            <a:avLst/>
+          </a:prstGeom>
+          <a:solidFill>
+            <a:srgbClr val="B45309"/>
+          </a:solidFill>
+          <a:ln w="12700">
+            <a:solidFill>
+              <a:srgbClr val="333333"/>
+            </a:solidFill>
+            <a:prstDash val="solid"/>
+          </a:ln>
+        </p:spPr>
+      </p:sp>
+      <p:sp>
+        <p:nvSpPr>
+          <p:cNvPr id="17" name="Text 15"/>
+          <p:cNvSpPr txBox="1"/>
+          <p:nvPr/>
+        </p:nvSpPr>
+        <p:spPr>
+          <a:xfrm>
+            <a:off x="6793992" y="2450592"/>
+            <a:ext cx="4526280" cy="566928"/>
+          </a:xfrm>
+          <a:prstGeom prst="rect">
+            <a:avLst/>
+          </a:prstGeom>
+          <a:noFill/>
+          <a:ln/>
+        </p:spPr>
+        <p:txBody>
+          <a:bodyPr wrap="square" lIns="0" tIns="0" rIns="0" bIns="0" rtlCol="0" anchor="t"/>
+          <a:lstStyle/>
+          <a:p>
+            <a:pPr indent="0" marL="0">
+              <a:buNone/>
+            </a:pPr>
+            <a:r>
+              <a:rPr lang="en-US" sz="1200" dirty="0">
+                <a:solidFill>
+                  <a:srgbClr val="10131A"/>
+                </a:solidFill>
+                <a:latin typeface="Calibri" pitchFamily="34" charset="0"/>
+                <a:ea typeface="Calibri" pitchFamily="34" charset="-122"/>
+                <a:cs typeface="Calibri" pitchFamily="34" charset="-120"/>
+              </a:rPr>
+              <a:t>Playwright already runs spec files across worker processes. Cypress does not — that gap is most of the win here</a:t>
+            </a:r>
+            <a:endParaRPr lang="en-US" sz="1200" dirty="0"/>
+          </a:p>
+        </p:txBody>
+      </p:sp>
+      <p:sp>
+        <p:nvSpPr>
+          <p:cNvPr id="18" name="Shape 16"/>
+          <p:cNvSpPr/>
+          <p:nvPr/>
+        </p:nvSpPr>
+        <p:spPr>
+          <a:xfrm>
+            <a:off x="6556248" y="3122676"/>
+            <a:ext cx="82296" cy="82296"/>
+          </a:xfrm>
+          <a:prstGeom prst="ellipse">
+            <a:avLst/>
+          </a:prstGeom>
+          <a:solidFill>
+            <a:srgbClr val="B45309"/>
+          </a:solidFill>
+          <a:ln w="12700">
+            <a:solidFill>
+              <a:srgbClr val="333333"/>
+            </a:solidFill>
+            <a:prstDash val="solid"/>
+          </a:ln>
+        </p:spPr>
+      </p:sp>
+      <p:sp>
+        <p:nvSpPr>
+          <p:cNvPr id="19" name="Text 17"/>
+          <p:cNvSpPr txBox="1"/>
+          <p:nvPr/>
+        </p:nvSpPr>
+        <p:spPr>
+          <a:xfrm>
+            <a:off x="6793992" y="3072384"/>
+            <a:ext cx="4526280" cy="566928"/>
+          </a:xfrm>
+          <a:prstGeom prst="rect">
+            <a:avLst/>
+          </a:prstGeom>
+          <a:noFill/>
+          <a:ln/>
+        </p:spPr>
+        <p:txBody>
+          <a:bodyPr wrap="square" lIns="0" tIns="0" rIns="0" bIns="0" rtlCol="0" anchor="t"/>
+          <a:lstStyle/>
+          <a:p>
+            <a:pPr indent="0" marL="0">
+              <a:buNone/>
+            </a:pPr>
+            <a:r>
+              <a:rPr lang="en-US" sz="1200" dirty="0">
+                <a:solidFill>
+                  <a:srgbClr val="10131A"/>
+                </a:solidFill>
+                <a:latin typeface="Calibri" pitchFamily="34" charset="0"/>
+                <a:ea typeface="Calibri" pitchFamily="34" charset="-122"/>
+                <a:cs typeface="Calibri" pitchFamily="34" charset="-120"/>
+              </a:rPr>
+              <a:t>Atomizing swaps that warm pool for one cold browser launch per target</a:t>
+            </a:r>
+            <a:endParaRPr lang="en-US" sz="1200" dirty="0"/>
+          </a:p>
+        </p:txBody>
+      </p:sp>
+      <p:sp>
+        <p:nvSpPr>
+          <p:cNvPr id="20" name="Shape 18"/>
+          <p:cNvSpPr/>
+          <p:nvPr/>
+        </p:nvSpPr>
+        <p:spPr>
+          <a:xfrm>
+            <a:off x="6556248" y="3744468"/>
+            <a:ext cx="82296" cy="82296"/>
+          </a:xfrm>
+          <a:prstGeom prst="ellipse">
+            <a:avLst/>
+          </a:prstGeom>
+          <a:solidFill>
+            <a:srgbClr val="B45309"/>
+          </a:solidFill>
+          <a:ln w="12700">
+            <a:solidFill>
+              <a:srgbClr val="333333"/>
+            </a:solidFill>
+            <a:prstDash val="solid"/>
+          </a:ln>
+        </p:spPr>
+      </p:sp>
+      <p:sp>
+        <p:nvSpPr>
+          <p:cNvPr id="21" name="Text 19"/>
+          <p:cNvSpPr txBox="1"/>
+          <p:nvPr/>
+        </p:nvSpPr>
+        <p:spPr>
+          <a:xfrm>
+            <a:off x="6793992" y="3694176"/>
+            <a:ext cx="4526280" cy="566928"/>
+          </a:xfrm>
+          <a:prstGeom prst="rect">
+            <a:avLst/>
+          </a:prstGeom>
+          <a:noFill/>
+          <a:ln/>
+        </p:spPr>
+        <p:txBody>
+          <a:bodyPr wrap="square" lIns="0" tIns="0" rIns="0" bIns="0" rtlCol="0" anchor="t"/>
+          <a:lstStyle/>
+          <a:p>
+            <a:pPr indent="0" marL="0">
+              <a:buNone/>
+            </a:pPr>
+            <a:r>
+              <a:rPr lang="en-US" sz="1200" dirty="0">
+                <a:solidFill>
+                  <a:srgbClr val="10131A"/>
+                </a:solidFill>
+                <a:latin typeface="Calibri" pitchFamily="34" charset="0"/>
+                <a:ea typeface="Calibri" pitchFamily="34" charset="-122"/>
+                <a:cs typeface="Calibri" pitchFamily="34" charset="-120"/>
+              </a:rPr>
+              <a:t>Playwright ships native --shard, so rung 4 needs no Nx either</a:t>
+            </a:r>
+            <a:endParaRPr lang="en-US" sz="1200" dirty="0"/>
+          </a:p>
+        </p:txBody>
+      </p:sp>
+      <p:sp>
+        <p:nvSpPr>
+          <p:cNvPr id="22" name="Shape 20"/>
+          <p:cNvSpPr/>
+          <p:nvPr/>
+        </p:nvSpPr>
+        <p:spPr>
+          <a:xfrm>
+            <a:off x="640080" y="5212080"/>
+            <a:ext cx="10881360" cy="1097280"/>
+          </a:xfrm>
+          <a:prstGeom prst="roundRect">
+            <a:avLst>
+              <a:gd name="adj" fmla="val 5833"/>
+            </a:avLst>
+          </a:prstGeom>
+          <a:solidFill>
+            <a:srgbClr val="FFFFFF"/>
+          </a:solidFill>
+          <a:ln w="12700">
+            <a:solidFill>
+              <a:srgbClr val="E2E6ED"/>
+            </a:solidFill>
+            <a:prstDash val="solid"/>
+          </a:ln>
+        </p:spPr>
+      </p:sp>
+      <p:sp>
+        <p:nvSpPr>
+          <p:cNvPr id="23" name="Text 21"/>
+          <p:cNvSpPr txBox="1"/>
+          <p:nvPr/>
+        </p:nvSpPr>
+        <p:spPr>
+          <a:xfrm>
+            <a:off x="914400" y="5349240"/>
+            <a:ext cx="10332720" cy="868680"/>
+          </a:xfrm>
+          <a:prstGeom prst="rect">
+            <a:avLst/>
+          </a:prstGeom>
+          <a:noFill/>
+          <a:ln/>
+        </p:spPr>
+        <p:txBody>
+          <a:bodyPr wrap="square" lIns="0" tIns="0" rIns="0" bIns="0" rtlCol="0" anchor="t"/>
+          <a:lstStyle/>
+          <a:p>
+            <a:pPr indent="0" marL="0">
+              <a:lnSpc>
+                <a:spcPct val="115000"/>
+              </a:lnSpc>
+              <a:buNone/>
+            </a:pPr>
+            <a:r>
+              <a:rPr lang="en-US" sz="1300" b="1" dirty="0">
+                <a:solidFill>
+                  <a:srgbClr val="10131A"/>
+                </a:solidFill>
+                <a:latin typeface="Calibri" pitchFamily="34" charset="0"/>
+                <a:ea typeface="Calibri" pitchFamily="34" charset="-122"/>
+                <a:cs typeface="Calibri" pitchFamily="34" charset="-120"/>
+              </a:rPr>
+              <a:t>The short answer — </a:t>
+            </a:r>
+            <a:pPr indent="0" marL="0">
+              <a:lnSpc>
+                <a:spcPct val="115000"/>
+              </a:lnSpc>
+              <a:buNone/>
+            </a:pPr>
+            <a:r>
+              <a:rPr lang="en-US" sz="1300" dirty="0">
+                <a:solidFill>
+                  <a:srgbClr val="10131A"/>
+                </a:solidFill>
+                <a:latin typeface="Calibri" pitchFamily="34" charset="0"/>
+                <a:ea typeface="Calibri" pitchFamily="34" charset="-122"/>
+                <a:cs typeface="Calibri" pitchFamily="34" charset="-120"/>
+              </a:rPr>
+              <a:t>on Cypress the atomizer buys you parallelism and caching. On Playwright it mostly buys caching, because the parallelism was already there.</a:t>
+            </a:r>
+            <a:endParaRPr lang="en-US" sz="1300" dirty="0"/>
+          </a:p>
+          <a:p>
+            <a:pPr indent="0" marL="0">
+              <a:lnSpc>
+                <a:spcPct val="115000"/>
+              </a:lnSpc>
+              <a:buNone/>
+            </a:pPr>
+            <a:r>
+              <a:rPr lang="en-US" sz="1300" dirty="0">
+                <a:solidFill>
+                  <a:srgbClr val="5C6675"/>
+                </a:solidFill>
+                <a:latin typeface="Calibri" pitchFamily="34" charset="0"/>
+                <a:ea typeface="Calibri" pitchFamily="34" charset="-122"/>
+                <a:cs typeface="Calibri" pitchFamily="34" charset="-120"/>
+              </a:rPr>
+              <a:t>Still worth it: the cache and failure-only retries have no Playwright equivalent, and affected does not care which runner you use. Measure before you trade away the worker pool.</a:t>
+            </a:r>
+            <a:endParaRPr lang="en-US" sz="1300" dirty="0"/>
+          </a:p>
+        </p:txBody>
+      </p:sp>
+    </p:spTree>
+  </p:cSld>
+  <p:clrMapOvr>
+    <a:masterClrMapping/>
+  </p:clrMapOvr>
+</p:sld>
+</file>
+
 <file path=ppt/slides/slide3.xml><?xml version="1.0" encoding="utf-8"?>
 <p:sld xmlns:a="http://schemas.openxmlformats.org/drawingml/2006/main" xmlns:r="http://schemas.openxmlformats.org/officeDocument/2006/relationships" xmlns:p="http://schemas.openxmlformats.org/presentationml/2006/main">
   <p:cSld name="Slide 3">

</xml_diff>

<commit_message>
Add a prepared-answers slide to the appendix
Ten questions the talk invites, with answers, two columns. Reference material
for the presenter rather than something to show — the speaker notes say so, and
flag which three actually come up.

Answers stay honest where it costs something: Nx Cloud is often the right
purchase, the cache does not fix flakes, and parallel-safe test data is a bigger
job than any of the configuration in this talk.
</commit_message>
<xml_diff>
--- a/talk/Scaling-E2E-Tests-with-Nx.pptx
+++ b/talk/Scaling-E2E-Tests-with-Nx.pptx
@@ -31,9 +31,10 @@
     <p:sldId id="279" r:id="rId25"/>
     <p:sldId id="280" r:id="rId26"/>
     <p:sldId id="281" r:id="rId27"/>
+    <p:sldId id="282" r:id="rId28"/>
   </p:sldIdLst>
   <p:notesMasterIdLst>
-    <p:notesMasterId r:id="rId28"/>
+    <p:notesMasterId r:id="rId29"/>
   </p:notesMasterIdLst>
   <p:sldSz cx="12192000" cy="6858000"/>
   <p:notesSz cx="6858000" cy="12192000"/>
@@ -2187,6 +2188,94 @@
             <a:fld id="{F7021451-1387-4CA6-816F-3879F97B5CBC}" type="slidenum">
               <a:rPr lang="en-US"/>
               <a:t>26</a:t>
+            </a:fld>
+            <a:endParaRPr lang="en-US"/>
+          </a:p>
+        </p:txBody>
+      </p:sp>
+    </p:spTree>
+    <p:extLst>
+      <p:ext uri="{BB962C8B-B14F-4D97-AF65-F5344CB8AC3E}">
+        <p14:creationId xmlns:p14="http://schemas.microsoft.com/office/powerpoint/2010/main" val="1024086991"/>
+      </p:ext>
+    </p:extLst>
+  </p:cSld>
+  <p:clrMapOvr>
+    <a:masterClrMapping/>
+  </p:clrMapOvr>
+</p:notes>
+</file>
+
+<file path=ppt/notesSlides/notesSlide27.xml><?xml version="1.0" encoding="utf-8"?>
+<p:notes xmlns:a="http://schemas.openxmlformats.org/drawingml/2006/main" xmlns:r="http://schemas.openxmlformats.org/officeDocument/2006/relationships" xmlns:p="http://schemas.openxmlformats.org/presentationml/2006/main">
+  <p:cSld>
+    <p:spTree>
+      <p:nvGrpSpPr>
+        <p:cNvPr id="1" name=""/>
+        <p:cNvGrpSpPr/>
+        <p:nvPr/>
+      </p:nvGrpSpPr>
+      <p:grpSpPr>
+        <a:xfrm>
+          <a:off x="0" y="0"/>
+          <a:ext cx="0" cy="0"/>
+          <a:chOff x="0" y="0"/>
+          <a:chExt cx="0" cy="0"/>
+        </a:xfrm>
+      </p:grpSpPr>
+      <p:sp>
+        <p:nvSpPr>
+          <p:cNvPr id="2" name="Slide Image Placeholder 1"/>
+          <p:cNvSpPr>
+            <a:spLocks noGrp="1" noRot="1" noChangeAspect="1"/>
+          </p:cNvSpPr>
+          <p:nvPr>
+            <p:ph type="sldImg"/>
+          </p:nvPr>
+        </p:nvSpPr>
+        <p:spPr/>
+      </p:sp>
+      <p:sp>
+        <p:nvSpPr>
+          <p:cNvPr id="3" name="Notes Placeholder 2"/>
+          <p:cNvSpPr>
+            <a:spLocks noGrp="1"/>
+          </p:cNvSpPr>
+          <p:nvPr>
+            <p:ph type="body" idx="1"/>
+          </p:nvPr>
+        </p:nvSpPr>
+        <p:spPr/>
+        <p:txBody>
+          <a:bodyPr/>
+          <a:lstStyle/>
+          <a:p>
+            <a:r>
+              <a:rPr lang="en-US" dirty="0"/>
+              <a:t>Reference only — do not present this, it is for you when a question lands. Numbers 1, 4 and 9 are the ones that actually come up. On 1: do not be defensive, Nx Cloud is a good product and the talk only claims the free tier is unclaimed. On 8: this is the honest answer that separates people who have done it from people who have read about it — parallel-safe test data is the real project, the Nx config is an afternoon.</a:t>
+            </a:r>
+            <a:endParaRPr lang="en-US" dirty="0"/>
+          </a:p>
+        </p:txBody>
+      </p:sp>
+      <p:sp>
+        <p:nvSpPr>
+          <p:cNvPr id="4" name="Slide Number Placeholder 3"/>
+          <p:cNvSpPr>
+            <a:spLocks noGrp="1"/>
+          </p:cNvSpPr>
+          <p:nvPr>
+            <p:ph type="sldNum" sz="quarter" idx="10"/>
+          </p:nvPr>
+        </p:nvSpPr>
+        <p:spPr/>
+        <p:txBody>
+          <a:bodyPr/>
+          <a:lstStyle/>
+          <a:p>
+            <a:fld id="{F7021451-1387-4CA6-816F-3879F97B5CBC}" type="slidenum">
+              <a:rPr lang="en-US"/>
+              <a:t>27</a:t>
             </a:fld>
             <a:endParaRPr lang="en-US"/>
           </a:p>
@@ -16870,6 +16959,1286 @@
 </p:sld>
 </file>
 
+<file path=ppt/slides/slide27.xml><?xml version="1.0" encoding="utf-8"?>
+<p:sld xmlns:a="http://schemas.openxmlformats.org/drawingml/2006/main" xmlns:r="http://schemas.openxmlformats.org/officeDocument/2006/relationships" xmlns:p="http://schemas.openxmlformats.org/presentationml/2006/main">
+  <p:cSld name="Slide 27">
+    <p:bg>
+      <p:bgPr>
+        <a:solidFill>
+          <a:srgbClr val="F7F8FA"/>
+        </a:solidFill>
+      </p:bgPr>
+    </p:bg>
+    <p:spTree>
+      <p:nvGrpSpPr>
+        <p:cNvPr id="1" name=""/>
+        <p:cNvGrpSpPr/>
+        <p:nvPr/>
+      </p:nvGrpSpPr>
+      <p:grpSpPr>
+        <a:xfrm>
+          <a:off x="0" y="0"/>
+          <a:ext cx="0" cy="0"/>
+          <a:chOff x="0" y="0"/>
+          <a:chExt cx="0" cy="0"/>
+        </a:xfrm>
+      </p:grpSpPr>
+      <p:sp>
+        <p:nvSpPr>
+          <p:cNvPr id="2" name="Text 0"/>
+          <p:cNvSpPr txBox="1"/>
+          <p:nvPr/>
+        </p:nvSpPr>
+        <p:spPr>
+          <a:xfrm>
+            <a:off x="640080" y="411480"/>
+            <a:ext cx="10881360" cy="274320"/>
+          </a:xfrm>
+          <a:prstGeom prst="rect">
+            <a:avLst/>
+          </a:prstGeom>
+          <a:noFill/>
+          <a:ln/>
+        </p:spPr>
+        <p:txBody>
+          <a:bodyPr wrap="square" lIns="0" tIns="0" rIns="0" bIns="0" rtlCol="0" anchor="ctr"/>
+          <a:lstStyle/>
+          <a:p>
+            <a:pPr indent="0" marL="0">
+              <a:buNone/>
+            </a:pPr>
+            <a:r>
+              <a:rPr lang="en-US" sz="1200" b="1" spc="250" kern="0" dirty="0">
+                <a:solidFill>
+                  <a:srgbClr val="B45309"/>
+                </a:solidFill>
+                <a:latin typeface="Calibri" pitchFamily="34" charset="0"/>
+                <a:ea typeface="Calibri" pitchFamily="34" charset="-122"/>
+                <a:cs typeface="Calibri" pitchFamily="34" charset="-120"/>
+              </a:rPr>
+              <a:t>APPENDIX · PREPARED ANSWERS</a:t>
+            </a:r>
+            <a:endParaRPr lang="en-US" sz="1200" dirty="0"/>
+          </a:p>
+        </p:txBody>
+      </p:sp>
+      <p:sp>
+        <p:nvSpPr>
+          <p:cNvPr id="3" name="Text 1"/>
+          <p:cNvSpPr txBox="1"/>
+          <p:nvPr/>
+        </p:nvSpPr>
+        <p:spPr>
+          <a:xfrm>
+            <a:off x="640080" y="749808"/>
+            <a:ext cx="10881360" cy="731520"/>
+          </a:xfrm>
+          <a:prstGeom prst="rect">
+            <a:avLst/>
+          </a:prstGeom>
+          <a:noFill/>
+          <a:ln/>
+        </p:spPr>
+        <p:txBody>
+          <a:bodyPr wrap="square" lIns="0" tIns="0" rIns="0" bIns="0" rtlCol="0" anchor="ctr"/>
+          <a:lstStyle/>
+          <a:p>
+            <a:pPr indent="0" marL="0">
+              <a:buNone/>
+            </a:pPr>
+            <a:r>
+              <a:rPr lang="en-US" sz="3800" b="1" dirty="0">
+                <a:solidFill>
+                  <a:srgbClr val="10131A"/>
+                </a:solidFill>
+                <a:latin typeface="Cambria" pitchFamily="34" charset="0"/>
+                <a:ea typeface="Cambria" pitchFamily="34" charset="-122"/>
+                <a:cs typeface="Cambria" pitchFamily="34" charset="-120"/>
+              </a:rPr>
+              <a:t>Ten questions you will probably get</a:t>
+            </a:r>
+            <a:endParaRPr lang="en-US" sz="3800" dirty="0"/>
+          </a:p>
+        </p:txBody>
+      </p:sp>
+      <p:sp>
+        <p:nvSpPr>
+          <p:cNvPr id="4" name="Text 2"/>
+          <p:cNvSpPr txBox="1"/>
+          <p:nvPr/>
+        </p:nvSpPr>
+        <p:spPr>
+          <a:xfrm>
+            <a:off x="640080" y="1700784"/>
+            <a:ext cx="365760" cy="274320"/>
+          </a:xfrm>
+          <a:prstGeom prst="rect">
+            <a:avLst/>
+          </a:prstGeom>
+          <a:noFill/>
+          <a:ln/>
+        </p:spPr>
+        <p:txBody>
+          <a:bodyPr wrap="square" lIns="0" tIns="0" rIns="0" bIns="0" rtlCol="0" anchor="ctr"/>
+          <a:lstStyle/>
+          <a:p>
+            <a:pPr indent="0" marL="0">
+              <a:buNone/>
+            </a:pPr>
+            <a:r>
+              <a:rPr lang="en-US" sz="1100" b="1" dirty="0">
+                <a:solidFill>
+                  <a:srgbClr val="B45309"/>
+                </a:solidFill>
+                <a:latin typeface="Courier New" pitchFamily="34" charset="0"/>
+                <a:ea typeface="Courier New" pitchFamily="34" charset="-122"/>
+                <a:cs typeface="Courier New" pitchFamily="34" charset="-120"/>
+              </a:rPr>
+              <a:t>01</a:t>
+            </a:r>
+            <a:endParaRPr lang="en-US" sz="1100" dirty="0"/>
+          </a:p>
+        </p:txBody>
+      </p:sp>
+      <p:sp>
+        <p:nvSpPr>
+          <p:cNvPr id="5" name="Text 3"/>
+          <p:cNvSpPr txBox="1"/>
+          <p:nvPr/>
+        </p:nvSpPr>
+        <p:spPr>
+          <a:xfrm>
+            <a:off x="1051560" y="1700784"/>
+            <a:ext cx="4937760" cy="274320"/>
+          </a:xfrm>
+          <a:prstGeom prst="rect">
+            <a:avLst/>
+          </a:prstGeom>
+          <a:noFill/>
+          <a:ln/>
+        </p:spPr>
+        <p:txBody>
+          <a:bodyPr wrap="square" lIns="0" tIns="0" rIns="0" bIns="0" rtlCol="0" anchor="t"/>
+          <a:lstStyle/>
+          <a:p>
+            <a:pPr indent="0" marL="0">
+              <a:buNone/>
+            </a:pPr>
+            <a:r>
+              <a:rPr lang="en-US" sz="1250" b="1" dirty="0">
+                <a:solidFill>
+                  <a:srgbClr val="10131A"/>
+                </a:solidFill>
+                <a:latin typeface="Calibri" pitchFamily="34" charset="0"/>
+                <a:ea typeface="Calibri" pitchFamily="34" charset="-122"/>
+                <a:cs typeface="Calibri" pitchFamily="34" charset="-120"/>
+              </a:rPr>
+              <a:t>Why not just pay for Nx Cloud?</a:t>
+            </a:r>
+            <a:endParaRPr lang="en-US" sz="1250" dirty="0"/>
+          </a:p>
+        </p:txBody>
+      </p:sp>
+      <p:sp>
+        <p:nvSpPr>
+          <p:cNvPr id="6" name="Text 4"/>
+          <p:cNvSpPr txBox="1"/>
+          <p:nvPr/>
+        </p:nvSpPr>
+        <p:spPr>
+          <a:xfrm>
+            <a:off x="1051560" y="1984248"/>
+            <a:ext cx="4937760" cy="603504"/>
+          </a:xfrm>
+          <a:prstGeom prst="rect">
+            <a:avLst/>
+          </a:prstGeom>
+          <a:noFill/>
+          <a:ln/>
+        </p:spPr>
+        <p:txBody>
+          <a:bodyPr wrap="square" lIns="0" tIns="0" rIns="0" bIns="0" rtlCol="0" anchor="t"/>
+          <a:lstStyle/>
+          <a:p>
+            <a:pPr indent="0" marL="0">
+              <a:buNone/>
+            </a:pPr>
+            <a:r>
+              <a:rPr lang="en-US" sz="1050" dirty="0">
+                <a:solidFill>
+                  <a:srgbClr val="5C6675"/>
+                </a:solidFill>
+                <a:latin typeface="Calibri" pitchFamily="34" charset="0"/>
+                <a:ea typeface="Calibri" pitchFamily="34" charset="-122"/>
+                <a:cs typeface="Calibri" pitchFamily="34" charset="-120"/>
+              </a:rPr>
+              <a:t>Often the right call. It adds distribution by measured duration, a shared cache and flaky detection. This is the free half of the same idea.</a:t>
+            </a:r>
+            <a:endParaRPr lang="en-US" sz="1050" dirty="0"/>
+          </a:p>
+        </p:txBody>
+      </p:sp>
+      <p:sp>
+        <p:nvSpPr>
+          <p:cNvPr id="7" name="Text 5"/>
+          <p:cNvSpPr txBox="1"/>
+          <p:nvPr/>
+        </p:nvSpPr>
+        <p:spPr>
+          <a:xfrm>
+            <a:off x="640080" y="2651760"/>
+            <a:ext cx="365760" cy="274320"/>
+          </a:xfrm>
+          <a:prstGeom prst="rect">
+            <a:avLst/>
+          </a:prstGeom>
+          <a:noFill/>
+          <a:ln/>
+        </p:spPr>
+        <p:txBody>
+          <a:bodyPr wrap="square" lIns="0" tIns="0" rIns="0" bIns="0" rtlCol="0" anchor="ctr"/>
+          <a:lstStyle/>
+          <a:p>
+            <a:pPr indent="0" marL="0">
+              <a:buNone/>
+            </a:pPr>
+            <a:r>
+              <a:rPr lang="en-US" sz="1100" b="1" dirty="0">
+                <a:solidFill>
+                  <a:srgbClr val="B45309"/>
+                </a:solidFill>
+                <a:latin typeface="Courier New" pitchFamily="34" charset="0"/>
+                <a:ea typeface="Courier New" pitchFamily="34" charset="-122"/>
+                <a:cs typeface="Courier New" pitchFamily="34" charset="-120"/>
+              </a:rPr>
+              <a:t>02</a:t>
+            </a:r>
+            <a:endParaRPr lang="en-US" sz="1100" dirty="0"/>
+          </a:p>
+        </p:txBody>
+      </p:sp>
+      <p:sp>
+        <p:nvSpPr>
+          <p:cNvPr id="8" name="Text 6"/>
+          <p:cNvSpPr txBox="1"/>
+          <p:nvPr/>
+        </p:nvSpPr>
+        <p:spPr>
+          <a:xfrm>
+            <a:off x="1051560" y="2651760"/>
+            <a:ext cx="4937760" cy="274320"/>
+          </a:xfrm>
+          <a:prstGeom prst="rect">
+            <a:avLst/>
+          </a:prstGeom>
+          <a:noFill/>
+          <a:ln/>
+        </p:spPr>
+        <p:txBody>
+          <a:bodyPr wrap="square" lIns="0" tIns="0" rIns="0" bIns="0" rtlCol="0" anchor="t"/>
+          <a:lstStyle/>
+          <a:p>
+            <a:pPr indent="0" marL="0">
+              <a:buNone/>
+            </a:pPr>
+            <a:r>
+              <a:rPr lang="en-US" sz="1250" b="1" dirty="0">
+                <a:solidFill>
+                  <a:srgbClr val="10131A"/>
+                </a:solidFill>
+                <a:latin typeface="Calibri" pitchFamily="34" charset="0"/>
+                <a:ea typeface="Calibri" pitchFamily="34" charset="-122"/>
+                <a:cs typeface="Calibri" pitchFamily="34" charset="-120"/>
+              </a:rPr>
+              <a:t>Does the cache fix flaky tests?</a:t>
+            </a:r>
+            <a:endParaRPr lang="en-US" sz="1250" dirty="0"/>
+          </a:p>
+        </p:txBody>
+      </p:sp>
+      <p:sp>
+        <p:nvSpPr>
+          <p:cNvPr id="9" name="Text 7"/>
+          <p:cNvSpPr txBox="1"/>
+          <p:nvPr/>
+        </p:nvSpPr>
+        <p:spPr>
+          <a:xfrm>
+            <a:off x="1051560" y="2935224"/>
+            <a:ext cx="4937760" cy="603504"/>
+          </a:xfrm>
+          <a:prstGeom prst="rect">
+            <a:avLst/>
+          </a:prstGeom>
+          <a:noFill/>
+          <a:ln/>
+        </p:spPr>
+        <p:txBody>
+          <a:bodyPr wrap="square" lIns="0" tIns="0" rIns="0" bIns="0" rtlCol="0" anchor="t"/>
+          <a:lstStyle/>
+          <a:p>
+            <a:pPr indent="0" marL="0">
+              <a:buNone/>
+            </a:pPr>
+            <a:r>
+              <a:rPr lang="en-US" sz="1050" dirty="0">
+                <a:solidFill>
+                  <a:srgbClr val="5C6675"/>
+                </a:solidFill>
+                <a:latin typeface="Calibri" pitchFamily="34" charset="0"/>
+                <a:ea typeface="Calibri" pitchFamily="34" charset="-122"/>
+                <a:cs typeface="Calibri" pitchFamily="34" charset="-120"/>
+              </a:rPr>
+              <a:t>No. It makes retries cheap. A flake fails, is never cached, and re-runs on its own while everything else replays.</a:t>
+            </a:r>
+            <a:endParaRPr lang="en-US" sz="1050" dirty="0"/>
+          </a:p>
+        </p:txBody>
+      </p:sp>
+      <p:sp>
+        <p:nvSpPr>
+          <p:cNvPr id="10" name="Text 8"/>
+          <p:cNvSpPr txBox="1"/>
+          <p:nvPr/>
+        </p:nvSpPr>
+        <p:spPr>
+          <a:xfrm>
+            <a:off x="640080" y="3602736"/>
+            <a:ext cx="365760" cy="274320"/>
+          </a:xfrm>
+          <a:prstGeom prst="rect">
+            <a:avLst/>
+          </a:prstGeom>
+          <a:noFill/>
+          <a:ln/>
+        </p:spPr>
+        <p:txBody>
+          <a:bodyPr wrap="square" lIns="0" tIns="0" rIns="0" bIns="0" rtlCol="0" anchor="ctr"/>
+          <a:lstStyle/>
+          <a:p>
+            <a:pPr indent="0" marL="0">
+              <a:buNone/>
+            </a:pPr>
+            <a:r>
+              <a:rPr lang="en-US" sz="1100" b="1" dirty="0">
+                <a:solidFill>
+                  <a:srgbClr val="B45309"/>
+                </a:solidFill>
+                <a:latin typeface="Courier New" pitchFamily="34" charset="0"/>
+                <a:ea typeface="Courier New" pitchFamily="34" charset="-122"/>
+                <a:cs typeface="Courier New" pitchFamily="34" charset="-120"/>
+              </a:rPr>
+              <a:t>03</a:t>
+            </a:r>
+            <a:endParaRPr lang="en-US" sz="1100" dirty="0"/>
+          </a:p>
+        </p:txBody>
+      </p:sp>
+      <p:sp>
+        <p:nvSpPr>
+          <p:cNvPr id="11" name="Text 9"/>
+          <p:cNvSpPr txBox="1"/>
+          <p:nvPr/>
+        </p:nvSpPr>
+        <p:spPr>
+          <a:xfrm>
+            <a:off x="1051560" y="3602736"/>
+            <a:ext cx="4937760" cy="274320"/>
+          </a:xfrm>
+          <a:prstGeom prst="rect">
+            <a:avLst/>
+          </a:prstGeom>
+          <a:noFill/>
+          <a:ln/>
+        </p:spPr>
+        <p:txBody>
+          <a:bodyPr wrap="square" lIns="0" tIns="0" rIns="0" bIns="0" rtlCol="0" anchor="t"/>
+          <a:lstStyle/>
+          <a:p>
+            <a:pPr indent="0" marL="0">
+              <a:buNone/>
+            </a:pPr>
+            <a:r>
+              <a:rPr lang="en-US" sz="1250" b="1" dirty="0">
+                <a:solidFill>
+                  <a:srgbClr val="10131A"/>
+                </a:solidFill>
+                <a:latin typeface="Calibri" pitchFamily="34" charset="0"/>
+                <a:ea typeface="Calibri" pitchFamily="34" charset="-122"/>
+                <a:cs typeface="Calibri" pitchFamily="34" charset="-120"/>
+              </a:rPr>
+              <a:t>Can the cache hand back a wrong result?</a:t>
+            </a:r>
+            <a:endParaRPr lang="en-US" sz="1250" dirty="0"/>
+          </a:p>
+        </p:txBody>
+      </p:sp>
+      <p:sp>
+        <p:nvSpPr>
+          <p:cNvPr id="12" name="Text 10"/>
+          <p:cNvSpPr txBox="1"/>
+          <p:nvPr/>
+        </p:nvSpPr>
+        <p:spPr>
+          <a:xfrm>
+            <a:off x="1051560" y="3886200"/>
+            <a:ext cx="4937760" cy="603504"/>
+          </a:xfrm>
+          <a:prstGeom prst="rect">
+            <a:avLst/>
+          </a:prstGeom>
+          <a:noFill/>
+          <a:ln/>
+        </p:spPr>
+        <p:txBody>
+          <a:bodyPr wrap="square" lIns="0" tIns="0" rIns="0" bIns="0" rtlCol="0" anchor="t"/>
+          <a:lstStyle/>
+          <a:p>
+            <a:pPr indent="0" marL="0">
+              <a:buNone/>
+            </a:pPr>
+            <a:r>
+              <a:rPr lang="en-US" sz="1050" dirty="0">
+                <a:solidFill>
+                  <a:srgbClr val="5C6675"/>
+                </a:solidFill>
+                <a:latin typeface="Calibri" pitchFamily="34" charset="0"/>
+                <a:ea typeface="Calibri" pitchFamily="34" charset="-122"/>
+                <a:cs typeface="Calibri" pitchFamily="34" charset="-120"/>
+              </a:rPr>
+              <a:t>Only if a task has inputs Nx cannot see — a live API, the clock, a shared database. Declare them as inputs or mark the task uncacheable.</a:t>
+            </a:r>
+            <a:endParaRPr lang="en-US" sz="1050" dirty="0"/>
+          </a:p>
+        </p:txBody>
+      </p:sp>
+      <p:sp>
+        <p:nvSpPr>
+          <p:cNvPr id="13" name="Text 11"/>
+          <p:cNvSpPr txBox="1"/>
+          <p:nvPr/>
+        </p:nvSpPr>
+        <p:spPr>
+          <a:xfrm>
+            <a:off x="640080" y="4553712"/>
+            <a:ext cx="365760" cy="274320"/>
+          </a:xfrm>
+          <a:prstGeom prst="rect">
+            <a:avLst/>
+          </a:prstGeom>
+          <a:noFill/>
+          <a:ln/>
+        </p:spPr>
+        <p:txBody>
+          <a:bodyPr wrap="square" lIns="0" tIns="0" rIns="0" bIns="0" rtlCol="0" anchor="ctr"/>
+          <a:lstStyle/>
+          <a:p>
+            <a:pPr indent="0" marL="0">
+              <a:buNone/>
+            </a:pPr>
+            <a:r>
+              <a:rPr lang="en-US" sz="1100" b="1" dirty="0">
+                <a:solidFill>
+                  <a:srgbClr val="B45309"/>
+                </a:solidFill>
+                <a:latin typeface="Courier New" pitchFamily="34" charset="0"/>
+                <a:ea typeface="Courier New" pitchFamily="34" charset="-122"/>
+                <a:cs typeface="Courier New" pitchFamily="34" charset="-120"/>
+              </a:rPr>
+              <a:t>04</a:t>
+            </a:r>
+            <a:endParaRPr lang="en-US" sz="1100" dirty="0"/>
+          </a:p>
+        </p:txBody>
+      </p:sp>
+      <p:sp>
+        <p:nvSpPr>
+          <p:cNvPr id="14" name="Text 12"/>
+          <p:cNvSpPr txBox="1"/>
+          <p:nvPr/>
+        </p:nvSpPr>
+        <p:spPr>
+          <a:xfrm>
+            <a:off x="1051560" y="4553712"/>
+            <a:ext cx="4937760" cy="274320"/>
+          </a:xfrm>
+          <a:prstGeom prst="rect">
+            <a:avLst/>
+          </a:prstGeom>
+          <a:noFill/>
+          <a:ln/>
+        </p:spPr>
+        <p:txBody>
+          <a:bodyPr wrap="square" lIns="0" tIns="0" rIns="0" bIns="0" rtlCol="0" anchor="t"/>
+          <a:lstStyle/>
+          <a:p>
+            <a:pPr indent="0" marL="0">
+              <a:buNone/>
+            </a:pPr>
+            <a:r>
+              <a:rPr lang="en-US" sz="1250" b="1" dirty="0">
+                <a:solidFill>
+                  <a:srgbClr val="10131A"/>
+                </a:solidFill>
+                <a:latin typeface="Calibri" pitchFamily="34" charset="0"/>
+                <a:ea typeface="Calibri" pitchFamily="34" charset="-122"/>
+                <a:cs typeface="Calibri" pitchFamily="34" charset="-120"/>
+              </a:rPr>
+              <a:t>Can the team share one cache?</a:t>
+            </a:r>
+            <a:endParaRPr lang="en-US" sz="1250" dirty="0"/>
+          </a:p>
+        </p:txBody>
+      </p:sp>
+      <p:sp>
+        <p:nvSpPr>
+          <p:cNvPr id="15" name="Text 13"/>
+          <p:cNvSpPr txBox="1"/>
+          <p:nvPr/>
+        </p:nvSpPr>
+        <p:spPr>
+          <a:xfrm>
+            <a:off x="1051560" y="4837176"/>
+            <a:ext cx="4937760" cy="603504"/>
+          </a:xfrm>
+          <a:prstGeom prst="rect">
+            <a:avLst/>
+          </a:prstGeom>
+          <a:noFill/>
+          <a:ln/>
+        </p:spPr>
+        <p:txBody>
+          <a:bodyPr wrap="square" lIns="0" tIns="0" rIns="0" bIns="0" rtlCol="0" anchor="t"/>
+          <a:lstStyle/>
+          <a:p>
+            <a:pPr indent="0" marL="0">
+              <a:buNone/>
+            </a:pPr>
+            <a:r>
+              <a:rPr lang="en-US" sz="1050" dirty="0">
+                <a:solidFill>
+                  <a:srgbClr val="5C6675"/>
+                </a:solidFill>
+                <a:latin typeface="Calibri" pitchFamily="34" charset="0"/>
+                <a:ea typeface="Calibri" pitchFamily="34" charset="-122"/>
+                <a:cs typeface="Calibri" pitchFamily="34" charset="-120"/>
+              </a:rPr>
+              <a:t>Not on the free tier: it is per-machine and per-CI-job. A shared remote cache is the main thing Nx Cloud actually sells.</a:t>
+            </a:r>
+            <a:endParaRPr lang="en-US" sz="1050" dirty="0"/>
+          </a:p>
+        </p:txBody>
+      </p:sp>
+      <p:sp>
+        <p:nvSpPr>
+          <p:cNvPr id="16" name="Text 14"/>
+          <p:cNvSpPr txBox="1"/>
+          <p:nvPr/>
+        </p:nvSpPr>
+        <p:spPr>
+          <a:xfrm>
+            <a:off x="640080" y="5504688"/>
+            <a:ext cx="365760" cy="274320"/>
+          </a:xfrm>
+          <a:prstGeom prst="rect">
+            <a:avLst/>
+          </a:prstGeom>
+          <a:noFill/>
+          <a:ln/>
+        </p:spPr>
+        <p:txBody>
+          <a:bodyPr wrap="square" lIns="0" tIns="0" rIns="0" bIns="0" rtlCol="0" anchor="ctr"/>
+          <a:lstStyle/>
+          <a:p>
+            <a:pPr indent="0" marL="0">
+              <a:buNone/>
+            </a:pPr>
+            <a:r>
+              <a:rPr lang="en-US" sz="1100" b="1" dirty="0">
+                <a:solidFill>
+                  <a:srgbClr val="B45309"/>
+                </a:solidFill>
+                <a:latin typeface="Courier New" pitchFamily="34" charset="0"/>
+                <a:ea typeface="Courier New" pitchFamily="34" charset="-122"/>
+                <a:cs typeface="Courier New" pitchFamily="34" charset="-120"/>
+              </a:rPr>
+              <a:t>05</a:t>
+            </a:r>
+            <a:endParaRPr lang="en-US" sz="1100" dirty="0"/>
+          </a:p>
+        </p:txBody>
+      </p:sp>
+      <p:sp>
+        <p:nvSpPr>
+          <p:cNvPr id="17" name="Text 15"/>
+          <p:cNvSpPr txBox="1"/>
+          <p:nvPr/>
+        </p:nvSpPr>
+        <p:spPr>
+          <a:xfrm>
+            <a:off x="1051560" y="5504688"/>
+            <a:ext cx="4937760" cy="274320"/>
+          </a:xfrm>
+          <a:prstGeom prst="rect">
+            <a:avLst/>
+          </a:prstGeom>
+          <a:noFill/>
+          <a:ln/>
+        </p:spPr>
+        <p:txBody>
+          <a:bodyPr wrap="square" lIns="0" tIns="0" rIns="0" bIns="0" rtlCol="0" anchor="t"/>
+          <a:lstStyle/>
+          <a:p>
+            <a:pPr indent="0" marL="0">
+              <a:buNone/>
+            </a:pPr>
+            <a:r>
+              <a:rPr lang="en-US" sz="1250" b="1" dirty="0">
+                <a:solidFill>
+                  <a:srgbClr val="10131A"/>
+                </a:solidFill>
+                <a:latin typeface="Calibri" pitchFamily="34" charset="0"/>
+                <a:ea typeface="Calibri" pitchFamily="34" charset="-122"/>
+                <a:cs typeface="Calibri" pitchFamily="34" charset="-120"/>
+              </a:rPr>
+              <a:t>Do I need a monorepo for this?</a:t>
+            </a:r>
+            <a:endParaRPr lang="en-US" sz="1250" dirty="0"/>
+          </a:p>
+        </p:txBody>
+      </p:sp>
+      <p:sp>
+        <p:nvSpPr>
+          <p:cNvPr id="18" name="Text 16"/>
+          <p:cNvSpPr txBox="1"/>
+          <p:nvPr/>
+        </p:nvSpPr>
+        <p:spPr>
+          <a:xfrm>
+            <a:off x="1051560" y="5788152"/>
+            <a:ext cx="4937760" cy="603504"/>
+          </a:xfrm>
+          <a:prstGeom prst="rect">
+            <a:avLst/>
+          </a:prstGeom>
+          <a:noFill/>
+          <a:ln/>
+        </p:spPr>
+        <p:txBody>
+          <a:bodyPr wrap="square" lIns="0" tIns="0" rIns="0" bIns="0" rtlCol="0" anchor="t"/>
+          <a:lstStyle/>
+          <a:p>
+            <a:pPr indent="0" marL="0">
+              <a:buNone/>
+            </a:pPr>
+            <a:r>
+              <a:rPr lang="en-US" sz="1050" dirty="0">
+                <a:solidFill>
+                  <a:srgbClr val="5C6675"/>
+                </a:solidFill>
+                <a:latin typeface="Calibri" pitchFamily="34" charset="0"/>
+                <a:ea typeface="Calibri" pitchFamily="34" charset="-122"/>
+                <a:cs typeface="Calibri" pitchFamily="34" charset="-120"/>
+              </a:rPr>
+              <a:t>No. The atomizer works on a single project. It is affected that needs several projects before it earns its keep.</a:t>
+            </a:r>
+            <a:endParaRPr lang="en-US" sz="1050" dirty="0"/>
+          </a:p>
+        </p:txBody>
+      </p:sp>
+      <p:sp>
+        <p:nvSpPr>
+          <p:cNvPr id="19" name="Text 17"/>
+          <p:cNvSpPr txBox="1"/>
+          <p:nvPr/>
+        </p:nvSpPr>
+        <p:spPr>
+          <a:xfrm>
+            <a:off x="6263640" y="1700784"/>
+            <a:ext cx="365760" cy="274320"/>
+          </a:xfrm>
+          <a:prstGeom prst="rect">
+            <a:avLst/>
+          </a:prstGeom>
+          <a:noFill/>
+          <a:ln/>
+        </p:spPr>
+        <p:txBody>
+          <a:bodyPr wrap="square" lIns="0" tIns="0" rIns="0" bIns="0" rtlCol="0" anchor="ctr"/>
+          <a:lstStyle/>
+          <a:p>
+            <a:pPr indent="0" marL="0">
+              <a:buNone/>
+            </a:pPr>
+            <a:r>
+              <a:rPr lang="en-US" sz="1100" b="1" dirty="0">
+                <a:solidFill>
+                  <a:srgbClr val="B45309"/>
+                </a:solidFill>
+                <a:latin typeface="Courier New" pitchFamily="34" charset="0"/>
+                <a:ea typeface="Courier New" pitchFamily="34" charset="-122"/>
+                <a:cs typeface="Courier New" pitchFamily="34" charset="-120"/>
+              </a:rPr>
+              <a:t>06</a:t>
+            </a:r>
+            <a:endParaRPr lang="en-US" sz="1100" dirty="0"/>
+          </a:p>
+        </p:txBody>
+      </p:sp>
+      <p:sp>
+        <p:nvSpPr>
+          <p:cNvPr id="20" name="Text 18"/>
+          <p:cNvSpPr txBox="1"/>
+          <p:nvPr/>
+        </p:nvSpPr>
+        <p:spPr>
+          <a:xfrm>
+            <a:off x="6675120" y="1700784"/>
+            <a:ext cx="4937760" cy="274320"/>
+          </a:xfrm>
+          <a:prstGeom prst="rect">
+            <a:avLst/>
+          </a:prstGeom>
+          <a:noFill/>
+          <a:ln/>
+        </p:spPr>
+        <p:txBody>
+          <a:bodyPr wrap="square" lIns="0" tIns="0" rIns="0" bIns="0" rtlCol="0" anchor="t"/>
+          <a:lstStyle/>
+          <a:p>
+            <a:pPr indent="0" marL="0">
+              <a:buNone/>
+            </a:pPr>
+            <a:r>
+              <a:rPr lang="en-US" sz="1250" b="1" dirty="0">
+                <a:solidFill>
+                  <a:srgbClr val="10131A"/>
+                </a:solidFill>
+                <a:latin typeface="Calibri" pitchFamily="34" charset="0"/>
+                <a:ea typeface="Calibri" pitchFamily="34" charset="-122"/>
+                <a:cs typeface="Calibri" pitchFamily="34" charset="-120"/>
+              </a:rPr>
+              <a:t>One app has 200 specs, the others have 5?</a:t>
+            </a:r>
+            <a:endParaRPr lang="en-US" sz="1250" dirty="0"/>
+          </a:p>
+        </p:txBody>
+      </p:sp>
+      <p:sp>
+        <p:nvSpPr>
+          <p:cNvPr id="21" name="Text 19"/>
+          <p:cNvSpPr txBox="1"/>
+          <p:nvPr/>
+        </p:nvSpPr>
+        <p:spPr>
+          <a:xfrm>
+            <a:off x="6675120" y="1984248"/>
+            <a:ext cx="4937760" cy="603504"/>
+          </a:xfrm>
+          <a:prstGeom prst="rect">
+            <a:avLst/>
+          </a:prstGeom>
+          <a:noFill/>
+          <a:ln/>
+        </p:spPr>
+        <p:txBody>
+          <a:bodyPr wrap="square" lIns="0" tIns="0" rIns="0" bIns="0" rtlCol="0" anchor="t"/>
+          <a:lstStyle/>
+          <a:p>
+            <a:pPr indent="0" marL="0">
+              <a:buNone/>
+            </a:pPr>
+            <a:r>
+              <a:rPr lang="en-US" sz="1050" dirty="0">
+                <a:solidFill>
+                  <a:srgbClr val="5C6675"/>
+                </a:solidFill>
+                <a:latin typeface="Calibri" pitchFamily="34" charset="0"/>
+                <a:ea typeface="Calibri" pitchFamily="34" charset="-122"/>
+                <a:cs typeface="Calibri" pitchFamily="34" charset="-120"/>
+              </a:rPr>
+              <a:t>That is exactly when sharding beats a per-app matrix. Shard the big one; leave the small ones a runner each.</a:t>
+            </a:r>
+            <a:endParaRPr lang="en-US" sz="1050" dirty="0"/>
+          </a:p>
+        </p:txBody>
+      </p:sp>
+      <p:sp>
+        <p:nvSpPr>
+          <p:cNvPr id="22" name="Text 20"/>
+          <p:cNvSpPr txBox="1"/>
+          <p:nvPr/>
+        </p:nvSpPr>
+        <p:spPr>
+          <a:xfrm>
+            <a:off x="6263640" y="2651760"/>
+            <a:ext cx="365760" cy="274320"/>
+          </a:xfrm>
+          <a:prstGeom prst="rect">
+            <a:avLst/>
+          </a:prstGeom>
+          <a:noFill/>
+          <a:ln/>
+        </p:spPr>
+        <p:txBody>
+          <a:bodyPr wrap="square" lIns="0" tIns="0" rIns="0" bIns="0" rtlCol="0" anchor="ctr"/>
+          <a:lstStyle/>
+          <a:p>
+            <a:pPr indent="0" marL="0">
+              <a:buNone/>
+            </a:pPr>
+            <a:r>
+              <a:rPr lang="en-US" sz="1100" b="1" dirty="0">
+                <a:solidFill>
+                  <a:srgbClr val="B45309"/>
+                </a:solidFill>
+                <a:latin typeface="Courier New" pitchFamily="34" charset="0"/>
+                <a:ea typeface="Courier New" pitchFamily="34" charset="-122"/>
+                <a:cs typeface="Courier New" pitchFamily="34" charset="-120"/>
+              </a:rPr>
+              <a:t>07</a:t>
+            </a:r>
+            <a:endParaRPr lang="en-US" sz="1100" dirty="0"/>
+          </a:p>
+        </p:txBody>
+      </p:sp>
+      <p:sp>
+        <p:nvSpPr>
+          <p:cNvPr id="23" name="Text 21"/>
+          <p:cNvSpPr txBox="1"/>
+          <p:nvPr/>
+        </p:nvSpPr>
+        <p:spPr>
+          <a:xfrm>
+            <a:off x="6675120" y="2651760"/>
+            <a:ext cx="4937760" cy="274320"/>
+          </a:xfrm>
+          <a:prstGeom prst="rect">
+            <a:avLst/>
+          </a:prstGeom>
+          <a:noFill/>
+          <a:ln/>
+        </p:spPr>
+        <p:txBody>
+          <a:bodyPr wrap="square" lIns="0" tIns="0" rIns="0" bIns="0" rtlCol="0" anchor="t"/>
+          <a:lstStyle/>
+          <a:p>
+            <a:pPr indent="0" marL="0">
+              <a:buNone/>
+            </a:pPr>
+            <a:r>
+              <a:rPr lang="en-US" sz="1250" b="1" dirty="0">
+                <a:solidFill>
+                  <a:srgbClr val="10131A"/>
+                </a:solidFill>
+                <a:latin typeface="Calibri" pitchFamily="34" charset="0"/>
+                <a:ea typeface="Calibri" pitchFamily="34" charset="-122"/>
+                <a:cs typeface="Calibri" pitchFamily="34" charset="-120"/>
+              </a:rPr>
+              <a:t>Will 30 targets cost more CI minutes?</a:t>
+            </a:r>
+            <a:endParaRPr lang="en-US" sz="1250" dirty="0"/>
+          </a:p>
+        </p:txBody>
+      </p:sp>
+      <p:sp>
+        <p:nvSpPr>
+          <p:cNvPr id="24" name="Text 22"/>
+          <p:cNvSpPr txBox="1"/>
+          <p:nvPr/>
+        </p:nvSpPr>
+        <p:spPr>
+          <a:xfrm>
+            <a:off x="6675120" y="2935224"/>
+            <a:ext cx="4937760" cy="603504"/>
+          </a:xfrm>
+          <a:prstGeom prst="rect">
+            <a:avLst/>
+          </a:prstGeom>
+          <a:noFill/>
+          <a:ln/>
+        </p:spPr>
+        <p:txBody>
+          <a:bodyPr wrap="square" lIns="0" tIns="0" rIns="0" bIns="0" rtlCol="0" anchor="t"/>
+          <a:lstStyle/>
+          <a:p>
+            <a:pPr indent="0" marL="0">
+              <a:buNone/>
+            </a:pPr>
+            <a:r>
+              <a:rPr lang="en-US" sz="1050" dirty="0">
+                <a:solidFill>
+                  <a:srgbClr val="5C6675"/>
+                </a:solidFill>
+                <a:latin typeface="Calibri" pitchFamily="34" charset="0"/>
+                <a:ea typeface="Calibri" pitchFamily="34" charset="-122"/>
+                <a:cs typeface="Calibri" pitchFamily="34" charset="-120"/>
+              </a:rPr>
+              <a:t>It went 48m to 25m on the real project, and a replayed job bills almost nothing. More runners does mean more concurrency — measure yours.</a:t>
+            </a:r>
+            <a:endParaRPr lang="en-US" sz="1050" dirty="0"/>
+          </a:p>
+        </p:txBody>
+      </p:sp>
+      <p:sp>
+        <p:nvSpPr>
+          <p:cNvPr id="25" name="Text 23"/>
+          <p:cNvSpPr txBox="1"/>
+          <p:nvPr/>
+        </p:nvSpPr>
+        <p:spPr>
+          <a:xfrm>
+            <a:off x="6263640" y="3602736"/>
+            <a:ext cx="365760" cy="274320"/>
+          </a:xfrm>
+          <a:prstGeom prst="rect">
+            <a:avLst/>
+          </a:prstGeom>
+          <a:noFill/>
+          <a:ln/>
+        </p:spPr>
+        <p:txBody>
+          <a:bodyPr wrap="square" lIns="0" tIns="0" rIns="0" bIns="0" rtlCol="0" anchor="ctr"/>
+          <a:lstStyle/>
+          <a:p>
+            <a:pPr indent="0" marL="0">
+              <a:buNone/>
+            </a:pPr>
+            <a:r>
+              <a:rPr lang="en-US" sz="1100" b="1" dirty="0">
+                <a:solidFill>
+                  <a:srgbClr val="B45309"/>
+                </a:solidFill>
+                <a:latin typeface="Courier New" pitchFamily="34" charset="0"/>
+                <a:ea typeface="Courier New" pitchFamily="34" charset="-122"/>
+                <a:cs typeface="Courier New" pitchFamily="34" charset="-120"/>
+              </a:rPr>
+              <a:t>08</a:t>
+            </a:r>
+            <a:endParaRPr lang="en-US" sz="1100" dirty="0"/>
+          </a:p>
+        </p:txBody>
+      </p:sp>
+      <p:sp>
+        <p:nvSpPr>
+          <p:cNvPr id="26" name="Text 24"/>
+          <p:cNvSpPr txBox="1"/>
+          <p:nvPr/>
+        </p:nvSpPr>
+        <p:spPr>
+          <a:xfrm>
+            <a:off x="6675120" y="3602736"/>
+            <a:ext cx="4937760" cy="274320"/>
+          </a:xfrm>
+          <a:prstGeom prst="rect">
+            <a:avLst/>
+          </a:prstGeom>
+          <a:noFill/>
+          <a:ln/>
+        </p:spPr>
+        <p:txBody>
+          <a:bodyPr wrap="square" lIns="0" tIns="0" rIns="0" bIns="0" rtlCol="0" anchor="t"/>
+          <a:lstStyle/>
+          <a:p>
+            <a:pPr indent="0" marL="0">
+              <a:buNone/>
+            </a:pPr>
+            <a:r>
+              <a:rPr lang="en-US" sz="1250" b="1" dirty="0">
+                <a:solidFill>
+                  <a:srgbClr val="10131A"/>
+                </a:solidFill>
+                <a:latin typeface="Calibri" pitchFamily="34" charset="0"/>
+                <a:ea typeface="Calibri" pitchFamily="34" charset="-122"/>
+                <a:cs typeface="Calibri" pitchFamily="34" charset="-120"/>
+              </a:rPr>
+              <a:t>What about shared test data?</a:t>
+            </a:r>
+            <a:endParaRPr lang="en-US" sz="1250" dirty="0"/>
+          </a:p>
+        </p:txBody>
+      </p:sp>
+      <p:sp>
+        <p:nvSpPr>
+          <p:cNvPr id="27" name="Text 25"/>
+          <p:cNvSpPr txBox="1"/>
+          <p:nvPr/>
+        </p:nvSpPr>
+        <p:spPr>
+          <a:xfrm>
+            <a:off x="6675120" y="3886200"/>
+            <a:ext cx="4937760" cy="603504"/>
+          </a:xfrm>
+          <a:prstGeom prst="rect">
+            <a:avLst/>
+          </a:prstGeom>
+          <a:noFill/>
+          <a:ln/>
+        </p:spPr>
+        <p:txBody>
+          <a:bodyPr wrap="square" lIns="0" tIns="0" rIns="0" bIns="0" rtlCol="0" anchor="t"/>
+          <a:lstStyle/>
+          <a:p>
+            <a:pPr indent="0" marL="0">
+              <a:buNone/>
+            </a:pPr>
+            <a:r>
+              <a:rPr lang="en-US" sz="1050" dirty="0">
+                <a:solidFill>
+                  <a:srgbClr val="5C6675"/>
+                </a:solidFill>
+                <a:latin typeface="Calibri" pitchFamily="34" charset="0"/>
+                <a:ea typeface="Calibri" pitchFamily="34" charset="-122"/>
+                <a:cs typeface="Calibri" pitchFamily="34" charset="-120"/>
+              </a:rPr>
+              <a:t>The real blocker, and it is not an Nx problem. Specs must be independent before you can run them at once. Usually more work than the config.</a:t>
+            </a:r>
+            <a:endParaRPr lang="en-US" sz="1050" dirty="0"/>
+          </a:p>
+        </p:txBody>
+      </p:sp>
+      <p:sp>
+        <p:nvSpPr>
+          <p:cNvPr id="28" name="Text 26"/>
+          <p:cNvSpPr txBox="1"/>
+          <p:nvPr/>
+        </p:nvSpPr>
+        <p:spPr>
+          <a:xfrm>
+            <a:off x="6263640" y="4553712"/>
+            <a:ext cx="365760" cy="274320"/>
+          </a:xfrm>
+          <a:prstGeom prst="rect">
+            <a:avLst/>
+          </a:prstGeom>
+          <a:noFill/>
+          <a:ln/>
+        </p:spPr>
+        <p:txBody>
+          <a:bodyPr wrap="square" lIns="0" tIns="0" rIns="0" bIns="0" rtlCol="0" anchor="ctr"/>
+          <a:lstStyle/>
+          <a:p>
+            <a:pPr indent="0" marL="0">
+              <a:buNone/>
+            </a:pPr>
+            <a:r>
+              <a:rPr lang="en-US" sz="1100" b="1" dirty="0">
+                <a:solidFill>
+                  <a:srgbClr val="B45309"/>
+                </a:solidFill>
+                <a:latin typeface="Courier New" pitchFamily="34" charset="0"/>
+                <a:ea typeface="Courier New" pitchFamily="34" charset="-122"/>
+                <a:cs typeface="Courier New" pitchFamily="34" charset="-120"/>
+              </a:rPr>
+              <a:t>09</a:t>
+            </a:r>
+            <a:endParaRPr lang="en-US" sz="1100" dirty="0"/>
+          </a:p>
+        </p:txBody>
+      </p:sp>
+      <p:sp>
+        <p:nvSpPr>
+          <p:cNvPr id="29" name="Text 27"/>
+          <p:cNvSpPr txBox="1"/>
+          <p:nvPr/>
+        </p:nvSpPr>
+        <p:spPr>
+          <a:xfrm>
+            <a:off x="6675120" y="4553712"/>
+            <a:ext cx="4937760" cy="274320"/>
+          </a:xfrm>
+          <a:prstGeom prst="rect">
+            <a:avLst/>
+          </a:prstGeom>
+          <a:noFill/>
+          <a:ln/>
+        </p:spPr>
+        <p:txBody>
+          <a:bodyPr wrap="square" lIns="0" tIns="0" rIns="0" bIns="0" rtlCol="0" anchor="t"/>
+          <a:lstStyle/>
+          <a:p>
+            <a:pPr indent="0" marL="0">
+              <a:buNone/>
+            </a:pPr>
+            <a:r>
+              <a:rPr lang="en-US" sz="1250" b="1" dirty="0">
+                <a:solidFill>
+                  <a:srgbClr val="10131A"/>
+                </a:solidFill>
+                <a:latin typeface="Calibri" pitchFamily="34" charset="0"/>
+                <a:ea typeface="Calibri" pitchFamily="34" charset="-122"/>
+                <a:cs typeface="Calibri" pitchFamily="34" charset="-120"/>
+              </a:rPr>
+              <a:t>Does this work with Playwright?</a:t>
+            </a:r>
+            <a:endParaRPr lang="en-US" sz="1250" dirty="0"/>
+          </a:p>
+        </p:txBody>
+      </p:sp>
+      <p:sp>
+        <p:nvSpPr>
+          <p:cNvPr id="30" name="Text 28"/>
+          <p:cNvSpPr txBox="1"/>
+          <p:nvPr/>
+        </p:nvSpPr>
+        <p:spPr>
+          <a:xfrm>
+            <a:off x="6675120" y="4837176"/>
+            <a:ext cx="4937760" cy="603504"/>
+          </a:xfrm>
+          <a:prstGeom prst="rect">
+            <a:avLst/>
+          </a:prstGeom>
+          <a:noFill/>
+          <a:ln/>
+        </p:spPr>
+        <p:txBody>
+          <a:bodyPr wrap="square" lIns="0" tIns="0" rIns="0" bIns="0" rtlCol="0" anchor="t"/>
+          <a:lstStyle/>
+          <a:p>
+            <a:pPr indent="0" marL="0">
+              <a:buNone/>
+            </a:pPr>
+            <a:r>
+              <a:rPr lang="en-US" sz="1050" dirty="0">
+                <a:solidFill>
+                  <a:srgbClr val="5C6675"/>
+                </a:solidFill>
+                <a:latin typeface="Calibri" pitchFamily="34" charset="0"/>
+                <a:ea typeface="Calibri" pitchFamily="34" charset="-122"/>
+                <a:cs typeface="Calibri" pitchFamily="34" charset="-120"/>
+              </a:rPr>
+              <a:t>Same atomizer, same gate. But Playwright already parallelises, so you mostly gain the cache. Previous slide has the detail.</a:t>
+            </a:r>
+            <a:endParaRPr lang="en-US" sz="1050" dirty="0"/>
+          </a:p>
+        </p:txBody>
+      </p:sp>
+      <p:sp>
+        <p:nvSpPr>
+          <p:cNvPr id="31" name="Text 29"/>
+          <p:cNvSpPr txBox="1"/>
+          <p:nvPr/>
+        </p:nvSpPr>
+        <p:spPr>
+          <a:xfrm>
+            <a:off x="6263640" y="5504688"/>
+            <a:ext cx="365760" cy="274320"/>
+          </a:xfrm>
+          <a:prstGeom prst="rect">
+            <a:avLst/>
+          </a:prstGeom>
+          <a:noFill/>
+          <a:ln/>
+        </p:spPr>
+        <p:txBody>
+          <a:bodyPr wrap="square" lIns="0" tIns="0" rIns="0" bIns="0" rtlCol="0" anchor="ctr"/>
+          <a:lstStyle/>
+          <a:p>
+            <a:pPr indent="0" marL="0">
+              <a:buNone/>
+            </a:pPr>
+            <a:r>
+              <a:rPr lang="en-US" sz="1100" b="1" dirty="0">
+                <a:solidFill>
+                  <a:srgbClr val="B45309"/>
+                </a:solidFill>
+                <a:latin typeface="Courier New" pitchFamily="34" charset="0"/>
+                <a:ea typeface="Courier New" pitchFamily="34" charset="-122"/>
+                <a:cs typeface="Courier New" pitchFamily="34" charset="-120"/>
+              </a:rPr>
+              <a:t>10</a:t>
+            </a:r>
+            <a:endParaRPr lang="en-US" sz="1100" dirty="0"/>
+          </a:p>
+        </p:txBody>
+      </p:sp>
+      <p:sp>
+        <p:nvSpPr>
+          <p:cNvPr id="32" name="Text 30"/>
+          <p:cNvSpPr txBox="1"/>
+          <p:nvPr/>
+        </p:nvSpPr>
+        <p:spPr>
+          <a:xfrm>
+            <a:off x="6675120" y="5504688"/>
+            <a:ext cx="4937760" cy="274320"/>
+          </a:xfrm>
+          <a:prstGeom prst="rect">
+            <a:avLst/>
+          </a:prstGeom>
+          <a:noFill/>
+          <a:ln/>
+        </p:spPr>
+        <p:txBody>
+          <a:bodyPr wrap="square" lIns="0" tIns="0" rIns="0" bIns="0" rtlCol="0" anchor="t"/>
+          <a:lstStyle/>
+          <a:p>
+            <a:pPr indent="0" marL="0">
+              <a:buNone/>
+            </a:pPr>
+            <a:r>
+              <a:rPr lang="en-US" sz="1250" b="1" dirty="0">
+                <a:solidFill>
+                  <a:srgbClr val="10131A"/>
+                </a:solidFill>
+                <a:latin typeface="Calibri" pitchFamily="34" charset="0"/>
+                <a:ea typeface="Calibri" pitchFamily="34" charset="-122"/>
+                <a:cs typeface="Calibri" pitchFamily="34" charset="-120"/>
+              </a:rPr>
+              <a:t>How long did this take to set up?</a:t>
+            </a:r>
+            <a:endParaRPr lang="en-US" sz="1250" dirty="0"/>
+          </a:p>
+        </p:txBody>
+      </p:sp>
+      <p:sp>
+        <p:nvSpPr>
+          <p:cNvPr id="33" name="Text 31"/>
+          <p:cNvSpPr txBox="1"/>
+          <p:nvPr/>
+        </p:nvSpPr>
+        <p:spPr>
+          <a:xfrm>
+            <a:off x="6675120" y="5788152"/>
+            <a:ext cx="4937760" cy="603504"/>
+          </a:xfrm>
+          <a:prstGeom prst="rect">
+            <a:avLst/>
+          </a:prstGeom>
+          <a:noFill/>
+          <a:ln/>
+        </p:spPr>
+        <p:txBody>
+          <a:bodyPr wrap="square" lIns="0" tIns="0" rIns="0" bIns="0" rtlCol="0" anchor="t"/>
+          <a:lstStyle/>
+          <a:p>
+            <a:pPr indent="0" marL="0">
+              <a:buNone/>
+            </a:pPr>
+            <a:r>
+              <a:rPr lang="en-US" sz="1050" dirty="0">
+                <a:solidFill>
+                  <a:srgbClr val="5C6675"/>
+                </a:solidFill>
+                <a:latin typeface="Calibri" pitchFamily="34" charset="0"/>
+                <a:ea typeface="Calibri" pitchFamily="34" charset="-122"/>
+                <a:cs typeface="Calibri" pitchFamily="34" charset="-120"/>
+              </a:rPr>
+              <a:t>The config is minutes. Reviewing a thousand tests took months. The tooling was never the hard part.</a:t>
+            </a:r>
+            <a:endParaRPr lang="en-US" sz="1050" dirty="0"/>
+          </a:p>
+        </p:txBody>
+      </p:sp>
+    </p:spTree>
+  </p:cSld>
+  <p:clrMapOvr>
+    <a:masterClrMapping/>
+  </p:clrMapOvr>
+</p:sld>
+</file>
+
 <file path=ppt/slides/slide3.xml><?xml version="1.0" encoding="utf-8"?>
 <p:sld xmlns:a="http://schemas.openxmlformats.org/drawingml/2006/main" xmlns:r="http://schemas.openxmlformats.org/officeDocument/2006/relationships" xmlns:p="http://schemas.openxmlformats.org/presentationml/2006/main">
   <p:cSld name="Slide 3">

</xml_diff>

<commit_message>
Move the demo commands out of the notes into demo.md
Thirty-three commands in slide order, copy-pasteable, with the expected output
and timing beside each. Reading commands off a presenter screen and retyping
them is the worst way to run a live demo.

The speaker notes keep the framing — what to point at, what to say — and slide 1
points at the file. Verified every script, file and binary the run sheet
references actually exists.
</commit_message>
<xml_diff>
--- a/talk/Scaling-E2E-Tests-with-Nx.pptx
+++ b/talk/Scaling-E2E-Tests-with-Nx.pptx
@@ -530,12 +530,7 @@
             <a:r>
               <a:rPr lang="en-US" dirty="0"/>
               <a:t>Thirty seconds on who you are, then move. The QR stays useful all talk — people scan it while you set up the demo. Everything in this deck was measured on the repo linked at the end; nothing needs an Nx Cloud account.
-BEFORE YOU PRESENT
-  $ cd ~/IdeaProjects/nx-scaling-e2e-tests-with-atomizer
-  $ npm ci &amp;&amp; npx cypress install
-  $ npm run demo:status      → expect buggyDiscount: false
-  $ npx nx reset             → cold cache, so the first number is honest
-  Keep a terminal in the repo root on a second screen or a split.</a:t>
+Every command this talk runs is in demo.md at the repo root, in slide order — keep it open on a second screen rather than reading commands off these notes.</a:t>
             </a:r>
             <a:endParaRPr lang="en-US" dirty="0"/>
           </a:p>
@@ -711,10 +706,7 @@
           <a:p>
             <a:r>
               <a:rPr lang="en-US" dirty="0"/>
-              <a:t>Stress "generated". Nobody maintains this list — that is the difference from hand-rolled spec sharding.
-DEMO — what the atomizer generated
-  $ npm run e2e:targets
-  30 targets across 3 projects. Point out the names are file paths.</a:t>
+              <a:t>Stress "generated". Nobody maintains this list — that is the difference from hand-rolled spec sharding.</a:t>
             </a:r>
             <a:endParaRPr lang="en-US" dirty="0"/>
           </a:p>
@@ -802,12 +794,7 @@
           <a:p>
             <a:r>
               <a:rPr lang="en-US" dirty="0"/>
-              <a:t>Do this live. Piping through `npm run e2e:targets` gives a cleaner list if the JSON is too wide for the screen.
-DEMO — where the targets come from
-  $ npx nx show project shop-e2e --json
-  (wide — use `npm run e2e:targets` if the JSON does not fit the screen)
-  $ grep -A8 "cypress/plugin" nx.json
-  Nine lines of config generate all thirty targets.</a:t>
+              <a:t>Do this live. Piping through `npm run e2e:targets` gives a cleaner list if the JSON is too wide for the screen.</a:t>
             </a:r>
             <a:endParaRPr lang="en-US" dirty="0"/>
           </a:p>
@@ -895,13 +882,7 @@
           <a:p>
             <a:r>
               <a:rPr lang="en-US" dirty="0"/>
-              <a:t>This is the slide that did not exist last time — Nx 23 added the guard. Do not rush to the workaround: sit on the third bullet. For a lot of the room this is not a technical problem at all, it is a purchase order they are not going to win this quarter. The good news lands on the next slide.
-DEMO — hit the gate, then walk around it
-  $ npx nx run-many -t e2e-ci --parallel=5
-  Fails, listing all three e2e-ci tasks. Read it out loud.
-  $ npx nx run "shop-e2e:e2e-ci--src/e2e/catalog.cy.ts"
-  Same plugin, one leaf target, green. ~25s from cold because it builds the
-  app and starts preview first; a couple of seconds once those are cached.</a:t>
+              <a:t>This is the slide that did not exist last time — Nx 23 added the guard. Do not rush to the workaround: sit on the third bullet. For a lot of the room this is not a technical problem at all, it is a purchase order they are not going to win this quarter. The good news lands on the next slide.</a:t>
             </a:r>
             <a:endParaRPr lang="en-US" dirty="0"/>
           </a:p>
@@ -989,12 +970,7 @@
           <a:p>
             <a:r>
               <a:rPr lang="en-US" dirty="0"/>
-              <a:t>The script is twenty lines and does two things: ask Nx for the target list, hand it to run-many. Do not hand-roll a process pool — you lose the cache and the usual first attempt swallows exit codes. The amber box buys you credibility for the cache claims coming next, so do not rush it.
-DEMO — parallel on one machine
-  $ npx nx reset
-  $ node tools/run-e2e.mjs --project=shop-e2e --parallel=5
-  ~40-46s across runs, against the 1m 33s baseline from earlier.
-  Whole workspace if you have time: node tools/run-e2e.mjs --parallel=5  (~2m 06s)</a:t>
+              <a:t>The script is twenty lines and does two things: ask Nx for the target list, hand it to run-many. Do not hand-roll a process pool — you lose the cache and the usual first attempt swallows exit codes. The amber box buys you credibility for the cache claims coming next, so do not rush it.</a:t>
             </a:r>
             <a:endParaRPr lang="en-US" dirty="0"/>
           </a:p>
@@ -1082,12 +1058,7 @@
           <a:p>
             <a:r>
               <a:rPr lang="en-US" dirty="0"/>
-              <a:t>Sharding by index is the answer people expect, so say why it is the wrong default here and keep it for the case it is good at: one app big enough to dominate. The cross-product point is real — this repo has two login.cy.ts files and the runner refuses the selection rather than quietly running both.
-DEMO — the same thing on CI
-  $ gh run list --limit 5
-  $ gh run view --web
-  One job per app, and the matrix is generated from the graph:
-  $ sed -n "1,40p" .github/workflows/e2e.yml</a:t>
+              <a:t>Sharding by index is the answer people expect, so say why it is the wrong default here and keep it for the case it is good at: one app big enough to dominate. The cross-product point is real — this repo has two login.cy.ts files and the runner refuses the selection rather than quietly running both.</a:t>
             </a:r>
             <a:endParaRPr lang="en-US" dirty="0"/>
           </a:p>
@@ -1263,10 +1234,7 @@
           <a:p>
             <a:r>
               <a:rPr lang="en-US" dirty="0"/>
-              <a:t>Hit up-arrow and enter. The whole point is that it returns before you finish the sentence.
-DEMO — run it again
-  $ node tools/run-e2e.mjs --project=shop-e2e --parallel=5
-  Up-arrow, enter. Back in ~0.2s with 11/12 cache hits.</a:t>
+              <a:t>Hit up-arrow and enter. The whole point is that it returns before you finish the sentence.</a:t>
             </a:r>
             <a:endParaRPr lang="en-US" dirty="0"/>
           </a:p>
@@ -1354,12 +1322,7 @@
           <a:p>
             <a:r>
               <a:rPr lang="en-US" dirty="0"/>
-              <a:t>Be honest about 37→28: the two seeded failures are the two slowest specs and each still boots Cypress. The saving scales with how many specs pass — on 200 specs with 3 failures it is enormous.
-DEMO — the money moment
-  $ npm run demo:break
-  $ node tools/run-e2e.mjs --project=shop-e2e --parallel=5   → ~40s, 2 fail
-  $ node tools/run-e2e.mjs --project=shop-e2e --parallel=5   → ~28s, 9/10 cached
-  Nothing changed between those two. Only the failures re-executed.</a:t>
+              <a:t>Be honest about 37→28: the two seeded failures are the two slowest specs and each still boots Cypress. The saving scales with how many specs pass — on 200 specs with 3 failures it is enormous.</a:t>
             </a:r>
             <a:endParaRPr lang="en-US" dirty="0"/>
           </a:p>
@@ -1447,11 +1410,7 @@
           <a:p>
             <a:r>
               <a:rPr lang="en-US" dirty="0"/>
-              <a:t>If you want the "everything re-runs" version instead, run nx reset before this step. Best real example from this repo: a commit that touched only the slide deck restored the previous commit's cache and reported 33/36 hits and a 119ms run — the single-machine CI job went from 3m44s to 35s without anyone planning it. Inputs, not commits.
-DEMO — undo it
-  $ npm run demo:fix
-  $ node tools/run-e2e.mjs --project=shop-e2e --parallel=5
-  ~0.2s. Reverting restored the old input hash, so the old results came back.</a:t>
+              <a:t>If you want the "everything re-runs" version instead, run nx reset before this step. Best real example from this repo: a commit that touched only the slide deck restored the previous commit's cache and reported 33/36 hits and a 119ms run — the single-machine CI job went from 3m44s to 35s without anyone planning it. Inputs, not commits.</a:t>
             </a:r>
             <a:endParaRPr lang="en-US" dirty="0"/>
           </a:p>
@@ -1627,11 +1586,7 @@
           <a:p>
             <a:r>
               <a:rPr lang="en-US" dirty="0"/>
-              <a:t>The bars are this laptop — the same machine they just watched the demo on — so the numbers match what they saw. The right column is an 18-core M5 for contrast. Two things to land. One: rung 2 is slower than not splitting on both machines, 31% here and 22% there, so the startup tax is real and not a quirk of old hardware. Two: on the M5 rung 3 beats rung 4, 48s against 55s. More cores beat more machines until you run out of cores — which is why CI still needs rung 4, because a CI runner is small.
-DO NOT RUN THIS LIVE
-  $ npm run e2e:benchmark
-  ~15 minutes — it runs every rung from a cold cache.
-  Run it the morning of the talk and read the numbers off this slide.</a:t>
+              <a:t>The bars are this laptop — the same machine they just watched the demo on — so the numbers match what they saw. The right column is an 18-core M5 for contrast. Two things to land. One: rung 2 is slower than not splitting on both machines, 31% here and 22% there, so the startup tax is real and not a quirk of old hardware. Two: on the M5 rung 3 beats rung 4, 48s against 55s. More cores beat more machines until you run out of cores — which is why CI still needs rung 4, because a CI runner is small.</a:t>
             </a:r>
             <a:endParaRPr lang="en-US" dirty="0"/>
           </a:p>
@@ -1719,13 +1674,7 @@
           <a:p>
             <a:r>
               <a:rPr lang="en-US" dirty="0"/>
-              <a:t>Run this live: npm run e2e:affected on a clean tree exits green instantly, then touch libs/ui and watch two apps light up. The last row is the one that lands — most CI runs on most days are documentation and config.
-DEMO — let the graph choose
-  $ npm run e2e:affected                                    → nothing affected, instant
-  $ echo "/* demo */" &gt;&gt; libs/ui/src/styles.css
-  $ node tools/e2e-targets.mjs --affected --projects-json   → ["admin-e2e","docs-e2e"]
-  $ git checkout -- libs/ui/src/styles.css
-  Discovery is instant. Only run the full affected suite (~1m 22s) if you have time.</a:t>
+              <a:t>Run this live: npm run e2e:affected on a clean tree exits green instantly, then touch libs/ui and watch two apps light up. The last row is the one that lands — most CI runs on most days are documentation and config.</a:t>
             </a:r>
             <a:endParaRPr lang="en-US" dirty="0"/>
           </a:p>
@@ -2869,11 +2818,7 @@
           <a:p>
             <a:r>
               <a:rPr lang="en-US" dirty="0"/>
-              <a:t>Orientation, not content — keep it under a minute. Two things to point at. One: the libs are shared unevenly, formatting by shop and admin, ui by admin and docs, which is what makes the affected demo land later. Two: thirty spec files but only three runnable tasks, because nx e2e is one Cypress process per app. That three is the number the atomizer turns into thirty. Have `nx graph` open in a tab if you would rather show the real thing.
-DEMO — show the real graph
-  $ npx nx graph
-  Opens a browser. Click shop, then ui, to show what depends on what.
-  Ctrl+C when done. `npx nx graph --print` if the projector hates the browser.</a:t>
+              <a:t>Orientation, not content — keep it under a minute. Two things to point at. One: the libs are shared unevenly, formatting by shop and admin, ui by admin and docs, which is what makes the affected demo land later. Two: thirty spec files but only three runnable tasks, because nx e2e is one Cypress process per app. That three is the number the atomizer turns into thirty. Have `nx graph` open in a tab if you would rather show the real thing.</a:t>
             </a:r>
             <a:endParaRPr lang="en-US" dirty="0"/>
           </a:p>
@@ -2961,11 +2906,7 @@
           <a:p>
             <a:r>
               <a:rPr lang="en-US" dirty="0"/>
-              <a:t>Run this live if the timing works, otherwise show the recording. The number to sit with is 4m20s on a toy repo with 30 specs — the audience can extrapolate to their own suite faster than you can do it for them.
-DEMO — the un-atomized baseline
-  $ npx nx e2e shop-e2e
-  ~1m 33s for ONE app. Start it, keep talking, come back to it.
-  All three serially is 4m 20s — quote that, do not run it.</a:t>
+              <a:t>Run this live if the timing works, otherwise show the recording. The number to sit with is 4m20s on a toy repo with 30 specs — the audience can extrapolate to their own suite faster than you can do it for them.</a:t>
             </a:r>
             <a:endParaRPr lang="en-US" dirty="0"/>
           </a:p>

</xml_diff>